<commit_message>
fix(slide12): correct four-fifths figures to match ethics_audit output
</commit_message>
<xml_diff>
--- a/deck/NovaCorp_deck.pptx
+++ b/deck/NovaCorp_deck.pptx
@@ -5421,7 +5421,7 @@
                 </a:solidFill>
                 <a:latin typeface="Calibri"/>
               </a:rPr>
-              <a:t>A “who stopped answering” flag looks free. It flags 21.6% of under-25s and 3.3% of 45–49s.</a:t>
+              <a:t>A “who stopped answering” flag looks free. It flags 16.6% of 18–24s and 1.4% of 45–49s.</a:t>
             </a:r>
           </a:p>
         </p:txBody>
@@ -5463,7 +5463,7 @@
                 </a:solidFill>
                 <a:latin typeface="Calibri"/>
               </a:rPr>
-              <a:t>Four-fifths rule applied to a proposed individual flight-risk flag. 901 active staff flagged. Full fairness method and results in appendix A4.</a:t>
+              <a:t>Four-fifths rule applied to a proposed individual flight-risk flag, on all active staff. All figures from ethics_audit.py. Full fairness method and results in appendix A4.</a:t>
             </a:r>
           </a:p>
         </p:txBody>
@@ -5593,7 +5593,7 @@
                 </a:solidFill>
                 <a:latin typeface="Calibri"/>
               </a:rPr>
-              <a:t> it fails on age (impact ratio </a:t>
+              <a:t> it fails on age (ratio </a:t>
             </a:r>
             <a:r>
               <a:rPr sz="1200" i="0" b="1">
@@ -5602,7 +5602,7 @@
                 </a:solidFill>
                 <a:latin typeface="Calibri"/>
               </a:rPr>
-              <a:t>0.15</a:t>
+              <a:t>0.08</a:t>
             </a:r>
             <a:r>
               <a:rPr sz="1200" i="0" b="0">
@@ -5611,7 +5611,7 @@
                 </a:solidFill>
                 <a:latin typeface="Calibri"/>
               </a:rPr>
-              <a:t>), on role level (L1 9.2% vs L5 1.4%) and on acquisition cohort (Entity_C 36.9%, Entity_B 28.2% vs Entity_A 4.1%).</a:t>
+              <a:t>, a twelvefold gap), on role level (L1 9.2% vs L5 1.4%) and on acquisition cohort (Entity_C 31.7% vs NovaCorp-Origin 2.4%).</a:t>
             </a:r>
           </a:p>
           <a:p>
@@ -5648,7 +5648,25 @@
                 </a:solidFill>
                 <a:latin typeface="Calibri"/>
               </a:rPr>
-              <a:t>: 901 flagged, </a:t>
+              <a:t>: </a:t>
+            </a:r>
+            <a:r>
+              <a:rPr sz="1200" i="0" b="1">
+                <a:solidFill>
+                  <a:srgbClr val="460073"/>
+                </a:solidFill>
+                <a:latin typeface="Calibri"/>
+              </a:rPr>
+              <a:t>901 false positives</a:t>
+            </a:r>
+            <a:r>
+              <a:rPr sz="1200" i="0" b="0">
+                <a:solidFill>
+                  <a:srgbClr val="22222A"/>
+                </a:solidFill>
+                <a:latin typeface="Calibri"/>
+              </a:rPr>
+              <a:t> against 263 true ones, </a:t>
             </a:r>
             <a:r>
               <a:rPr sz="1200" i="0" b="1">

</xml_diff>

<commit_message>
feat(deck): add robustness, 90-day plan and model card appendices; de-duplicate chart titles
</commit_message>
<xml_diff>
--- a/deck/NovaCorp_deck.pptx
+++ b/deck/NovaCorp_deck.pptx
@@ -37,6 +37,9 @@
     <p:sldId id="285" r:id="rId36"/>
     <p:sldId id="286" r:id="rId37"/>
     <p:sldId id="287" r:id="rId38"/>
+    <p:sldId id="288" r:id="rId39"/>
+    <p:sldId id="289" r:id="rId40"/>
+    <p:sldId id="290" r:id="rId41"/>
   </p:sldIdLst>
   <p:sldSz cx="12191695" cy="6858000" type="screen4x3"/>
   <p:notesSz cx="6858000" cy="9144000"/>
@@ -5759,8 +5762,8 @@
         </p:blipFill>
         <p:spPr>
           <a:xfrm>
-            <a:off x="5349240" y="2168437"/>
-            <a:ext cx="6263640" cy="3435526"/>
+            <a:off x="5349240" y="2167103"/>
+            <a:ext cx="6263640" cy="3438193"/>
           </a:xfrm>
           <a:prstGeom prst="rect">
             <a:avLst/>
@@ -12665,8 +12668,8 @@
         </p:blipFill>
         <p:spPr>
           <a:xfrm>
-            <a:off x="640080" y="2022208"/>
-            <a:ext cx="6583680" cy="3362224"/>
+            <a:off x="640080" y="2020824"/>
+            <a:ext cx="6583680" cy="3364992"/>
           </a:xfrm>
           <a:prstGeom prst="rect">
             <a:avLst/>
@@ -23151,8 +23154,8 @@
         </p:blipFill>
         <p:spPr>
           <a:xfrm>
-            <a:off x="4892040" y="2341870"/>
-            <a:ext cx="6720840" cy="3225820"/>
+            <a:off x="4892040" y="2329734"/>
+            <a:ext cx="6720840" cy="3250091"/>
           </a:xfrm>
           <a:prstGeom prst="rect">
             <a:avLst/>
@@ -27345,7 +27348,7 @@
 </p:sld>
 </file>
 
-<file path=ppt/slides/slide4.xml><?xml version="1.0" encoding="utf-8"?>
+<file path=ppt/slides/slide33.xml><?xml version="1.0" encoding="utf-8"?>
 <p:sld xmlns:a="http://schemas.openxmlformats.org/drawingml/2006/main" xmlns:p="http://schemas.openxmlformats.org/presentationml/2006/main" xmlns:r="http://schemas.openxmlformats.org/officeDocument/2006/relationships">
   <p:cSld>
     <p:spTree>
@@ -27370,7 +27373,7 @@
             <a:avLst/>
           </a:prstGeom>
           <a:solidFill>
-            <a:srgbClr val="A100FF"/>
+            <a:srgbClr val="5A5A66"/>
           </a:solidFill>
           <a:ln>
             <a:noFill/>
@@ -27407,8 +27410,8 @@
         </p:nvSpPr>
         <p:spPr>
           <a:xfrm>
-            <a:off x="566928" y="365760"/>
-            <a:ext cx="11057839" cy="219456"/>
+            <a:off x="566928" y="347472"/>
+            <a:ext cx="11057839" cy="237744"/>
           </a:xfrm>
           <a:prstGeom prst="rect">
             <a:avLst/>
@@ -27430,6 +27433,3314 @@
               </a:spcAft>
             </a:pPr>
             <a:r>
+              <a:rPr sz="1100" i="0" b="1">
+                <a:solidFill>
+                  <a:srgbClr val="A100FF"/>
+                </a:solidFill>
+                <a:latin typeface="Calibri"/>
+              </a:rPr>
+              <a:t>APPENDIX A15</a:t>
+            </a:r>
+          </a:p>
+        </p:txBody>
+      </p:sp>
+      <p:sp>
+        <p:nvSpPr>
+          <p:cNvPr id="4" name="TextBox 3"/>
+          <p:cNvSpPr txBox="1"/>
+          <p:nvPr/>
+        </p:nvSpPr>
+        <p:spPr>
+          <a:xfrm>
+            <a:off x="566928" y="621792"/>
+            <a:ext cx="11057839" cy="457200"/>
+          </a:xfrm>
+          <a:prstGeom prst="rect">
+            <a:avLst/>
+          </a:prstGeom>
+          <a:noFill/>
+        </p:spPr>
+        <p:txBody>
+          <a:bodyPr wrap="square" anchor="t" lIns="0" rIns="0" tIns="0" bIns="0">
+            <a:spAutoFit/>
+          </a:bodyPr>
+          <a:lstStyle/>
+          <a:p>
+            <a:pPr algn="l">
+              <a:lnSpc>
+                <a:spcPct val="100000"/>
+              </a:lnSpc>
+              <a:spcAft>
+                <a:spcPts val="0"/>
+              </a:spcAft>
+            </a:pPr>
+            <a:r>
+              <a:rPr sz="2300" i="0" b="1">
+                <a:solidFill>
+                  <a:srgbClr val="460073"/>
+                </a:solidFill>
+                <a:latin typeface="Calibri"/>
+              </a:rPr>
+              <a:t>Does the Entity_B finding survive controls?</a:t>
+            </a:r>
+          </a:p>
+        </p:txBody>
+      </p:sp>
+      <p:sp>
+        <p:nvSpPr>
+          <p:cNvPr id="5" name="TextBox 4"/>
+          <p:cNvSpPr txBox="1"/>
+          <p:nvPr/>
+        </p:nvSpPr>
+        <p:spPr>
+          <a:xfrm>
+            <a:off x="566928" y="1051560"/>
+            <a:ext cx="10607040" cy="384048"/>
+          </a:xfrm>
+          <a:prstGeom prst="rect">
+            <a:avLst/>
+          </a:prstGeom>
+          <a:noFill/>
+        </p:spPr>
+        <p:txBody>
+          <a:bodyPr wrap="square" anchor="t" lIns="0" rIns="0" tIns="0" bIns="0">
+            <a:spAutoFit/>
+          </a:bodyPr>
+          <a:lstStyle/>
+          <a:p>
+            <a:pPr algn="l">
+              <a:lnSpc>
+                <a:spcPct val="115000"/>
+              </a:lnSpc>
+              <a:spcAft>
+                <a:spcPts val="0"/>
+              </a:spcAft>
+            </a:pPr>
+            <a:r>
+              <a:rPr sz="1150" i="1" b="0">
+                <a:solidFill>
+                  <a:srgbClr val="5A5A66"/>
+                </a:solidFill>
+                <a:latin typeface="Calibri"/>
+              </a:rPr>
+              <a:t>The obvious challenge to slide 6 is that Entity_B might simply sit in departments or levels that lose people anyway. We tested it. It does not.</a:t>
+            </a:r>
+          </a:p>
+        </p:txBody>
+      </p:sp>
+      <p:sp>
+        <p:nvSpPr>
+          <p:cNvPr id="6" name="TextBox 5"/>
+          <p:cNvSpPr txBox="1"/>
+          <p:nvPr/>
+        </p:nvSpPr>
+        <p:spPr>
+          <a:xfrm>
+            <a:off x="566928" y="6355080"/>
+            <a:ext cx="10241280" cy="365760"/>
+          </a:xfrm>
+          <a:prstGeom prst="rect">
+            <a:avLst/>
+          </a:prstGeom>
+          <a:noFill/>
+        </p:spPr>
+        <p:txBody>
+          <a:bodyPr wrap="square" anchor="t" lIns="0" rIns="0" tIns="0" bIns="0">
+            <a:spAutoFit/>
+          </a:bodyPr>
+          <a:lstStyle/>
+          <a:p>
+            <a:pPr algn="l">
+              <a:lnSpc>
+                <a:spcPct val="100000"/>
+              </a:lnSpc>
+              <a:spcAft>
+                <a:spcPts val="0"/>
+              </a:spcAft>
+            </a:pPr>
+            <a:r>
+              <a:rPr sz="800" i="1" b="0">
+                <a:solidFill>
+                  <a:srgbClr val="5A5A66"/>
+                </a:solidFill>
+                <a:latin typeface="Calibri"/>
+              </a:rPr>
+              <a:t>Logistic model on voluntary exit, baseline Entity_A, n = 13,136 with 1,133 events. Reproduce with robustness_check.py.</a:t>
+            </a:r>
+          </a:p>
+        </p:txBody>
+      </p:sp>
+      <p:sp>
+        <p:nvSpPr>
+          <p:cNvPr id="7" name="TextBox 6"/>
+          <p:cNvSpPr txBox="1"/>
+          <p:nvPr/>
+        </p:nvSpPr>
+        <p:spPr>
+          <a:xfrm>
+            <a:off x="10893247" y="6355080"/>
+            <a:ext cx="731520" cy="228600"/>
+          </a:xfrm>
+          <a:prstGeom prst="rect">
+            <a:avLst/>
+          </a:prstGeom>
+          <a:noFill/>
+        </p:spPr>
+        <p:txBody>
+          <a:bodyPr wrap="square" anchor="t" lIns="0" rIns="0" tIns="0" bIns="0">
+            <a:spAutoFit/>
+          </a:bodyPr>
+          <a:lstStyle/>
+          <a:p>
+            <a:pPr algn="r">
+              <a:lnSpc>
+                <a:spcPct val="100000"/>
+              </a:lnSpc>
+              <a:spcAft>
+                <a:spcPts val="0"/>
+              </a:spcAft>
+            </a:pPr>
+            <a:r>
+              <a:rPr sz="1000" i="0" b="1">
+                <a:solidFill>
+                  <a:srgbClr val="5A5A66"/>
+                </a:solidFill>
+                <a:latin typeface="Calibri"/>
+              </a:rPr>
+              <a:t>A15</a:t>
+            </a:r>
+          </a:p>
+        </p:txBody>
+      </p:sp>
+      <p:graphicFrame>
+        <p:nvGraphicFramePr>
+          <p:cNvPr id="8" name="Table 7"/>
+          <p:cNvGraphicFramePr>
+            <a:graphicFrameLocks noGrp="1"/>
+          </p:cNvGraphicFramePr>
+          <p:nvPr/>
+        </p:nvGraphicFramePr>
+        <p:xfrm>
+          <a:off x="566928" y="1755648"/>
+          <a:ext cx="11064240" cy="1261872"/>
+        </p:xfrm>
+        <a:graphic>
+          <a:graphicData uri="http://schemas.openxmlformats.org/drawingml/2006/table">
+            <a:tbl>
+              <a:tblPr firstRow="1" bandRow="1">
+                <a:tableStyleId>{5C22544A-7EE6-4342-B048-85BDC9FD1C3A}</a:tableStyleId>
+              </a:tblPr>
+              <a:tblGrid>
+                <a:gridCol w="5577840"/>
+                <a:gridCol w="2011680"/>
+                <a:gridCol w="1828800"/>
+                <a:gridCol w="1645920"/>
+              </a:tblGrid>
+              <a:tr h="420624">
+                <a:tc>
+                  <a:txBody>
+                    <a:bodyPr wrap="square"/>
+                    <a:lstStyle/>
+                    <a:p>
+                      <a:pPr algn="l"/>
+                      <a:r>
+                        <a:rPr sz="1150" b="1">
+                          <a:solidFill>
+                            <a:srgbClr val="FFFFFF"/>
+                          </a:solidFill>
+                          <a:latin typeface="Calibri"/>
+                        </a:rPr>
+                        <a:t>Model</a:t>
+                      </a:r>
+                    </a:p>
+                  </a:txBody>
+                  <a:tcPr marL="91440" marR="73152" marT="27432" marB="27432" anchor="ctr">
+                    <a:solidFill>
+                      <a:srgbClr val="460073"/>
+                    </a:solidFill>
+                  </a:tcPr>
+                </a:tc>
+                <a:tc>
+                  <a:txBody>
+                    <a:bodyPr wrap="square"/>
+                    <a:lstStyle/>
+                    <a:p>
+                      <a:pPr algn="ctr"/>
+                      <a:r>
+                        <a:rPr sz="1150" b="1">
+                          <a:solidFill>
+                            <a:srgbClr val="FFFFFF"/>
+                          </a:solidFill>
+                          <a:latin typeface="Calibri"/>
+                        </a:rPr>
+                        <a:t>Entity_B vs Entity_A</a:t>
+                      </a:r>
+                    </a:p>
+                  </a:txBody>
+                  <a:tcPr marL="91440" marR="73152" marT="27432" marB="27432" anchor="ctr">
+                    <a:solidFill>
+                      <a:srgbClr val="460073"/>
+                    </a:solidFill>
+                  </a:tcPr>
+                </a:tc>
+                <a:tc>
+                  <a:txBody>
+                    <a:bodyPr wrap="square"/>
+                    <a:lstStyle/>
+                    <a:p>
+                      <a:pPr algn="ctr"/>
+                      <a:r>
+                        <a:rPr sz="1150" b="1">
+                          <a:solidFill>
+                            <a:srgbClr val="FFFFFF"/>
+                          </a:solidFill>
+                          <a:latin typeface="Calibri"/>
+                        </a:rPr>
+                        <a:t>95% CI</a:t>
+                      </a:r>
+                    </a:p>
+                  </a:txBody>
+                  <a:tcPr marL="91440" marR="73152" marT="27432" marB="27432" anchor="ctr">
+                    <a:solidFill>
+                      <a:srgbClr val="460073"/>
+                    </a:solidFill>
+                  </a:tcPr>
+                </a:tc>
+                <a:tc>
+                  <a:txBody>
+                    <a:bodyPr wrap="square"/>
+                    <a:lstStyle/>
+                    <a:p>
+                      <a:pPr algn="ctr"/>
+                      <a:r>
+                        <a:rPr sz="1150" b="1">
+                          <a:solidFill>
+                            <a:srgbClr val="FFFFFF"/>
+                          </a:solidFill>
+                          <a:latin typeface="Calibri"/>
+                        </a:rPr>
+                        <a:t>p</a:t>
+                      </a:r>
+                    </a:p>
+                  </a:txBody>
+                  <a:tcPr marL="91440" marR="73152" marT="27432" marB="27432" anchor="ctr">
+                    <a:solidFill>
+                      <a:srgbClr val="460073"/>
+                    </a:solidFill>
+                  </a:tcPr>
+                </a:tc>
+              </a:tr>
+              <a:tr h="420624">
+                <a:tc>
+                  <a:txBody>
+                    <a:bodyPr wrap="square"/>
+                    <a:lstStyle/>
+                    <a:p>
+                      <a:pPr algn="l"/>
+                      <a:r>
+                        <a:rPr sz="1150" b="1">
+                          <a:solidFill>
+                            <a:srgbClr val="22222A"/>
+                          </a:solidFill>
+                          <a:latin typeface="Calibri"/>
+                        </a:rPr>
+                        <a:t>Controlling for department, role level, pay and high-potential status</a:t>
+                      </a:r>
+                    </a:p>
+                  </a:txBody>
+                  <a:tcPr marL="91440" marR="73152" marT="27432" marB="27432" anchor="ctr">
+                    <a:solidFill>
+                      <a:srgbClr val="F4E9FF"/>
+                    </a:solidFill>
+                  </a:tcPr>
+                </a:tc>
+                <a:tc>
+                  <a:txBody>
+                    <a:bodyPr wrap="square"/>
+                    <a:lstStyle/>
+                    <a:p>
+                      <a:pPr algn="ctr"/>
+                      <a:r>
+                        <a:rPr sz="1150" b="1">
+                          <a:solidFill>
+                            <a:srgbClr val="22222A"/>
+                          </a:solidFill>
+                          <a:latin typeface="Calibri"/>
+                        </a:rPr>
+                        <a:t>1.95×</a:t>
+                      </a:r>
+                    </a:p>
+                  </a:txBody>
+                  <a:tcPr marL="91440" marR="73152" marT="27432" marB="27432" anchor="ctr">
+                    <a:solidFill>
+                      <a:srgbClr val="F4E9FF"/>
+                    </a:solidFill>
+                  </a:tcPr>
+                </a:tc>
+                <a:tc>
+                  <a:txBody>
+                    <a:bodyPr wrap="square"/>
+                    <a:lstStyle/>
+                    <a:p>
+                      <a:pPr algn="ctr"/>
+                      <a:r>
+                        <a:rPr sz="1150" b="1">
+                          <a:solidFill>
+                            <a:srgbClr val="22222A"/>
+                          </a:solidFill>
+                          <a:latin typeface="Calibri"/>
+                        </a:rPr>
+                        <a:t>1.55 – 2.44</a:t>
+                      </a:r>
+                    </a:p>
+                  </a:txBody>
+                  <a:tcPr marL="91440" marR="73152" marT="27432" marB="27432" anchor="ctr">
+                    <a:solidFill>
+                      <a:srgbClr val="F4E9FF"/>
+                    </a:solidFill>
+                  </a:tcPr>
+                </a:tc>
+                <a:tc>
+                  <a:txBody>
+                    <a:bodyPr wrap="square"/>
+                    <a:lstStyle/>
+                    <a:p>
+                      <a:pPr algn="ctr"/>
+                      <a:r>
+                        <a:rPr sz="1150" b="1">
+                          <a:solidFill>
+                            <a:srgbClr val="22222A"/>
+                          </a:solidFill>
+                          <a:latin typeface="Calibri"/>
+                        </a:rPr>
+                        <a:t>8.4×10⁻⁹</a:t>
+                      </a:r>
+                    </a:p>
+                  </a:txBody>
+                  <a:tcPr marL="91440" marR="73152" marT="27432" marB="27432" anchor="ctr">
+                    <a:solidFill>
+                      <a:srgbClr val="F4E9FF"/>
+                    </a:solidFill>
+                  </a:tcPr>
+                </a:tc>
+              </a:tr>
+              <a:tr h="420624">
+                <a:tc>
+                  <a:txBody>
+                    <a:bodyPr wrap="square"/>
+                    <a:lstStyle/>
+                    <a:p>
+                      <a:pPr algn="l"/>
+                      <a:r>
+                        <a:rPr sz="1150" b="0">
+                          <a:solidFill>
+                            <a:srgbClr val="22222A"/>
+                          </a:solidFill>
+                          <a:latin typeface="Calibri"/>
+                        </a:rPr>
+                        <a:t>…and additionally for tenure</a:t>
+                      </a:r>
+                    </a:p>
+                  </a:txBody>
+                  <a:tcPr marL="91440" marR="73152" marT="27432" marB="27432" anchor="ctr">
+                    <a:solidFill>
+                      <a:srgbClr val="F8F8FB"/>
+                    </a:solidFill>
+                  </a:tcPr>
+                </a:tc>
+                <a:tc>
+                  <a:txBody>
+                    <a:bodyPr wrap="square"/>
+                    <a:lstStyle/>
+                    <a:p>
+                      <a:pPr algn="ctr"/>
+                      <a:r>
+                        <a:rPr sz="1150" b="0">
+                          <a:solidFill>
+                            <a:srgbClr val="22222A"/>
+                          </a:solidFill>
+                          <a:latin typeface="Calibri"/>
+                        </a:rPr>
+                        <a:t>1.92×</a:t>
+                      </a:r>
+                    </a:p>
+                  </a:txBody>
+                  <a:tcPr marL="91440" marR="73152" marT="27432" marB="27432" anchor="ctr">
+                    <a:solidFill>
+                      <a:srgbClr val="F8F8FB"/>
+                    </a:solidFill>
+                  </a:tcPr>
+                </a:tc>
+                <a:tc>
+                  <a:txBody>
+                    <a:bodyPr wrap="square"/>
+                    <a:lstStyle/>
+                    <a:p>
+                      <a:pPr algn="ctr"/>
+                      <a:r>
+                        <a:rPr sz="1150" b="0">
+                          <a:solidFill>
+                            <a:srgbClr val="22222A"/>
+                          </a:solidFill>
+                          <a:latin typeface="Calibri"/>
+                        </a:rPr>
+                        <a:t>1.53 – 2.41</a:t>
+                      </a:r>
+                    </a:p>
+                  </a:txBody>
+                  <a:tcPr marL="91440" marR="73152" marT="27432" marB="27432" anchor="ctr">
+                    <a:solidFill>
+                      <a:srgbClr val="F8F8FB"/>
+                    </a:solidFill>
+                  </a:tcPr>
+                </a:tc>
+                <a:tc>
+                  <a:txBody>
+                    <a:bodyPr wrap="square"/>
+                    <a:lstStyle/>
+                    <a:p>
+                      <a:pPr algn="ctr"/>
+                      <a:r>
+                        <a:rPr sz="1150" b="0">
+                          <a:solidFill>
+                            <a:srgbClr val="22222A"/>
+                          </a:solidFill>
+                          <a:latin typeface="Calibri"/>
+                        </a:rPr>
+                        <a:t>1.6×10⁻⁸</a:t>
+                      </a:r>
+                    </a:p>
+                  </a:txBody>
+                  <a:tcPr marL="91440" marR="73152" marT="27432" marB="27432" anchor="ctr">
+                    <a:solidFill>
+                      <a:srgbClr val="F8F8FB"/>
+                    </a:solidFill>
+                  </a:tcPr>
+                </a:tc>
+              </a:tr>
+            </a:tbl>
+          </a:graphicData>
+        </a:graphic>
+      </p:graphicFrame>
+      <p:sp>
+        <p:nvSpPr>
+          <p:cNvPr id="9" name="TextBox 8"/>
+          <p:cNvSpPr txBox="1"/>
+          <p:nvPr/>
+        </p:nvSpPr>
+        <p:spPr>
+          <a:xfrm>
+            <a:off x="566928" y="3246120"/>
+            <a:ext cx="5394960" cy="2651760"/>
+          </a:xfrm>
+          <a:prstGeom prst="rect">
+            <a:avLst/>
+          </a:prstGeom>
+          <a:noFill/>
+        </p:spPr>
+        <p:txBody>
+          <a:bodyPr wrap="square" anchor="t" lIns="0" rIns="0" tIns="0" bIns="0">
+            <a:spAutoFit/>
+          </a:bodyPr>
+          <a:lstStyle/>
+          <a:p>
+            <a:pPr algn="l">
+              <a:lnSpc>
+                <a:spcPct val="118000"/>
+              </a:lnSpc>
+              <a:spcAft>
+                <a:spcPts val="1200"/>
+              </a:spcAft>
+            </a:pPr>
+            <a:r>
+              <a:rPr sz="1150" i="0" b="1">
+                <a:solidFill>
+                  <a:srgbClr val="460073"/>
+                </a:solidFill>
+                <a:latin typeface="Calibri"/>
+              </a:rPr>
+              <a:t>The effect holds either way.</a:t>
+            </a:r>
+            <a:r>
+              <a:rPr sz="1150" i="0" b="0">
+                <a:solidFill>
+                  <a:srgbClr val="22222A"/>
+                </a:solidFill>
+                <a:latin typeface="Calibri"/>
+              </a:rPr>
+              <a:t> Slide 6 quotes a 1.9× rate ratio. The adjusted odds ratio is 1.95, so the headline is not an artifact of what Entity_B does or where it sits.</a:t>
+            </a:r>
+          </a:p>
+          <a:p>
+            <a:pPr algn="l">
+              <a:lnSpc>
+                <a:spcPct val="118000"/>
+              </a:lnSpc>
+              <a:spcAft>
+                <a:spcPts val="1200"/>
+              </a:spcAft>
+            </a:pPr>
+            <a:r>
+              <a:rPr sz="1150" i="0" b="1">
+                <a:solidFill>
+                  <a:srgbClr val="460073"/>
+                </a:solidFill>
+                <a:latin typeface="Calibri"/>
+              </a:rPr>
+              <a:t>Department explains very little.</a:t>
+            </a:r>
+            <a:r>
+              <a:rPr sz="1150" i="0" b="0">
+                <a:solidFill>
+                  <a:srgbClr val="22222A"/>
+                </a:solidFill>
+                <a:latin typeface="Calibri"/>
+              </a:rPr>
+              <a:t> Only one of six department terms reaches p &lt; 0.05, and every odds ratio sits between 0.77 and 1.00. Risk &amp; Compliance is exactly 1.00 once entity is in the model.</a:t>
+            </a:r>
+          </a:p>
+          <a:p>
+            <a:pPr algn="l">
+              <a:lnSpc>
+                <a:spcPct val="118000"/>
+              </a:lnSpc>
+              <a:spcAft>
+                <a:spcPts val="1200"/>
+              </a:spcAft>
+            </a:pPr>
+            <a:r>
+              <a:rPr sz="1150" i="0" b="1">
+                <a:solidFill>
+                  <a:srgbClr val="460073"/>
+                </a:solidFill>
+                <a:latin typeface="Calibri"/>
+              </a:rPr>
+              <a:t>High-potential status replicates independently.</a:t>
+            </a:r>
+            <a:r>
+              <a:rPr sz="1150" i="0" b="0">
+                <a:solidFill>
+                  <a:srgbClr val="22222A"/>
+                </a:solidFill>
+                <a:latin typeface="Calibri"/>
+              </a:rPr>
+              <a:t> OR 1.59 (p = 3.6×10⁻⁶) here, against the 1.64× lift in A8 test 11 computed a different way.</a:t>
+            </a:r>
+          </a:p>
+        </p:txBody>
+      </p:sp>
+      <p:sp>
+        <p:nvSpPr>
+          <p:cNvPr id="10" name="Rectangle 9"/>
+          <p:cNvSpPr/>
+          <p:nvPr/>
+        </p:nvSpPr>
+        <p:spPr>
+          <a:xfrm>
+            <a:off x="6400800" y="3246120"/>
+            <a:ext cx="5257800" cy="2651760"/>
+          </a:xfrm>
+          <a:prstGeom prst="rect">
+            <a:avLst/>
+          </a:prstGeom>
+          <a:solidFill>
+            <a:srgbClr val="F7F3FC"/>
+          </a:solidFill>
+          <a:ln>
+            <a:noFill/>
+          </a:ln>
+          <a:effectLst/>
+        </p:spPr>
+        <p:style>
+          <a:lnRef idx="1">
+            <a:schemeClr val="accent1"/>
+          </a:lnRef>
+          <a:fillRef idx="3">
+            <a:schemeClr val="accent1"/>
+          </a:fillRef>
+          <a:effectRef idx="2">
+            <a:schemeClr val="accent1"/>
+          </a:effectRef>
+          <a:fontRef idx="minor">
+            <a:schemeClr val="lt1"/>
+          </a:fontRef>
+        </p:style>
+        <p:txBody>
+          <a:bodyPr rtlCol="0" anchor="ctr"/>
+          <a:lstStyle/>
+          <a:p>
+            <a:pPr algn="ctr"/>
+          </a:p>
+        </p:txBody>
+      </p:sp>
+      <p:sp>
+        <p:nvSpPr>
+          <p:cNvPr id="11" name="TextBox 10"/>
+          <p:cNvSpPr txBox="1"/>
+          <p:nvPr/>
+        </p:nvSpPr>
+        <p:spPr>
+          <a:xfrm>
+            <a:off x="6748272" y="3493008"/>
+            <a:ext cx="4572000" cy="2286000"/>
+          </a:xfrm>
+          <a:prstGeom prst="rect">
+            <a:avLst/>
+          </a:prstGeom>
+          <a:noFill/>
+        </p:spPr>
+        <p:txBody>
+          <a:bodyPr wrap="square" anchor="t" lIns="0" rIns="0" tIns="0" bIns="0">
+            <a:spAutoFit/>
+          </a:bodyPr>
+          <a:lstStyle/>
+          <a:p>
+            <a:pPr algn="l">
+              <a:lnSpc>
+                <a:spcPct val="100000"/>
+              </a:lnSpc>
+              <a:spcAft>
+                <a:spcPts val="1200"/>
+              </a:spcAft>
+            </a:pPr>
+            <a:r>
+              <a:rPr sz="1000" i="0" b="1">
+                <a:solidFill>
+                  <a:srgbClr val="5A5A66"/>
+                </a:solidFill>
+                <a:latin typeface="Calibri"/>
+              </a:rPr>
+              <a:t>WHY TENURE IS REPORTED SEPARATELY</a:t>
+            </a:r>
+          </a:p>
+          <a:p>
+            <a:pPr algn="l">
+              <a:lnSpc>
+                <a:spcPct val="116000"/>
+              </a:lnSpc>
+              <a:spcAft>
+                <a:spcPts val="900"/>
+              </a:spcAft>
+            </a:pPr>
+            <a:r>
+              <a:rPr sz="1100" i="0" b="0">
+                <a:solidFill>
+                  <a:srgbClr val="22222A"/>
+                </a:solidFill>
+                <a:latin typeface="Calibri"/>
+              </a:rPr>
+              <a:t>tenure_months is the system-entry artifact from A6 §1.1, so for the acquired cohorts it is close to a restatement of entity itself:</a:t>
+            </a:r>
+          </a:p>
+          <a:p>
+            <a:pPr algn="l">
+              <a:lnSpc>
+                <a:spcPct val="100000"/>
+              </a:lnSpc>
+              <a:spcAft>
+                <a:spcPts val="900"/>
+              </a:spcAft>
+            </a:pPr>
+            <a:r>
+              <a:rPr sz="1050" i="0" b="1">
+                <a:solidFill>
+                  <a:srgbClr val="460073"/>
+                </a:solidFill>
+                <a:latin typeface="Calibri"/>
+              </a:rPr>
+              <a:t>Entity_C 0–9 months  ·  Entity_B 0–20  ·  Entity_A 7–33  ·  NovaCorp-Origin 0–462</a:t>
+            </a:r>
+          </a:p>
+          <a:p>
+            <a:pPr algn="l">
+              <a:lnSpc>
+                <a:spcPct val="116000"/>
+              </a:lnSpc>
+              <a:spcAft>
+                <a:spcPts val="0"/>
+              </a:spcAft>
+            </a:pPr>
+            <a:r>
+              <a:rPr sz="1100" i="0" b="0">
+                <a:solidFill>
+                  <a:srgbClr val="22222A"/>
+                </a:solidFill>
+                <a:latin typeface="Calibri"/>
+              </a:rPr>
+              <a:t>Controlling for it is close to controlling for the thing being measured, so we report both models rather than picking the flattering one. Baseline is Entity_A because that is the comparison the deck makes. NovaCorp-Origin is the worst choice of baseline here, since it is the cohort the artifact distorts most.</a:t>
+            </a:r>
+          </a:p>
+        </p:txBody>
+      </p:sp>
+      <p:sp>
+        <p:nvSpPr>
+          <p:cNvPr id="12" name="Rectangle 11"/>
+          <p:cNvSpPr/>
+          <p:nvPr/>
+        </p:nvSpPr>
+        <p:spPr>
+          <a:xfrm>
+            <a:off x="566928" y="5925312"/>
+            <a:ext cx="50292" cy="365760"/>
+          </a:xfrm>
+          <a:prstGeom prst="rect">
+            <a:avLst/>
+          </a:prstGeom>
+          <a:solidFill>
+            <a:srgbClr val="FFB300"/>
+          </a:solidFill>
+          <a:ln>
+            <a:noFill/>
+          </a:ln>
+          <a:effectLst/>
+        </p:spPr>
+        <p:style>
+          <a:lnRef idx="1">
+            <a:schemeClr val="accent1"/>
+          </a:lnRef>
+          <a:fillRef idx="3">
+            <a:schemeClr val="accent1"/>
+          </a:fillRef>
+          <a:effectRef idx="2">
+            <a:schemeClr val="accent1"/>
+          </a:effectRef>
+          <a:fontRef idx="minor">
+            <a:schemeClr val="lt1"/>
+          </a:fontRef>
+        </p:style>
+        <p:txBody>
+          <a:bodyPr rtlCol="0" anchor="ctr"/>
+          <a:lstStyle/>
+          <a:p>
+            <a:pPr algn="ctr"/>
+          </a:p>
+        </p:txBody>
+      </p:sp>
+      <p:sp>
+        <p:nvSpPr>
+          <p:cNvPr id="13" name="TextBox 12"/>
+          <p:cNvSpPr txBox="1"/>
+          <p:nvPr/>
+        </p:nvSpPr>
+        <p:spPr>
+          <a:xfrm>
+            <a:off x="768096" y="5925312"/>
+            <a:ext cx="10771632" cy="365760"/>
+          </a:xfrm>
+          <a:prstGeom prst="rect">
+            <a:avLst/>
+          </a:prstGeom>
+          <a:noFill/>
+        </p:spPr>
+        <p:txBody>
+          <a:bodyPr wrap="square" anchor="ctr" lIns="0" rIns="0" tIns="0" bIns="0">
+            <a:spAutoFit/>
+          </a:bodyPr>
+          <a:lstStyle/>
+          <a:p>
+            <a:pPr algn="l">
+              <a:lnSpc>
+                <a:spcPct val="116000"/>
+              </a:lnSpc>
+              <a:spcAft>
+                <a:spcPts val="0"/>
+              </a:spcAft>
+            </a:pPr>
+            <a:r>
+              <a:rPr sz="1050" i="1" b="0">
+                <a:solidFill>
+                  <a:srgbClr val="22222A"/>
+                </a:solidFill>
+                <a:latin typeface="Calibri"/>
+              </a:rPr>
+              <a:t>This does not establish cause. It rules out the most likely confounders, which is a different and weaker claim, and the one we make.</a:t>
+            </a:r>
+          </a:p>
+        </p:txBody>
+      </p:sp>
+    </p:spTree>
+  </p:cSld>
+  <p:clrMapOvr>
+    <a:masterClrMapping/>
+  </p:clrMapOvr>
+</p:sld>
+</file>
+
+<file path=ppt/slides/slide34.xml><?xml version="1.0" encoding="utf-8"?>
+<p:sld xmlns:a="http://schemas.openxmlformats.org/drawingml/2006/main" xmlns:p="http://schemas.openxmlformats.org/presentationml/2006/main" xmlns:r="http://schemas.openxmlformats.org/officeDocument/2006/relationships">
+  <p:cSld>
+    <p:spTree>
+      <p:nvGrpSpPr>
+        <p:cNvPr id="1" name=""/>
+        <p:cNvGrpSpPr/>
+        <p:nvPr/>
+      </p:nvGrpSpPr>
+      <p:grpSpPr/>
+      <p:sp>
+        <p:nvSpPr>
+          <p:cNvPr id="2" name="Rectangle 1"/>
+          <p:cNvSpPr/>
+          <p:nvPr/>
+        </p:nvSpPr>
+        <p:spPr>
+          <a:xfrm>
+            <a:off x="0" y="0"/>
+            <a:ext cx="12191695" cy="68580"/>
+          </a:xfrm>
+          <a:prstGeom prst="rect">
+            <a:avLst/>
+          </a:prstGeom>
+          <a:solidFill>
+            <a:srgbClr val="5A5A66"/>
+          </a:solidFill>
+          <a:ln>
+            <a:noFill/>
+          </a:ln>
+          <a:effectLst/>
+        </p:spPr>
+        <p:style>
+          <a:lnRef idx="1">
+            <a:schemeClr val="accent1"/>
+          </a:lnRef>
+          <a:fillRef idx="3">
+            <a:schemeClr val="accent1"/>
+          </a:fillRef>
+          <a:effectRef idx="2">
+            <a:schemeClr val="accent1"/>
+          </a:effectRef>
+          <a:fontRef idx="minor">
+            <a:schemeClr val="lt1"/>
+          </a:fontRef>
+        </p:style>
+        <p:txBody>
+          <a:bodyPr rtlCol="0" anchor="ctr"/>
+          <a:lstStyle/>
+          <a:p>
+            <a:pPr algn="ctr"/>
+          </a:p>
+        </p:txBody>
+      </p:sp>
+      <p:sp>
+        <p:nvSpPr>
+          <p:cNvPr id="3" name="TextBox 2"/>
+          <p:cNvSpPr txBox="1"/>
+          <p:nvPr/>
+        </p:nvSpPr>
+        <p:spPr>
+          <a:xfrm>
+            <a:off x="566928" y="347472"/>
+            <a:ext cx="11057839" cy="237744"/>
+          </a:xfrm>
+          <a:prstGeom prst="rect">
+            <a:avLst/>
+          </a:prstGeom>
+          <a:noFill/>
+        </p:spPr>
+        <p:txBody>
+          <a:bodyPr wrap="square" anchor="t" lIns="0" rIns="0" tIns="0" bIns="0">
+            <a:spAutoFit/>
+          </a:bodyPr>
+          <a:lstStyle/>
+          <a:p>
+            <a:pPr algn="l">
+              <a:lnSpc>
+                <a:spcPct val="100000"/>
+              </a:lnSpc>
+              <a:spcAft>
+                <a:spcPts val="0"/>
+              </a:spcAft>
+            </a:pPr>
+            <a:r>
+              <a:rPr sz="1100" i="0" b="1">
+                <a:solidFill>
+                  <a:srgbClr val="A100FF"/>
+                </a:solidFill>
+                <a:latin typeface="Calibri"/>
+              </a:rPr>
+              <a:t>APPENDIX A16</a:t>
+            </a:r>
+          </a:p>
+        </p:txBody>
+      </p:sp>
+      <p:sp>
+        <p:nvSpPr>
+          <p:cNvPr id="4" name="TextBox 3"/>
+          <p:cNvSpPr txBox="1"/>
+          <p:nvPr/>
+        </p:nvSpPr>
+        <p:spPr>
+          <a:xfrm>
+            <a:off x="566928" y="621792"/>
+            <a:ext cx="11057839" cy="457200"/>
+          </a:xfrm>
+          <a:prstGeom prst="rect">
+            <a:avLst/>
+          </a:prstGeom>
+          <a:noFill/>
+        </p:spPr>
+        <p:txBody>
+          <a:bodyPr wrap="square" anchor="t" lIns="0" rIns="0" tIns="0" bIns="0">
+            <a:spAutoFit/>
+          </a:bodyPr>
+          <a:lstStyle/>
+          <a:p>
+            <a:pPr algn="l">
+              <a:lnSpc>
+                <a:spcPct val="100000"/>
+              </a:lnSpc>
+              <a:spcAft>
+                <a:spcPts val="0"/>
+              </a:spcAft>
+            </a:pPr>
+            <a:r>
+              <a:rPr sz="2300" i="0" b="1">
+                <a:solidFill>
+                  <a:srgbClr val="460073"/>
+                </a:solidFill>
+                <a:latin typeface="Calibri"/>
+              </a:rPr>
+              <a:t>The first 90 days, and what to measure</a:t>
+            </a:r>
+          </a:p>
+        </p:txBody>
+      </p:sp>
+      <p:sp>
+        <p:nvSpPr>
+          <p:cNvPr id="5" name="TextBox 4"/>
+          <p:cNvSpPr txBox="1"/>
+          <p:nvPr/>
+        </p:nvSpPr>
+        <p:spPr>
+          <a:xfrm>
+            <a:off x="566928" y="1051560"/>
+            <a:ext cx="10607040" cy="384048"/>
+          </a:xfrm>
+          <a:prstGeom prst="rect">
+            <a:avLst/>
+          </a:prstGeom>
+          <a:noFill/>
+        </p:spPr>
+        <p:txBody>
+          <a:bodyPr wrap="square" anchor="t" lIns="0" rIns="0" tIns="0" bIns="0">
+            <a:spAutoFit/>
+          </a:bodyPr>
+          <a:lstStyle/>
+          <a:p>
+            <a:pPr algn="l">
+              <a:lnSpc>
+                <a:spcPct val="115000"/>
+              </a:lnSpc>
+              <a:spcAft>
+                <a:spcPts val="0"/>
+              </a:spcAft>
+            </a:pPr>
+            <a:r>
+              <a:rPr sz="1150" i="1" b="0">
+                <a:solidFill>
+                  <a:srgbClr val="5A5A66"/>
+                </a:solidFill>
+                <a:latin typeface="Calibri"/>
+              </a:rPr>
+              <a:t>Slide 9 says Entity_A sets the success measure. This is that measure, stated so it can go in front of a board.</a:t>
+            </a:r>
+          </a:p>
+        </p:txBody>
+      </p:sp>
+      <p:sp>
+        <p:nvSpPr>
+          <p:cNvPr id="6" name="TextBox 5"/>
+          <p:cNvSpPr txBox="1"/>
+          <p:nvPr/>
+        </p:nvSpPr>
+        <p:spPr>
+          <a:xfrm>
+            <a:off x="566928" y="6355080"/>
+            <a:ext cx="10241280" cy="365760"/>
+          </a:xfrm>
+          <a:prstGeom prst="rect">
+            <a:avLst/>
+          </a:prstGeom>
+          <a:noFill/>
+        </p:spPr>
+        <p:txBody>
+          <a:bodyPr wrap="square" anchor="t" lIns="0" rIns="0" tIns="0" bIns="0">
+            <a:spAutoFit/>
+          </a:bodyPr>
+          <a:lstStyle/>
+          <a:p>
+            <a:pPr algn="l">
+              <a:lnSpc>
+                <a:spcPct val="100000"/>
+              </a:lnSpc>
+              <a:spcAft>
+                <a:spcPts val="0"/>
+              </a:spcAft>
+            </a:pPr>
+            <a:r>
+              <a:rPr sz="800" i="1" b="0">
+                <a:solidFill>
+                  <a:srgbClr val="5A5A66"/>
+                </a:solidFill>
+                <a:latin typeface="Calibri"/>
+              </a:rPr>
+              <a:t>Baselines are the current figures from cost_model.py. Targets are Entity_A's present position, not a generic benchmark, because Entity_A reached them inside this company with this workforce.</a:t>
+            </a:r>
+          </a:p>
+        </p:txBody>
+      </p:sp>
+      <p:sp>
+        <p:nvSpPr>
+          <p:cNvPr id="7" name="TextBox 6"/>
+          <p:cNvSpPr txBox="1"/>
+          <p:nvPr/>
+        </p:nvSpPr>
+        <p:spPr>
+          <a:xfrm>
+            <a:off x="10893247" y="6355080"/>
+            <a:ext cx="731520" cy="228600"/>
+          </a:xfrm>
+          <a:prstGeom prst="rect">
+            <a:avLst/>
+          </a:prstGeom>
+          <a:noFill/>
+        </p:spPr>
+        <p:txBody>
+          <a:bodyPr wrap="square" anchor="t" lIns="0" rIns="0" tIns="0" bIns="0">
+            <a:spAutoFit/>
+          </a:bodyPr>
+          <a:lstStyle/>
+          <a:p>
+            <a:pPr algn="r">
+              <a:lnSpc>
+                <a:spcPct val="100000"/>
+              </a:lnSpc>
+              <a:spcAft>
+                <a:spcPts val="0"/>
+              </a:spcAft>
+            </a:pPr>
+            <a:r>
+              <a:rPr sz="1000" i="0" b="1">
+                <a:solidFill>
+                  <a:srgbClr val="5A5A66"/>
+                </a:solidFill>
+                <a:latin typeface="Calibri"/>
+              </a:rPr>
+              <a:t>A16</a:t>
+            </a:r>
+          </a:p>
+        </p:txBody>
+      </p:sp>
+      <p:graphicFrame>
+        <p:nvGraphicFramePr>
+          <p:cNvPr id="8" name="Table 7"/>
+          <p:cNvGraphicFramePr>
+            <a:graphicFrameLocks noGrp="1"/>
+          </p:cNvGraphicFramePr>
+          <p:nvPr/>
+        </p:nvGraphicFramePr>
+        <p:xfrm>
+          <a:off x="566928" y="1783080"/>
+          <a:ext cx="11064240" cy="2816352"/>
+        </p:xfrm>
+        <a:graphic>
+          <a:graphicData uri="http://schemas.openxmlformats.org/drawingml/2006/table">
+            <a:tbl>
+              <a:tblPr firstRow="1" bandRow="1">
+                <a:tableStyleId>{5C22544A-7EE6-4342-B048-85BDC9FD1C3A}</a:tableStyleId>
+              </a:tblPr>
+              <a:tblGrid>
+                <a:gridCol w="2606040"/>
+                <a:gridCol w="1828800"/>
+                <a:gridCol w="2103120"/>
+                <a:gridCol w="1234440"/>
+                <a:gridCol w="3291840"/>
+              </a:tblGrid>
+              <a:tr h="402336">
+                <a:tc>
+                  <a:txBody>
+                    <a:bodyPr wrap="square"/>
+                    <a:lstStyle/>
+                    <a:p>
+                      <a:pPr algn="l"/>
+                      <a:r>
+                        <a:rPr sz="1000" b="1">
+                          <a:solidFill>
+                            <a:srgbClr val="FFFFFF"/>
+                          </a:solidFill>
+                          <a:latin typeface="Calibri"/>
+                        </a:rPr>
+                        <a:t>Metric</a:t>
+                      </a:r>
+                    </a:p>
+                  </a:txBody>
+                  <a:tcPr marL="91440" marR="73152" marT="27432" marB="27432" anchor="ctr">
+                    <a:solidFill>
+                      <a:srgbClr val="460073"/>
+                    </a:solidFill>
+                  </a:tcPr>
+                </a:tc>
+                <a:tc>
+                  <a:txBody>
+                    <a:bodyPr wrap="square"/>
+                    <a:lstStyle/>
+                    <a:p>
+                      <a:pPr algn="ctr"/>
+                      <a:r>
+                        <a:rPr sz="1000" b="1">
+                          <a:solidFill>
+                            <a:srgbClr val="FFFFFF"/>
+                          </a:solidFill>
+                          <a:latin typeface="Calibri"/>
+                        </a:rPr>
+                        <a:t>Entity_B today</a:t>
+                      </a:r>
+                    </a:p>
+                  </a:txBody>
+                  <a:tcPr marL="91440" marR="73152" marT="27432" marB="27432" anchor="ctr">
+                    <a:solidFill>
+                      <a:srgbClr val="460073"/>
+                    </a:solidFill>
+                  </a:tcPr>
+                </a:tc>
+                <a:tc>
+                  <a:txBody>
+                    <a:bodyPr wrap="square"/>
+                    <a:lstStyle/>
+                    <a:p>
+                      <a:pPr algn="ctr"/>
+                      <a:r>
+                        <a:rPr sz="1000" b="1">
+                          <a:solidFill>
+                            <a:srgbClr val="FFFFFF"/>
+                          </a:solidFill>
+                          <a:latin typeface="Calibri"/>
+                        </a:rPr>
+                        <a:t>Target (Entity_A today)</a:t>
+                      </a:r>
+                    </a:p>
+                  </a:txBody>
+                  <a:tcPr marL="91440" marR="73152" marT="27432" marB="27432" anchor="ctr">
+                    <a:solidFill>
+                      <a:srgbClr val="460073"/>
+                    </a:solidFill>
+                  </a:tcPr>
+                </a:tc>
+                <a:tc>
+                  <a:txBody>
+                    <a:bodyPr wrap="square"/>
+                    <a:lstStyle/>
+                    <a:p>
+                      <a:pPr algn="ctr"/>
+                      <a:r>
+                        <a:rPr sz="1000" b="1">
+                          <a:solidFill>
+                            <a:srgbClr val="FFFFFF"/>
+                          </a:solidFill>
+                          <a:latin typeface="Calibri"/>
+                        </a:rPr>
+                        <a:t>Review</a:t>
+                      </a:r>
+                    </a:p>
+                  </a:txBody>
+                  <a:tcPr marL="91440" marR="73152" marT="27432" marB="27432" anchor="ctr">
+                    <a:solidFill>
+                      <a:srgbClr val="460073"/>
+                    </a:solidFill>
+                  </a:tcPr>
+                </a:tc>
+                <a:tc>
+                  <a:txBody>
+                    <a:bodyPr wrap="square"/>
+                    <a:lstStyle/>
+                    <a:p>
+                      <a:pPr algn="l"/>
+                      <a:r>
+                        <a:rPr sz="1000" b="1">
+                          <a:solidFill>
+                            <a:srgbClr val="FFFFFF"/>
+                          </a:solidFill>
+                          <a:latin typeface="Calibri"/>
+                        </a:rPr>
+                        <a:t>Why this one</a:t>
+                      </a:r>
+                    </a:p>
+                  </a:txBody>
+                  <a:tcPr marL="91440" marR="73152" marT="27432" marB="27432" anchor="ctr">
+                    <a:solidFill>
+                      <a:srgbClr val="460073"/>
+                    </a:solidFill>
+                  </a:tcPr>
+                </a:tc>
+              </a:tr>
+              <a:tr h="402336">
+                <a:tc>
+                  <a:txBody>
+                    <a:bodyPr wrap="square"/>
+                    <a:lstStyle/>
+                    <a:p>
+                      <a:pPr algn="l"/>
+                      <a:r>
+                        <a:rPr sz="1050" b="0">
+                          <a:solidFill>
+                            <a:srgbClr val="22222A"/>
+                          </a:solidFill>
+                          <a:latin typeface="Calibri"/>
+                        </a:rPr>
+                        <a:t>Survey response rate</a:t>
+                      </a:r>
+                    </a:p>
+                  </a:txBody>
+                  <a:tcPr marL="91440" marR="73152" marT="27432" marB="27432" anchor="ctr">
+                    <a:solidFill>
+                      <a:srgbClr val="FFFFFF"/>
+                    </a:solidFill>
+                  </a:tcPr>
+                </a:tc>
+                <a:tc>
+                  <a:txBody>
+                    <a:bodyPr wrap="square"/>
+                    <a:lstStyle/>
+                    <a:p>
+                      <a:pPr algn="ctr"/>
+                      <a:r>
+                        <a:rPr sz="1050" b="0">
+                          <a:solidFill>
+                            <a:srgbClr val="22222A"/>
+                          </a:solidFill>
+                          <a:latin typeface="Calibri"/>
+                        </a:rPr>
+                        <a:t>62.6%</a:t>
+                      </a:r>
+                    </a:p>
+                  </a:txBody>
+                  <a:tcPr marL="91440" marR="73152" marT="27432" marB="27432" anchor="ctr">
+                    <a:solidFill>
+                      <a:srgbClr val="FFFFFF"/>
+                    </a:solidFill>
+                  </a:tcPr>
+                </a:tc>
+                <a:tc>
+                  <a:txBody>
+                    <a:bodyPr wrap="square"/>
+                    <a:lstStyle/>
+                    <a:p>
+                      <a:pPr algn="ctr"/>
+                      <a:r>
+                        <a:rPr sz="1050" b="0">
+                          <a:solidFill>
+                            <a:srgbClr val="22222A"/>
+                          </a:solidFill>
+                          <a:latin typeface="Calibri"/>
+                        </a:rPr>
+                        <a:t>83.8%</a:t>
+                      </a:r>
+                    </a:p>
+                  </a:txBody>
+                  <a:tcPr marL="91440" marR="73152" marT="27432" marB="27432" anchor="ctr">
+                    <a:solidFill>
+                      <a:srgbClr val="FFFFFF"/>
+                    </a:solidFill>
+                  </a:tcPr>
+                </a:tc>
+                <a:tc>
+                  <a:txBody>
+                    <a:bodyPr wrap="square"/>
+                    <a:lstStyle/>
+                    <a:p>
+                      <a:pPr algn="ctr"/>
+                      <a:r>
+                        <a:rPr sz="1050" b="0">
+                          <a:solidFill>
+                            <a:srgbClr val="22222A"/>
+                          </a:solidFill>
+                          <a:latin typeface="Calibri"/>
+                        </a:rPr>
+                        <a:t>Every wave</a:t>
+                      </a:r>
+                    </a:p>
+                  </a:txBody>
+                  <a:tcPr marL="91440" marR="73152" marT="27432" marB="27432" anchor="ctr">
+                    <a:solidFill>
+                      <a:srgbClr val="FFFFFF"/>
+                    </a:solidFill>
+                  </a:tcPr>
+                </a:tc>
+                <a:tc>
+                  <a:txBody>
+                    <a:bodyPr wrap="square"/>
+                    <a:lstStyle/>
+                    <a:p>
+                      <a:pPr algn="l"/>
+                      <a:r>
+                        <a:rPr sz="1050" b="0">
+                          <a:solidFill>
+                            <a:srgbClr val="22222A"/>
+                          </a:solidFill>
+                          <a:latin typeface="Calibri"/>
+                        </a:rPr>
+                        <a:t>Moves first and costs nothing to measure. The leading indicator.</a:t>
+                      </a:r>
+                    </a:p>
+                  </a:txBody>
+                  <a:tcPr marL="91440" marR="73152" marT="27432" marB="27432" anchor="ctr">
+                    <a:solidFill>
+                      <a:srgbClr val="FFFFFF"/>
+                    </a:solidFill>
+                  </a:tcPr>
+                </a:tc>
+              </a:tr>
+              <a:tr h="402336">
+                <a:tc>
+                  <a:txBody>
+                    <a:bodyPr wrap="square"/>
+                    <a:lstStyle/>
+                    <a:p>
+                      <a:pPr algn="l"/>
+                      <a:r>
+                        <a:rPr sz="1050" b="0">
+                          <a:solidFill>
+                            <a:srgbClr val="22222A"/>
+                          </a:solidFill>
+                          <a:latin typeface="Calibri"/>
+                        </a:rPr>
+                        <a:t>Senior leadership trust</a:t>
+                      </a:r>
+                    </a:p>
+                  </a:txBody>
+                  <a:tcPr marL="91440" marR="73152" marT="27432" marB="27432" anchor="ctr">
+                    <a:solidFill>
+                      <a:srgbClr val="F8F8FB"/>
+                    </a:solidFill>
+                  </a:tcPr>
+                </a:tc>
+                <a:tc>
+                  <a:txBody>
+                    <a:bodyPr wrap="square"/>
+                    <a:lstStyle/>
+                    <a:p>
+                      <a:pPr algn="ctr"/>
+                      <a:r>
+                        <a:rPr sz="1050" b="0">
+                          <a:solidFill>
+                            <a:srgbClr val="22222A"/>
+                          </a:solidFill>
+                          <a:latin typeface="Calibri"/>
+                        </a:rPr>
+                        <a:t>3.051</a:t>
+                      </a:r>
+                    </a:p>
+                  </a:txBody>
+                  <a:tcPr marL="91440" marR="73152" marT="27432" marB="27432" anchor="ctr">
+                    <a:solidFill>
+                      <a:srgbClr val="F8F8FB"/>
+                    </a:solidFill>
+                  </a:tcPr>
+                </a:tc>
+                <a:tc>
+                  <a:txBody>
+                    <a:bodyPr wrap="square"/>
+                    <a:lstStyle/>
+                    <a:p>
+                      <a:pPr algn="ctr"/>
+                      <a:r>
+                        <a:rPr sz="1050" b="0">
+                          <a:solidFill>
+                            <a:srgbClr val="22222A"/>
+                          </a:solidFill>
+                          <a:latin typeface="Calibri"/>
+                        </a:rPr>
+                        <a:t>3.352</a:t>
+                      </a:r>
+                    </a:p>
+                  </a:txBody>
+                  <a:tcPr marL="91440" marR="73152" marT="27432" marB="27432" anchor="ctr">
+                    <a:solidFill>
+                      <a:srgbClr val="F8F8FB"/>
+                    </a:solidFill>
+                  </a:tcPr>
+                </a:tc>
+                <a:tc>
+                  <a:txBody>
+                    <a:bodyPr wrap="square"/>
+                    <a:lstStyle/>
+                    <a:p>
+                      <a:pPr algn="ctr"/>
+                      <a:r>
+                        <a:rPr sz="1050" b="0">
+                          <a:solidFill>
+                            <a:srgbClr val="22222A"/>
+                          </a:solidFill>
+                          <a:latin typeface="Calibri"/>
+                        </a:rPr>
+                        <a:t>Every wave</a:t>
+                      </a:r>
+                    </a:p>
+                  </a:txBody>
+                  <a:tcPr marL="91440" marR="73152" marT="27432" marB="27432" anchor="ctr">
+                    <a:solidFill>
+                      <a:srgbClr val="F8F8FB"/>
+                    </a:solidFill>
+                  </a:tcPr>
+                </a:tc>
+                <a:tc>
+                  <a:txBody>
+                    <a:bodyPr wrap="square"/>
+                    <a:lstStyle/>
+                    <a:p>
+                      <a:pPr algn="l"/>
+                      <a:r>
+                        <a:rPr sz="1050" b="0">
+                          <a:solidFill>
+                            <a:srgbClr val="22222A"/>
+                          </a:solidFill>
+                          <a:latin typeface="Calibri"/>
+                        </a:rPr>
+                        <a:t>One of the two dimensions that actually collapsed.</a:t>
+                      </a:r>
+                    </a:p>
+                  </a:txBody>
+                  <a:tcPr marL="91440" marR="73152" marT="27432" marB="27432" anchor="ctr">
+                    <a:solidFill>
+                      <a:srgbClr val="F8F8FB"/>
+                    </a:solidFill>
+                  </a:tcPr>
+                </a:tc>
+              </a:tr>
+              <a:tr h="402336">
+                <a:tc>
+                  <a:txBody>
+                    <a:bodyPr wrap="square"/>
+                    <a:lstStyle/>
+                    <a:p>
+                      <a:pPr algn="l"/>
+                      <a:r>
+                        <a:rPr sz="1050" b="0">
+                          <a:solidFill>
+                            <a:srgbClr val="22222A"/>
+                          </a:solidFill>
+                          <a:latin typeface="Calibri"/>
+                        </a:rPr>
+                        <a:t>Purpose &amp; meaning</a:t>
+                      </a:r>
+                    </a:p>
+                  </a:txBody>
+                  <a:tcPr marL="91440" marR="73152" marT="27432" marB="27432" anchor="ctr">
+                    <a:solidFill>
+                      <a:srgbClr val="FFFFFF"/>
+                    </a:solidFill>
+                  </a:tcPr>
+                </a:tc>
+                <a:tc>
+                  <a:txBody>
+                    <a:bodyPr wrap="square"/>
+                    <a:lstStyle/>
+                    <a:p>
+                      <a:pPr algn="ctr"/>
+                      <a:r>
+                        <a:rPr sz="1050" b="0">
+                          <a:solidFill>
+                            <a:srgbClr val="22222A"/>
+                          </a:solidFill>
+                          <a:latin typeface="Calibri"/>
+                        </a:rPr>
+                        <a:t>3.058</a:t>
+                      </a:r>
+                    </a:p>
+                  </a:txBody>
+                  <a:tcPr marL="91440" marR="73152" marT="27432" marB="27432" anchor="ctr">
+                    <a:solidFill>
+                      <a:srgbClr val="FFFFFF"/>
+                    </a:solidFill>
+                  </a:tcPr>
+                </a:tc>
+                <a:tc>
+                  <a:txBody>
+                    <a:bodyPr wrap="square"/>
+                    <a:lstStyle/>
+                    <a:p>
+                      <a:pPr algn="ctr"/>
+                      <a:r>
+                        <a:rPr sz="1050" b="0">
+                          <a:solidFill>
+                            <a:srgbClr val="22222A"/>
+                          </a:solidFill>
+                          <a:latin typeface="Calibri"/>
+                        </a:rPr>
+                        <a:t>3.358</a:t>
+                      </a:r>
+                    </a:p>
+                  </a:txBody>
+                  <a:tcPr marL="91440" marR="73152" marT="27432" marB="27432" anchor="ctr">
+                    <a:solidFill>
+                      <a:srgbClr val="FFFFFF"/>
+                    </a:solidFill>
+                  </a:tcPr>
+                </a:tc>
+                <a:tc>
+                  <a:txBody>
+                    <a:bodyPr wrap="square"/>
+                    <a:lstStyle/>
+                    <a:p>
+                      <a:pPr algn="ctr"/>
+                      <a:r>
+                        <a:rPr sz="1050" b="0">
+                          <a:solidFill>
+                            <a:srgbClr val="22222A"/>
+                          </a:solidFill>
+                          <a:latin typeface="Calibri"/>
+                        </a:rPr>
+                        <a:t>Every wave</a:t>
+                      </a:r>
+                    </a:p>
+                  </a:txBody>
+                  <a:tcPr marL="91440" marR="73152" marT="27432" marB="27432" anchor="ctr">
+                    <a:solidFill>
+                      <a:srgbClr val="FFFFFF"/>
+                    </a:solidFill>
+                  </a:tcPr>
+                </a:tc>
+                <a:tc>
+                  <a:txBody>
+                    <a:bodyPr wrap="square"/>
+                    <a:lstStyle/>
+                    <a:p>
+                      <a:pPr algn="l"/>
+                      <a:r>
+                        <a:rPr sz="1050" b="0">
+                          <a:solidFill>
+                            <a:srgbClr val="22222A"/>
+                          </a:solidFill>
+                          <a:latin typeface="Calibri"/>
+                        </a:rPr>
+                        <a:t>The other one.</a:t>
+                      </a:r>
+                    </a:p>
+                  </a:txBody>
+                  <a:tcPr marL="91440" marR="73152" marT="27432" marB="27432" anchor="ctr">
+                    <a:solidFill>
+                      <a:srgbClr val="FFFFFF"/>
+                    </a:solidFill>
+                  </a:tcPr>
+                </a:tc>
+              </a:tr>
+              <a:tr h="402336">
+                <a:tc>
+                  <a:txBody>
+                    <a:bodyPr wrap="square"/>
+                    <a:lstStyle/>
+                    <a:p>
+                      <a:pPr algn="l"/>
+                      <a:r>
+                        <a:rPr sz="1050" b="0">
+                          <a:solidFill>
+                            <a:srgbClr val="22222A"/>
+                          </a:solidFill>
+                          <a:latin typeface="Calibri"/>
+                        </a:rPr>
+                        <a:t>Senior Manager (L3) attrition</a:t>
+                      </a:r>
+                    </a:p>
+                  </a:txBody>
+                  <a:tcPr marL="91440" marR="73152" marT="27432" marB="27432" anchor="ctr">
+                    <a:solidFill>
+                      <a:srgbClr val="F8F8FB"/>
+                    </a:solidFill>
+                  </a:tcPr>
+                </a:tc>
+                <a:tc>
+                  <a:txBody>
+                    <a:bodyPr wrap="square"/>
+                    <a:lstStyle/>
+                    <a:p>
+                      <a:pPr algn="ctr"/>
+                      <a:r>
+                        <a:rPr sz="1050" b="0">
+                          <a:solidFill>
+                            <a:srgbClr val="22222A"/>
+                          </a:solidFill>
+                          <a:latin typeface="Calibri"/>
+                        </a:rPr>
+                        <a:t>9.8%/yr</a:t>
+                      </a:r>
+                    </a:p>
+                  </a:txBody>
+                  <a:tcPr marL="91440" marR="73152" marT="27432" marB="27432" anchor="ctr">
+                    <a:solidFill>
+                      <a:srgbClr val="F8F8FB"/>
+                    </a:solidFill>
+                  </a:tcPr>
+                </a:tc>
+                <a:tc>
+                  <a:txBody>
+                    <a:bodyPr wrap="square"/>
+                    <a:lstStyle/>
+                    <a:p>
+                      <a:pPr algn="ctr"/>
+                      <a:r>
+                        <a:rPr sz="1050" b="0">
+                          <a:solidFill>
+                            <a:srgbClr val="22222A"/>
+                          </a:solidFill>
+                          <a:latin typeface="Calibri"/>
+                        </a:rPr>
+                        <a:t>2.9%/yr</a:t>
+                      </a:r>
+                    </a:p>
+                  </a:txBody>
+                  <a:tcPr marL="91440" marR="73152" marT="27432" marB="27432" anchor="ctr">
+                    <a:solidFill>
+                      <a:srgbClr val="F8F8FB"/>
+                    </a:solidFill>
+                  </a:tcPr>
+                </a:tc>
+                <a:tc>
+                  <a:txBody>
+                    <a:bodyPr wrap="square"/>
+                    <a:lstStyle/>
+                    <a:p>
+                      <a:pPr algn="ctr"/>
+                      <a:r>
+                        <a:rPr sz="1050" b="0">
+                          <a:solidFill>
+                            <a:srgbClr val="22222A"/>
+                          </a:solidFill>
+                          <a:latin typeface="Calibri"/>
+                        </a:rPr>
+                        <a:t>Quarterly</a:t>
+                      </a:r>
+                    </a:p>
+                  </a:txBody>
+                  <a:tcPr marL="91440" marR="73152" marT="27432" marB="27432" anchor="ctr">
+                    <a:solidFill>
+                      <a:srgbClr val="F8F8FB"/>
+                    </a:solidFill>
+                  </a:tcPr>
+                </a:tc>
+                <a:tc>
+                  <a:txBody>
+                    <a:bodyPr wrap="square"/>
+                    <a:lstStyle/>
+                    <a:p>
+                      <a:pPr algn="l"/>
+                      <a:r>
+                        <a:rPr sz="1050" b="0">
+                          <a:solidFill>
+                            <a:srgbClr val="22222A"/>
+                          </a:solidFill>
+                          <a:latin typeface="Calibri"/>
+                        </a:rPr>
+                        <a:t>The layer that has to carry the integration message.</a:t>
+                      </a:r>
+                    </a:p>
+                  </a:txBody>
+                  <a:tcPr marL="91440" marR="73152" marT="27432" marB="27432" anchor="ctr">
+                    <a:solidFill>
+                      <a:srgbClr val="F8F8FB"/>
+                    </a:solidFill>
+                  </a:tcPr>
+                </a:tc>
+              </a:tr>
+              <a:tr h="402336">
+                <a:tc>
+                  <a:txBody>
+                    <a:bodyPr wrap="square"/>
+                    <a:lstStyle/>
+                    <a:p>
+                      <a:pPr algn="l"/>
+                      <a:r>
+                        <a:rPr sz="1050" b="0">
+                          <a:solidFill>
+                            <a:srgbClr val="22222A"/>
+                          </a:solidFill>
+                          <a:latin typeface="Calibri"/>
+                        </a:rPr>
+                        <a:t>Voluntary attrition</a:t>
+                      </a:r>
+                    </a:p>
+                  </a:txBody>
+                  <a:tcPr marL="91440" marR="73152" marT="27432" marB="27432" anchor="ctr">
+                    <a:solidFill>
+                      <a:srgbClr val="FFFFFF"/>
+                    </a:solidFill>
+                  </a:tcPr>
+                </a:tc>
+                <a:tc>
+                  <a:txBody>
+                    <a:bodyPr wrap="square"/>
+                    <a:lstStyle/>
+                    <a:p>
+                      <a:pPr algn="ctr"/>
+                      <a:r>
+                        <a:rPr sz="1050" b="0">
+                          <a:solidFill>
+                            <a:srgbClr val="22222A"/>
+                          </a:solidFill>
+                          <a:latin typeface="Calibri"/>
+                        </a:rPr>
+                        <a:t>7.0%/yr</a:t>
+                      </a:r>
+                    </a:p>
+                  </a:txBody>
+                  <a:tcPr marL="91440" marR="73152" marT="27432" marB="27432" anchor="ctr">
+                    <a:solidFill>
+                      <a:srgbClr val="FFFFFF"/>
+                    </a:solidFill>
+                  </a:tcPr>
+                </a:tc>
+                <a:tc>
+                  <a:txBody>
+                    <a:bodyPr wrap="square"/>
+                    <a:lstStyle/>
+                    <a:p>
+                      <a:pPr algn="ctr"/>
+                      <a:r>
+                        <a:rPr sz="1050" b="0">
+                          <a:solidFill>
+                            <a:srgbClr val="22222A"/>
+                          </a:solidFill>
+                          <a:latin typeface="Calibri"/>
+                        </a:rPr>
+                        <a:t>3.6%/yr</a:t>
+                      </a:r>
+                    </a:p>
+                  </a:txBody>
+                  <a:tcPr marL="91440" marR="73152" marT="27432" marB="27432" anchor="ctr">
+                    <a:solidFill>
+                      <a:srgbClr val="FFFFFF"/>
+                    </a:solidFill>
+                  </a:tcPr>
+                </a:tc>
+                <a:tc>
+                  <a:txBody>
+                    <a:bodyPr wrap="square"/>
+                    <a:lstStyle/>
+                    <a:p>
+                      <a:pPr algn="ctr"/>
+                      <a:r>
+                        <a:rPr sz="1050" b="0">
+                          <a:solidFill>
+                            <a:srgbClr val="22222A"/>
+                          </a:solidFill>
+                          <a:latin typeface="Calibri"/>
+                        </a:rPr>
+                        <a:t>Quarterly</a:t>
+                      </a:r>
+                    </a:p>
+                  </a:txBody>
+                  <a:tcPr marL="91440" marR="73152" marT="27432" marB="27432" anchor="ctr">
+                    <a:solidFill>
+                      <a:srgbClr val="FFFFFF"/>
+                    </a:solidFill>
+                  </a:tcPr>
+                </a:tc>
+                <a:tc>
+                  <a:txBody>
+                    <a:bodyPr wrap="square"/>
+                    <a:lstStyle/>
+                    <a:p>
+                      <a:pPr algn="l"/>
+                      <a:r>
+                        <a:rPr sz="1050" b="0">
+                          <a:solidFill>
+                            <a:srgbClr val="22222A"/>
+                          </a:solidFill>
+                          <a:latin typeface="Calibri"/>
+                        </a:rPr>
+                        <a:t>The outcome. Moves last, so do not judge the programme on it early.</a:t>
+                      </a:r>
+                    </a:p>
+                  </a:txBody>
+                  <a:tcPr marL="91440" marR="73152" marT="27432" marB="27432" anchor="ctr">
+                    <a:solidFill>
+                      <a:srgbClr val="FFFFFF"/>
+                    </a:solidFill>
+                  </a:tcPr>
+                </a:tc>
+              </a:tr>
+              <a:tr h="402336">
+                <a:tc>
+                  <a:txBody>
+                    <a:bodyPr wrap="square"/>
+                    <a:lstStyle/>
+                    <a:p>
+                      <a:pPr algn="l"/>
+                      <a:r>
+                        <a:rPr sz="1050" b="0">
+                          <a:solidFill>
+                            <a:srgbClr val="22222A"/>
+                          </a:solidFill>
+                          <a:latin typeface="Calibri"/>
+                        </a:rPr>
+                        <a:t>Employees never surveyed</a:t>
+                      </a:r>
+                    </a:p>
+                  </a:txBody>
+                  <a:tcPr marL="91440" marR="73152" marT="27432" marB="27432" anchor="ctr">
+                    <a:solidFill>
+                      <a:srgbClr val="F8F8FB"/>
+                    </a:solidFill>
+                  </a:tcPr>
+                </a:tc>
+                <a:tc>
+                  <a:txBody>
+                    <a:bodyPr wrap="square"/>
+                    <a:lstStyle/>
+                    <a:p>
+                      <a:pPr algn="ctr"/>
+                      <a:r>
+                        <a:rPr sz="1050" b="0">
+                          <a:solidFill>
+                            <a:srgbClr val="22222A"/>
+                          </a:solidFill>
+                          <a:latin typeface="Calibri"/>
+                        </a:rPr>
+                        <a:t>152 on B and C systems</a:t>
+                      </a:r>
+                    </a:p>
+                  </a:txBody>
+                  <a:tcPr marL="91440" marR="73152" marT="27432" marB="27432" anchor="ctr">
+                    <a:solidFill>
+                      <a:srgbClr val="F8F8FB"/>
+                    </a:solidFill>
+                  </a:tcPr>
+                </a:tc>
+                <a:tc>
+                  <a:txBody>
+                    <a:bodyPr wrap="square"/>
+                    <a:lstStyle/>
+                    <a:p>
+                      <a:pPr algn="ctr"/>
+                      <a:r>
+                        <a:rPr sz="1050" b="0">
+                          <a:solidFill>
+                            <a:srgbClr val="22222A"/>
+                          </a:solidFill>
+                          <a:latin typeface="Calibri"/>
+                        </a:rPr>
+                        <a:t>0</a:t>
+                      </a:r>
+                    </a:p>
+                  </a:txBody>
+                  <a:tcPr marL="91440" marR="73152" marT="27432" marB="27432" anchor="ctr">
+                    <a:solidFill>
+                      <a:srgbClr val="F8F8FB"/>
+                    </a:solidFill>
+                  </a:tcPr>
+                </a:tc>
+                <a:tc>
+                  <a:txBody>
+                    <a:bodyPr wrap="square"/>
+                    <a:lstStyle/>
+                    <a:p>
+                      <a:pPr algn="ctr"/>
+                      <a:r>
+                        <a:rPr sz="1050" b="0">
+                          <a:solidFill>
+                            <a:srgbClr val="22222A"/>
+                          </a:solidFill>
+                          <a:latin typeface="Calibri"/>
+                        </a:rPr>
+                        <a:t>Every wave</a:t>
+                      </a:r>
+                    </a:p>
+                  </a:txBody>
+                  <a:tcPr marL="91440" marR="73152" marT="27432" marB="27432" anchor="ctr">
+                    <a:solidFill>
+                      <a:srgbClr val="F8F8FB"/>
+                    </a:solidFill>
+                  </a:tcPr>
+                </a:tc>
+                <a:tc>
+                  <a:txBody>
+                    <a:bodyPr wrap="square"/>
+                    <a:lstStyle/>
+                    <a:p>
+                      <a:pPr algn="l"/>
+                      <a:r>
+                        <a:rPr sz="1050" b="0">
+                          <a:solidFill>
+                            <a:srgbClr val="22222A"/>
+                          </a:solidFill>
+                          <a:latin typeface="Calibri"/>
+                        </a:rPr>
+                        <a:t>You cannot manage a cohort you are not asking.</a:t>
+                      </a:r>
+                    </a:p>
+                  </a:txBody>
+                  <a:tcPr marL="91440" marR="73152" marT="27432" marB="27432" anchor="ctr">
+                    <a:solidFill>
+                      <a:srgbClr val="F8F8FB"/>
+                    </a:solidFill>
+                  </a:tcPr>
+                </a:tc>
+              </a:tr>
+            </a:tbl>
+          </a:graphicData>
+        </a:graphic>
+      </p:graphicFrame>
+      <p:sp>
+        <p:nvSpPr>
+          <p:cNvPr id="9" name="Rectangle 8"/>
+          <p:cNvSpPr/>
+          <p:nvPr/>
+        </p:nvSpPr>
+        <p:spPr>
+          <a:xfrm>
+            <a:off x="566928" y="4892040"/>
+            <a:ext cx="3538728" cy="45720"/>
+          </a:xfrm>
+          <a:prstGeom prst="rect">
+            <a:avLst/>
+          </a:prstGeom>
+          <a:solidFill>
+            <a:srgbClr val="A100FF"/>
+          </a:solidFill>
+          <a:ln>
+            <a:noFill/>
+          </a:ln>
+          <a:effectLst/>
+        </p:spPr>
+        <p:style>
+          <a:lnRef idx="1">
+            <a:schemeClr val="accent1"/>
+          </a:lnRef>
+          <a:fillRef idx="3">
+            <a:schemeClr val="accent1"/>
+          </a:fillRef>
+          <a:effectRef idx="2">
+            <a:schemeClr val="accent1"/>
+          </a:effectRef>
+          <a:fontRef idx="minor">
+            <a:schemeClr val="lt1"/>
+          </a:fontRef>
+        </p:style>
+        <p:txBody>
+          <a:bodyPr rtlCol="0" anchor="ctr"/>
+          <a:lstStyle/>
+          <a:p>
+            <a:pPr algn="ctr"/>
+          </a:p>
+        </p:txBody>
+      </p:sp>
+      <p:sp>
+        <p:nvSpPr>
+          <p:cNvPr id="10" name="TextBox 9"/>
+          <p:cNvSpPr txBox="1"/>
+          <p:nvPr/>
+        </p:nvSpPr>
+        <p:spPr>
+          <a:xfrm>
+            <a:off x="566928" y="5065776"/>
+            <a:ext cx="3538728" cy="256032"/>
+          </a:xfrm>
+          <a:prstGeom prst="rect">
+            <a:avLst/>
+          </a:prstGeom>
+          <a:noFill/>
+        </p:spPr>
+        <p:txBody>
+          <a:bodyPr wrap="square" anchor="t" lIns="0" rIns="0" tIns="0" bIns="0">
+            <a:spAutoFit/>
+          </a:bodyPr>
+          <a:lstStyle/>
+          <a:p>
+            <a:pPr algn="l">
+              <a:lnSpc>
+                <a:spcPct val="100000"/>
+              </a:lnSpc>
+              <a:spcAft>
+                <a:spcPts val="800"/>
+              </a:spcAft>
+            </a:pPr>
+            <a:r>
+              <a:rPr sz="1050" i="0" b="1">
+                <a:solidFill>
+                  <a:srgbClr val="A100FF"/>
+                </a:solidFill>
+                <a:latin typeface="Calibri"/>
+              </a:rPr>
+              <a:t>BY DAY 30</a:t>
+            </a:r>
+          </a:p>
+          <a:p>
+            <a:pPr algn="l">
+              <a:lnSpc>
+                <a:spcPct val="118000"/>
+              </a:lnSpc>
+              <a:spcAft>
+                <a:spcPts val="0"/>
+              </a:spcAft>
+            </a:pPr>
+            <a:r>
+              <a:rPr sz="1100" i="0" b="0">
+                <a:solidFill>
+                  <a:srgbClr val="22222A"/>
+                </a:solidFill>
+                <a:latin typeface="Calibri"/>
+              </a:rPr>
+              <a:t>Regrettable flag redefined to include High Performer, and separated from the function that approves exits. Baseline restated. Costs about $0 and needs no programme.</a:t>
+            </a:r>
+          </a:p>
+        </p:txBody>
+      </p:sp>
+      <p:sp>
+        <p:nvSpPr>
+          <p:cNvPr id="11" name="Rectangle 10"/>
+          <p:cNvSpPr/>
+          <p:nvPr/>
+        </p:nvSpPr>
+        <p:spPr>
+          <a:xfrm>
+            <a:off x="4325112" y="4892040"/>
+            <a:ext cx="3538728" cy="45720"/>
+          </a:xfrm>
+          <a:prstGeom prst="rect">
+            <a:avLst/>
+          </a:prstGeom>
+          <a:solidFill>
+            <a:srgbClr val="FF6B6B"/>
+          </a:solidFill>
+          <a:ln>
+            <a:noFill/>
+          </a:ln>
+          <a:effectLst/>
+        </p:spPr>
+        <p:style>
+          <a:lnRef idx="1">
+            <a:schemeClr val="accent1"/>
+          </a:lnRef>
+          <a:fillRef idx="3">
+            <a:schemeClr val="accent1"/>
+          </a:fillRef>
+          <a:effectRef idx="2">
+            <a:schemeClr val="accent1"/>
+          </a:effectRef>
+          <a:fontRef idx="minor">
+            <a:schemeClr val="lt1"/>
+          </a:fontRef>
+        </p:style>
+        <p:txBody>
+          <a:bodyPr rtlCol="0" anchor="ctr"/>
+          <a:lstStyle/>
+          <a:p>
+            <a:pPr algn="ctr"/>
+          </a:p>
+        </p:txBody>
+      </p:sp>
+      <p:sp>
+        <p:nvSpPr>
+          <p:cNvPr id="12" name="TextBox 11"/>
+          <p:cNvSpPr txBox="1"/>
+          <p:nvPr/>
+        </p:nvSpPr>
+        <p:spPr>
+          <a:xfrm>
+            <a:off x="4325112" y="5065776"/>
+            <a:ext cx="3538728" cy="256032"/>
+          </a:xfrm>
+          <a:prstGeom prst="rect">
+            <a:avLst/>
+          </a:prstGeom>
+          <a:noFill/>
+        </p:spPr>
+        <p:txBody>
+          <a:bodyPr wrap="square" anchor="t" lIns="0" rIns="0" tIns="0" bIns="0">
+            <a:spAutoFit/>
+          </a:bodyPr>
+          <a:lstStyle/>
+          <a:p>
+            <a:pPr algn="l">
+              <a:lnSpc>
+                <a:spcPct val="100000"/>
+              </a:lnSpc>
+              <a:spcAft>
+                <a:spcPts val="800"/>
+              </a:spcAft>
+            </a:pPr>
+            <a:r>
+              <a:rPr sz="1050" i="0" b="1">
+                <a:solidFill>
+                  <a:srgbClr val="FF6B6B"/>
+                </a:solidFill>
+                <a:latin typeface="Calibri"/>
+              </a:rPr>
+              <a:t>BY DAY 60</a:t>
+            </a:r>
+          </a:p>
+          <a:p>
+            <a:pPr algn="l">
+              <a:lnSpc>
+                <a:spcPct val="118000"/>
+              </a:lnSpc>
+              <a:spcAft>
+                <a:spcPts val="0"/>
+              </a:spcAft>
+            </a:pPr>
+            <a:r>
+              <a:rPr sz="1100" i="0" b="0">
+                <a:solidFill>
+                  <a:srgbClr val="22222A"/>
+                </a:solidFill>
+                <a:latin typeface="Calibri"/>
+              </a:rPr>
+              <a:t>Entity_B migration off BambooHR scheduled with a date. Senior Manager retention conversations complete. All 152 unsurveyed staff issued the next wave.</a:t>
+            </a:r>
+          </a:p>
+        </p:txBody>
+      </p:sp>
+      <p:sp>
+        <p:nvSpPr>
+          <p:cNvPr id="13" name="Rectangle 12"/>
+          <p:cNvSpPr/>
+          <p:nvPr/>
+        </p:nvSpPr>
+        <p:spPr>
+          <a:xfrm>
+            <a:off x="8083296" y="4892040"/>
+            <a:ext cx="3538728" cy="45720"/>
+          </a:xfrm>
+          <a:prstGeom prst="rect">
+            <a:avLst/>
+          </a:prstGeom>
+          <a:solidFill>
+            <a:srgbClr val="00B7C3"/>
+          </a:solidFill>
+          <a:ln>
+            <a:noFill/>
+          </a:ln>
+          <a:effectLst/>
+        </p:spPr>
+        <p:style>
+          <a:lnRef idx="1">
+            <a:schemeClr val="accent1"/>
+          </a:lnRef>
+          <a:fillRef idx="3">
+            <a:schemeClr val="accent1"/>
+          </a:fillRef>
+          <a:effectRef idx="2">
+            <a:schemeClr val="accent1"/>
+          </a:effectRef>
+          <a:fontRef idx="minor">
+            <a:schemeClr val="lt1"/>
+          </a:fontRef>
+        </p:style>
+        <p:txBody>
+          <a:bodyPr rtlCol="0" anchor="ctr"/>
+          <a:lstStyle/>
+          <a:p>
+            <a:pPr algn="ctr"/>
+          </a:p>
+        </p:txBody>
+      </p:sp>
+      <p:sp>
+        <p:nvSpPr>
+          <p:cNvPr id="14" name="TextBox 13"/>
+          <p:cNvSpPr txBox="1"/>
+          <p:nvPr/>
+        </p:nvSpPr>
+        <p:spPr>
+          <a:xfrm>
+            <a:off x="8083296" y="5065776"/>
+            <a:ext cx="3538728" cy="256032"/>
+          </a:xfrm>
+          <a:prstGeom prst="rect">
+            <a:avLst/>
+          </a:prstGeom>
+          <a:noFill/>
+        </p:spPr>
+        <p:txBody>
+          <a:bodyPr wrap="square" anchor="t" lIns="0" rIns="0" tIns="0" bIns="0">
+            <a:spAutoFit/>
+          </a:bodyPr>
+          <a:lstStyle/>
+          <a:p>
+            <a:pPr algn="l">
+              <a:lnSpc>
+                <a:spcPct val="100000"/>
+              </a:lnSpc>
+              <a:spcAft>
+                <a:spcPts val="800"/>
+              </a:spcAft>
+            </a:pPr>
+            <a:r>
+              <a:rPr sz="1050" i="0" b="1">
+                <a:solidFill>
+                  <a:srgbClr val="00B7C3"/>
+                </a:solidFill>
+                <a:latin typeface="Calibri"/>
+              </a:rPr>
+              <a:t>BY DAY 90</a:t>
+            </a:r>
+          </a:p>
+          <a:p>
+            <a:pPr algn="l">
+              <a:lnSpc>
+                <a:spcPct val="118000"/>
+              </a:lnSpc>
+              <a:spcAft>
+                <a:spcPts val="0"/>
+              </a:spcAft>
+            </a:pPr>
+            <a:r>
+              <a:rPr sz="1100" i="0" b="0">
+                <a:solidFill>
+                  <a:srgbClr val="22222A"/>
+                </a:solidFill>
+                <a:latin typeface="Calibri"/>
+              </a:rPr>
+              <a:t>First post-intervention wave read against Entity_A's trajectory, not against Entity_B's own past. Response rate is the number to watch; attrition will not have moved yet.</a:t>
+            </a:r>
+          </a:p>
+        </p:txBody>
+      </p:sp>
+      <p:sp>
+        <p:nvSpPr>
+          <p:cNvPr id="15" name="Rectangle 14"/>
+          <p:cNvSpPr/>
+          <p:nvPr/>
+        </p:nvSpPr>
+        <p:spPr>
+          <a:xfrm>
+            <a:off x="566928" y="5943600"/>
+            <a:ext cx="50292" cy="347472"/>
+          </a:xfrm>
+          <a:prstGeom prst="rect">
+            <a:avLst/>
+          </a:prstGeom>
+          <a:solidFill>
+            <a:srgbClr val="FFB300"/>
+          </a:solidFill>
+          <a:ln>
+            <a:noFill/>
+          </a:ln>
+          <a:effectLst/>
+        </p:spPr>
+        <p:style>
+          <a:lnRef idx="1">
+            <a:schemeClr val="accent1"/>
+          </a:lnRef>
+          <a:fillRef idx="3">
+            <a:schemeClr val="accent1"/>
+          </a:fillRef>
+          <a:effectRef idx="2">
+            <a:schemeClr val="accent1"/>
+          </a:effectRef>
+          <a:fontRef idx="minor">
+            <a:schemeClr val="lt1"/>
+          </a:fontRef>
+        </p:style>
+        <p:txBody>
+          <a:bodyPr rtlCol="0" anchor="ctr"/>
+          <a:lstStyle/>
+          <a:p>
+            <a:pPr algn="ctr"/>
+          </a:p>
+        </p:txBody>
+      </p:sp>
+      <p:sp>
+        <p:nvSpPr>
+          <p:cNvPr id="16" name="TextBox 15"/>
+          <p:cNvSpPr txBox="1"/>
+          <p:nvPr/>
+        </p:nvSpPr>
+        <p:spPr>
+          <a:xfrm>
+            <a:off x="768096" y="5943600"/>
+            <a:ext cx="10771632" cy="347472"/>
+          </a:xfrm>
+          <a:prstGeom prst="rect">
+            <a:avLst/>
+          </a:prstGeom>
+          <a:noFill/>
+        </p:spPr>
+        <p:txBody>
+          <a:bodyPr wrap="square" anchor="ctr" lIns="0" rIns="0" tIns="0" bIns="0">
+            <a:spAutoFit/>
+          </a:bodyPr>
+          <a:lstStyle/>
+          <a:p>
+            <a:pPr algn="l">
+              <a:lnSpc>
+                <a:spcPct val="116000"/>
+              </a:lnSpc>
+              <a:spcAft>
+                <a:spcPts val="0"/>
+              </a:spcAft>
+            </a:pPr>
+            <a:r>
+              <a:rPr sz="1000" i="1" b="0">
+                <a:solidFill>
+                  <a:srgbClr val="22222A"/>
+                </a:solidFill>
+                <a:latin typeface="Calibri"/>
+              </a:rPr>
+              <a:t>Judge the programme on response rate and trust at 90 days. Attrition is a lagging measure and will not have moved.</a:t>
+            </a:r>
+          </a:p>
+        </p:txBody>
+      </p:sp>
+    </p:spTree>
+  </p:cSld>
+  <p:clrMapOvr>
+    <a:masterClrMapping/>
+  </p:clrMapOvr>
+</p:sld>
+</file>
+
+<file path=ppt/slides/slide35.xml><?xml version="1.0" encoding="utf-8"?>
+<p:sld xmlns:a="http://schemas.openxmlformats.org/drawingml/2006/main" xmlns:p="http://schemas.openxmlformats.org/presentationml/2006/main" xmlns:r="http://schemas.openxmlformats.org/officeDocument/2006/relationships">
+  <p:cSld>
+    <p:spTree>
+      <p:nvGrpSpPr>
+        <p:cNvPr id="1" name=""/>
+        <p:cNvGrpSpPr/>
+        <p:nvPr/>
+      </p:nvGrpSpPr>
+      <p:grpSpPr/>
+      <p:sp>
+        <p:nvSpPr>
+          <p:cNvPr id="2" name="Rectangle 1"/>
+          <p:cNvSpPr/>
+          <p:nvPr/>
+        </p:nvSpPr>
+        <p:spPr>
+          <a:xfrm>
+            <a:off x="0" y="0"/>
+            <a:ext cx="12191695" cy="68580"/>
+          </a:xfrm>
+          <a:prstGeom prst="rect">
+            <a:avLst/>
+          </a:prstGeom>
+          <a:solidFill>
+            <a:srgbClr val="5A5A66"/>
+          </a:solidFill>
+          <a:ln>
+            <a:noFill/>
+          </a:ln>
+          <a:effectLst/>
+        </p:spPr>
+        <p:style>
+          <a:lnRef idx="1">
+            <a:schemeClr val="accent1"/>
+          </a:lnRef>
+          <a:fillRef idx="3">
+            <a:schemeClr val="accent1"/>
+          </a:fillRef>
+          <a:effectRef idx="2">
+            <a:schemeClr val="accent1"/>
+          </a:effectRef>
+          <a:fontRef idx="minor">
+            <a:schemeClr val="lt1"/>
+          </a:fontRef>
+        </p:style>
+        <p:txBody>
+          <a:bodyPr rtlCol="0" anchor="ctr"/>
+          <a:lstStyle/>
+          <a:p>
+            <a:pPr algn="ctr"/>
+          </a:p>
+        </p:txBody>
+      </p:sp>
+      <p:sp>
+        <p:nvSpPr>
+          <p:cNvPr id="3" name="TextBox 2"/>
+          <p:cNvSpPr txBox="1"/>
+          <p:nvPr/>
+        </p:nvSpPr>
+        <p:spPr>
+          <a:xfrm>
+            <a:off x="566928" y="347472"/>
+            <a:ext cx="11057839" cy="237744"/>
+          </a:xfrm>
+          <a:prstGeom prst="rect">
+            <a:avLst/>
+          </a:prstGeom>
+          <a:noFill/>
+        </p:spPr>
+        <p:txBody>
+          <a:bodyPr wrap="square" anchor="t" lIns="0" rIns="0" tIns="0" bIns="0">
+            <a:spAutoFit/>
+          </a:bodyPr>
+          <a:lstStyle/>
+          <a:p>
+            <a:pPr algn="l">
+              <a:lnSpc>
+                <a:spcPct val="100000"/>
+              </a:lnSpc>
+              <a:spcAft>
+                <a:spcPts val="0"/>
+              </a:spcAft>
+            </a:pPr>
+            <a:r>
+              <a:rPr sz="1100" i="0" b="1">
+                <a:solidFill>
+                  <a:srgbClr val="A100FF"/>
+                </a:solidFill>
+                <a:latin typeface="Calibri"/>
+              </a:rPr>
+              <a:t>APPENDIX A17</a:t>
+            </a:r>
+          </a:p>
+        </p:txBody>
+      </p:sp>
+      <p:sp>
+        <p:nvSpPr>
+          <p:cNvPr id="4" name="TextBox 3"/>
+          <p:cNvSpPr txBox="1"/>
+          <p:nvPr/>
+        </p:nvSpPr>
+        <p:spPr>
+          <a:xfrm>
+            <a:off x="566928" y="621792"/>
+            <a:ext cx="11057839" cy="457200"/>
+          </a:xfrm>
+          <a:prstGeom prst="rect">
+            <a:avLst/>
+          </a:prstGeom>
+          <a:noFill/>
+        </p:spPr>
+        <p:txBody>
+          <a:bodyPr wrap="square" anchor="t" lIns="0" rIns="0" tIns="0" bIns="0">
+            <a:spAutoFit/>
+          </a:bodyPr>
+          <a:lstStyle/>
+          <a:p>
+            <a:pPr algn="l">
+              <a:lnSpc>
+                <a:spcPct val="100000"/>
+              </a:lnSpc>
+              <a:spcAft>
+                <a:spcPts val="0"/>
+              </a:spcAft>
+            </a:pPr>
+            <a:r>
+              <a:rPr sz="2300" i="0" b="1">
+                <a:solidFill>
+                  <a:srgbClr val="460073"/>
+                </a:solidFill>
+                <a:latin typeface="Calibri"/>
+              </a:rPr>
+              <a:t>Model card — cohort diagnostic</a:t>
+            </a:r>
+          </a:p>
+        </p:txBody>
+      </p:sp>
+      <p:sp>
+        <p:nvSpPr>
+          <p:cNvPr id="5" name="TextBox 4"/>
+          <p:cNvSpPr txBox="1"/>
+          <p:nvPr/>
+        </p:nvSpPr>
+        <p:spPr>
+          <a:xfrm>
+            <a:off x="566928" y="1051560"/>
+            <a:ext cx="10607040" cy="384048"/>
+          </a:xfrm>
+          <a:prstGeom prst="rect">
+            <a:avLst/>
+          </a:prstGeom>
+          <a:noFill/>
+        </p:spPr>
+        <p:txBody>
+          <a:bodyPr wrap="square" anchor="t" lIns="0" rIns="0" tIns="0" bIns="0">
+            <a:spAutoFit/>
+          </a:bodyPr>
+          <a:lstStyle/>
+          <a:p>
+            <a:pPr algn="l">
+              <a:lnSpc>
+                <a:spcPct val="115000"/>
+              </a:lnSpc>
+              <a:spcAft>
+                <a:spcPts val="0"/>
+              </a:spcAft>
+            </a:pPr>
+            <a:r>
+              <a:rPr sz="1150" i="1" b="0">
+                <a:solidFill>
+                  <a:srgbClr val="5A5A66"/>
+                </a:solidFill>
+                <a:latin typeface="Calibri"/>
+              </a:rPr>
+              <a:t>The accompanying dashboard is a model, so it gets a model card. Intended use, prohibited use, and known limits, stated up front rather than discovered later.</a:t>
+            </a:r>
+          </a:p>
+        </p:txBody>
+      </p:sp>
+      <p:sp>
+        <p:nvSpPr>
+          <p:cNvPr id="6" name="TextBox 5"/>
+          <p:cNvSpPr txBox="1"/>
+          <p:nvPr/>
+        </p:nvSpPr>
+        <p:spPr>
+          <a:xfrm>
+            <a:off x="10893247" y="6355080"/>
+            <a:ext cx="731520" cy="228600"/>
+          </a:xfrm>
+          <a:prstGeom prst="rect">
+            <a:avLst/>
+          </a:prstGeom>
+          <a:noFill/>
+        </p:spPr>
+        <p:txBody>
+          <a:bodyPr wrap="square" anchor="t" lIns="0" rIns="0" tIns="0" bIns="0">
+            <a:spAutoFit/>
+          </a:bodyPr>
+          <a:lstStyle/>
+          <a:p>
+            <a:pPr algn="r">
+              <a:lnSpc>
+                <a:spcPct val="100000"/>
+              </a:lnSpc>
+              <a:spcAft>
+                <a:spcPts val="0"/>
+              </a:spcAft>
+            </a:pPr>
+            <a:r>
+              <a:rPr sz="1000" i="0" b="1">
+                <a:solidFill>
+                  <a:srgbClr val="5A5A66"/>
+                </a:solidFill>
+                <a:latin typeface="Calibri"/>
+              </a:rPr>
+              <a:t>A17</a:t>
+            </a:r>
+          </a:p>
+        </p:txBody>
+      </p:sp>
+      <p:sp>
+        <p:nvSpPr>
+          <p:cNvPr id="7" name="Rectangle 6"/>
+          <p:cNvSpPr/>
+          <p:nvPr/>
+        </p:nvSpPr>
+        <p:spPr>
+          <a:xfrm>
+            <a:off x="566928" y="1627632"/>
+            <a:ext cx="3538728" cy="45720"/>
+          </a:xfrm>
+          <a:prstGeom prst="rect">
+            <a:avLst/>
+          </a:prstGeom>
+          <a:solidFill>
+            <a:srgbClr val="00B7C3"/>
+          </a:solidFill>
+          <a:ln>
+            <a:noFill/>
+          </a:ln>
+          <a:effectLst/>
+        </p:spPr>
+        <p:style>
+          <a:lnRef idx="1">
+            <a:schemeClr val="accent1"/>
+          </a:lnRef>
+          <a:fillRef idx="3">
+            <a:schemeClr val="accent1"/>
+          </a:fillRef>
+          <a:effectRef idx="2">
+            <a:schemeClr val="accent1"/>
+          </a:effectRef>
+          <a:fontRef idx="minor">
+            <a:schemeClr val="lt1"/>
+          </a:fontRef>
+        </p:style>
+        <p:txBody>
+          <a:bodyPr rtlCol="0" anchor="ctr"/>
+          <a:lstStyle/>
+          <a:p>
+            <a:pPr algn="ctr"/>
+          </a:p>
+        </p:txBody>
+      </p:sp>
+      <p:sp>
+        <p:nvSpPr>
+          <p:cNvPr id="8" name="TextBox 7"/>
+          <p:cNvSpPr txBox="1"/>
+          <p:nvPr/>
+        </p:nvSpPr>
+        <p:spPr>
+          <a:xfrm>
+            <a:off x="566928" y="1810512"/>
+            <a:ext cx="3538728" cy="274320"/>
+          </a:xfrm>
+          <a:prstGeom prst="rect">
+            <a:avLst/>
+          </a:prstGeom>
+          <a:noFill/>
+        </p:spPr>
+        <p:txBody>
+          <a:bodyPr wrap="square" anchor="t" lIns="0" rIns="0" tIns="0" bIns="0">
+            <a:spAutoFit/>
+          </a:bodyPr>
+          <a:lstStyle/>
+          <a:p>
+            <a:pPr algn="l">
+              <a:lnSpc>
+                <a:spcPct val="100000"/>
+              </a:lnSpc>
+              <a:spcAft>
+                <a:spcPts val="1200"/>
+              </a:spcAft>
+            </a:pPr>
+            <a:r>
+              <a:rPr sz="1050" i="0" b="1">
+                <a:solidFill>
+                  <a:srgbClr val="00B7C3"/>
+                </a:solidFill>
+                <a:latin typeface="Calibri"/>
+              </a:rPr>
+              <a:t>INTENDED USE</a:t>
+            </a:r>
+          </a:p>
+          <a:p>
+            <a:pPr algn="l">
+              <a:lnSpc>
+                <a:spcPct val="118000"/>
+              </a:lnSpc>
+              <a:spcAft>
+                <a:spcPts val="1000"/>
+              </a:spcAft>
+            </a:pPr>
+            <a:r>
+              <a:rPr sz="1100" i="0" b="0">
+                <a:solidFill>
+                  <a:srgbClr val="22222A"/>
+                </a:solidFill>
+                <a:latin typeface="Calibri"/>
+              </a:rPr>
+              <a:t>•  Cohort-level diagnostic for HR and integration leads.</a:t>
+            </a:r>
+          </a:p>
+          <a:p>
+            <a:pPr algn="l">
+              <a:lnSpc>
+                <a:spcPct val="118000"/>
+              </a:lnSpc>
+              <a:spcAft>
+                <a:spcPts val="1000"/>
+              </a:spcAft>
+            </a:pPr>
+            <a:r>
+              <a:rPr sz="1100" i="0" b="0">
+                <a:solidFill>
+                  <a:srgbClr val="22222A"/>
+                </a:solidFill>
+                <a:latin typeface="Calibri"/>
+              </a:rPr>
+              <a:t>•  Identifying which parts of the organisation resemble Entity_B before its attrition rose, so integration effort can be directed.</a:t>
+            </a:r>
+          </a:p>
+          <a:p>
+            <a:pPr algn="l">
+              <a:lnSpc>
+                <a:spcPct val="118000"/>
+              </a:lnSpc>
+              <a:spcAft>
+                <a:spcPts val="1000"/>
+              </a:spcAft>
+            </a:pPr>
+            <a:r>
+              <a:rPr sz="1100" i="0" b="0">
+                <a:solidFill>
+                  <a:srgbClr val="22222A"/>
+                </a:solidFill>
+                <a:latin typeface="Calibri"/>
+              </a:rPr>
+              <a:t>•  Tracking cohorts against the A16 measures over time.</a:t>
+            </a:r>
+          </a:p>
+        </p:txBody>
+      </p:sp>
+      <p:sp>
+        <p:nvSpPr>
+          <p:cNvPr id="9" name="Rectangle 8"/>
+          <p:cNvSpPr/>
+          <p:nvPr/>
+        </p:nvSpPr>
+        <p:spPr>
+          <a:xfrm>
+            <a:off x="4325112" y="1627632"/>
+            <a:ext cx="3538728" cy="45720"/>
+          </a:xfrm>
+          <a:prstGeom prst="rect">
+            <a:avLst/>
+          </a:prstGeom>
+          <a:solidFill>
+            <a:srgbClr val="FF6B6B"/>
+          </a:solidFill>
+          <a:ln>
+            <a:noFill/>
+          </a:ln>
+          <a:effectLst/>
+        </p:spPr>
+        <p:style>
+          <a:lnRef idx="1">
+            <a:schemeClr val="accent1"/>
+          </a:lnRef>
+          <a:fillRef idx="3">
+            <a:schemeClr val="accent1"/>
+          </a:fillRef>
+          <a:effectRef idx="2">
+            <a:schemeClr val="accent1"/>
+          </a:effectRef>
+          <a:fontRef idx="minor">
+            <a:schemeClr val="lt1"/>
+          </a:fontRef>
+        </p:style>
+        <p:txBody>
+          <a:bodyPr rtlCol="0" anchor="ctr"/>
+          <a:lstStyle/>
+          <a:p>
+            <a:pPr algn="ctr"/>
+          </a:p>
+        </p:txBody>
+      </p:sp>
+      <p:sp>
+        <p:nvSpPr>
+          <p:cNvPr id="10" name="TextBox 9"/>
+          <p:cNvSpPr txBox="1"/>
+          <p:nvPr/>
+        </p:nvSpPr>
+        <p:spPr>
+          <a:xfrm>
+            <a:off x="4325112" y="1810512"/>
+            <a:ext cx="3538728" cy="274320"/>
+          </a:xfrm>
+          <a:prstGeom prst="rect">
+            <a:avLst/>
+          </a:prstGeom>
+          <a:noFill/>
+        </p:spPr>
+        <p:txBody>
+          <a:bodyPr wrap="square" anchor="t" lIns="0" rIns="0" tIns="0" bIns="0">
+            <a:spAutoFit/>
+          </a:bodyPr>
+          <a:lstStyle/>
+          <a:p>
+            <a:pPr algn="l">
+              <a:lnSpc>
+                <a:spcPct val="100000"/>
+              </a:lnSpc>
+              <a:spcAft>
+                <a:spcPts val="1200"/>
+              </a:spcAft>
+            </a:pPr>
+            <a:r>
+              <a:rPr sz="1050" i="0" b="1">
+                <a:solidFill>
+                  <a:srgbClr val="FF6B6B"/>
+                </a:solidFill>
+                <a:latin typeface="Calibri"/>
+              </a:rPr>
+              <a:t>PROHIBITED USE</a:t>
+            </a:r>
+          </a:p>
+          <a:p>
+            <a:pPr algn="l">
+              <a:lnSpc>
+                <a:spcPct val="118000"/>
+              </a:lnSpc>
+              <a:spcAft>
+                <a:spcPts val="1000"/>
+              </a:spcAft>
+            </a:pPr>
+            <a:r>
+              <a:rPr sz="1100" i="0" b="0">
+                <a:solidFill>
+                  <a:srgbClr val="22222A"/>
+                </a:solidFill>
+                <a:latin typeface="Calibri"/>
+              </a:rPr>
+              <a:t>•  Any decision about an individual. The file contains no employee, manager or team identifier, so this is enforced by construction rather than by policy.</a:t>
+            </a:r>
+          </a:p>
+          <a:p>
+            <a:pPr algn="l">
+              <a:lnSpc>
+                <a:spcPct val="118000"/>
+              </a:lnSpc>
+              <a:spcAft>
+                <a:spcPts val="1000"/>
+              </a:spcAft>
+            </a:pPr>
+            <a:r>
+              <a:rPr sz="1100" i="0" b="0">
+                <a:solidFill>
+                  <a:srgbClr val="22222A"/>
+                </a:solidFill>
+                <a:latin typeface="Calibri"/>
+              </a:rPr>
+              <a:t>•  Performance management, redundancy selection, or promotion input.</a:t>
+            </a:r>
+          </a:p>
+          <a:p>
+            <a:pPr algn="l">
+              <a:lnSpc>
+                <a:spcPct val="118000"/>
+              </a:lnSpc>
+              <a:spcAft>
+                <a:spcPts val="1000"/>
+              </a:spcAft>
+            </a:pPr>
+            <a:r>
+              <a:rPr sz="1100" i="0" b="0">
+                <a:solidFill>
+                  <a:srgbClr val="22222A"/>
+                </a:solidFill>
+                <a:latin typeface="Calibri"/>
+              </a:rPr>
+              <a:t>•  Publishing cohort scores to managers without the fairness context in A4.</a:t>
+            </a:r>
+          </a:p>
+        </p:txBody>
+      </p:sp>
+      <p:sp>
+        <p:nvSpPr>
+          <p:cNvPr id="11" name="Rectangle 10"/>
+          <p:cNvSpPr/>
+          <p:nvPr/>
+        </p:nvSpPr>
+        <p:spPr>
+          <a:xfrm>
+            <a:off x="8083296" y="1627632"/>
+            <a:ext cx="3538728" cy="45720"/>
+          </a:xfrm>
+          <a:prstGeom prst="rect">
+            <a:avLst/>
+          </a:prstGeom>
+          <a:solidFill>
+            <a:srgbClr val="FFB300"/>
+          </a:solidFill>
+          <a:ln>
+            <a:noFill/>
+          </a:ln>
+          <a:effectLst/>
+        </p:spPr>
+        <p:style>
+          <a:lnRef idx="1">
+            <a:schemeClr val="accent1"/>
+          </a:lnRef>
+          <a:fillRef idx="3">
+            <a:schemeClr val="accent1"/>
+          </a:fillRef>
+          <a:effectRef idx="2">
+            <a:schemeClr val="accent1"/>
+          </a:effectRef>
+          <a:fontRef idx="minor">
+            <a:schemeClr val="lt1"/>
+          </a:fontRef>
+        </p:style>
+        <p:txBody>
+          <a:bodyPr rtlCol="0" anchor="ctr"/>
+          <a:lstStyle/>
+          <a:p>
+            <a:pPr algn="ctr"/>
+          </a:p>
+        </p:txBody>
+      </p:sp>
+      <p:sp>
+        <p:nvSpPr>
+          <p:cNvPr id="12" name="TextBox 11"/>
+          <p:cNvSpPr txBox="1"/>
+          <p:nvPr/>
+        </p:nvSpPr>
+        <p:spPr>
+          <a:xfrm>
+            <a:off x="8083296" y="1810512"/>
+            <a:ext cx="3538728" cy="274320"/>
+          </a:xfrm>
+          <a:prstGeom prst="rect">
+            <a:avLst/>
+          </a:prstGeom>
+          <a:noFill/>
+        </p:spPr>
+        <p:txBody>
+          <a:bodyPr wrap="square" anchor="t" lIns="0" rIns="0" tIns="0" bIns="0">
+            <a:spAutoFit/>
+          </a:bodyPr>
+          <a:lstStyle/>
+          <a:p>
+            <a:pPr algn="l">
+              <a:lnSpc>
+                <a:spcPct val="100000"/>
+              </a:lnSpc>
+              <a:spcAft>
+                <a:spcPts val="1200"/>
+              </a:spcAft>
+            </a:pPr>
+            <a:r>
+              <a:rPr sz="1050" i="0" b="1">
+                <a:solidFill>
+                  <a:srgbClr val="FFB300"/>
+                </a:solidFill>
+                <a:latin typeface="Calibri"/>
+              </a:rPr>
+              <a:t>KNOWN LIMITS</a:t>
+            </a:r>
+          </a:p>
+          <a:p>
+            <a:pPr algn="l">
+              <a:lnSpc>
+                <a:spcPct val="118000"/>
+              </a:lnSpc>
+              <a:spcAft>
+                <a:spcPts val="1000"/>
+              </a:spcAft>
+            </a:pPr>
+            <a:r>
+              <a:rPr sz="1100" i="0" b="0">
+                <a:solidFill>
+                  <a:srgbClr val="22222A"/>
+                </a:solidFill>
+                <a:latin typeface="Calibri"/>
+              </a:rPr>
+              <a:t>•  Diagnostic, not predictive. It has no validated forward accuracy and none is claimed.</a:t>
+            </a:r>
+          </a:p>
+          <a:p>
+            <a:pPr algn="l">
+              <a:lnSpc>
+                <a:spcPct val="118000"/>
+              </a:lnSpc>
+              <a:spcAft>
+                <a:spcPts val="1000"/>
+              </a:spcAft>
+            </a:pPr>
+            <a:r>
+              <a:rPr sz="1100" i="0" b="0">
+                <a:solidFill>
+                  <a:srgbClr val="22222A"/>
+                </a:solidFill>
+                <a:latin typeface="Calibri"/>
+              </a:rPr>
+              <a:t>•  Engagement is observed only for responders, so every score is a lower bound on a partially observed population.</a:t>
+            </a:r>
+          </a:p>
+          <a:p>
+            <a:pPr algn="l">
+              <a:lnSpc>
+                <a:spcPct val="118000"/>
+              </a:lnSpc>
+              <a:spcAft>
+                <a:spcPts val="1000"/>
+              </a:spcAft>
+            </a:pPr>
+            <a:r>
+              <a:rPr sz="1100" i="0" b="0">
+                <a:solidFill>
+                  <a:srgbClr val="22222A"/>
+                </a:solidFill>
+                <a:latin typeface="Calibri"/>
+              </a:rPr>
+              <a:t>•  Component weights (40/40/20) are a judgement, not a finding. They are shown separately in the tool so the score can be audited.</a:t>
+            </a:r>
+          </a:p>
+          <a:p>
+            <a:pPr algn="l">
+              <a:lnSpc>
+                <a:spcPct val="118000"/>
+              </a:lnSpc>
+              <a:spcAft>
+                <a:spcPts val="1000"/>
+              </a:spcAft>
+            </a:pPr>
+            <a:r>
+              <a:rPr sz="1100" i="0" b="0">
+                <a:solidFill>
+                  <a:srgbClr val="22222A"/>
+                </a:solidFill>
+                <a:latin typeface="Calibri"/>
+              </a:rPr>
+              <a:t>•  Eight cohorts covering 44 people are suppressed below the response floor.</a:t>
+            </a:r>
+          </a:p>
+        </p:txBody>
+      </p:sp>
+      <p:sp>
+        <p:nvSpPr>
+          <p:cNvPr id="13" name="Rectangle 12"/>
+          <p:cNvSpPr/>
+          <p:nvPr/>
+        </p:nvSpPr>
+        <p:spPr>
+          <a:xfrm>
+            <a:off x="566928" y="4892040"/>
+            <a:ext cx="11064240" cy="1234440"/>
+          </a:xfrm>
+          <a:prstGeom prst="rect">
+            <a:avLst/>
+          </a:prstGeom>
+          <a:solidFill>
+            <a:srgbClr val="F7F3FC"/>
+          </a:solidFill>
+          <a:ln>
+            <a:noFill/>
+          </a:ln>
+          <a:effectLst/>
+        </p:spPr>
+        <p:style>
+          <a:lnRef idx="1">
+            <a:schemeClr val="accent1"/>
+          </a:lnRef>
+          <a:fillRef idx="3">
+            <a:schemeClr val="accent1"/>
+          </a:fillRef>
+          <a:effectRef idx="2">
+            <a:schemeClr val="accent1"/>
+          </a:effectRef>
+          <a:fontRef idx="minor">
+            <a:schemeClr val="lt1"/>
+          </a:fontRef>
+        </p:style>
+        <p:txBody>
+          <a:bodyPr rtlCol="0" anchor="ctr"/>
+          <a:lstStyle/>
+          <a:p>
+            <a:pPr algn="ctr"/>
+          </a:p>
+        </p:txBody>
+      </p:sp>
+      <p:sp>
+        <p:nvSpPr>
+          <p:cNvPr id="14" name="TextBox 13"/>
+          <p:cNvSpPr txBox="1"/>
+          <p:nvPr/>
+        </p:nvSpPr>
+        <p:spPr>
+          <a:xfrm>
+            <a:off x="932688" y="5120640"/>
+            <a:ext cx="10332720" cy="914400"/>
+          </a:xfrm>
+          <a:prstGeom prst="rect">
+            <a:avLst/>
+          </a:prstGeom>
+          <a:noFill/>
+        </p:spPr>
+        <p:txBody>
+          <a:bodyPr wrap="square" anchor="t" lIns="0" rIns="0" tIns="0" bIns="0">
+            <a:spAutoFit/>
+          </a:bodyPr>
+          <a:lstStyle/>
+          <a:p>
+            <a:pPr algn="l">
+              <a:lnSpc>
+                <a:spcPct val="100000"/>
+              </a:lnSpc>
+              <a:spcAft>
+                <a:spcPts val="600"/>
+              </a:spcAft>
+            </a:pPr>
+            <a:r>
+              <a:rPr sz="1250" i="0" b="1">
+                <a:solidFill>
+                  <a:srgbClr val="460073"/>
+                </a:solidFill>
+                <a:latin typeface="Calibri"/>
+              </a:rPr>
+              <a:t>Why there is no individual-level version</a:t>
+            </a:r>
+          </a:p>
+          <a:p>
+            <a:pPr algn="l">
+              <a:lnSpc>
+                <a:spcPct val="118000"/>
+              </a:lnSpc>
+              <a:spcAft>
+                <a:spcPts val="0"/>
+              </a:spcAft>
+            </a:pPr>
+            <a:r>
+              <a:rPr sz="1100" i="0" b="0">
+                <a:solidFill>
+                  <a:srgbClr val="22222A"/>
+                </a:solidFill>
+                <a:latin typeface="Calibri"/>
+              </a:rPr>
+              <a:t>We built and tested one. On the four-fifths rule it returns impact ratios of 0.08 on age, 0.15 on role level and 0.08 on acquisition cohort, and its precision is 22.6% — 901 false positives against 263 true ones. Low response is concentrated in the acquisition cohorts, so at individual level the flag would substantially be measuring integration failure rather than intent. We did not ship it, and this page exists so that decision travels with the tool.</a:t>
+            </a:r>
+          </a:p>
+        </p:txBody>
+      </p:sp>
+      <p:sp>
+        <p:nvSpPr>
+          <p:cNvPr id="15" name="Rectangle 14"/>
+          <p:cNvSpPr/>
+          <p:nvPr/>
+        </p:nvSpPr>
+        <p:spPr>
+          <a:xfrm>
+            <a:off x="566928" y="6309360"/>
+            <a:ext cx="50292" cy="365760"/>
+          </a:xfrm>
+          <a:prstGeom prst="rect">
+            <a:avLst/>
+          </a:prstGeom>
+          <a:solidFill>
+            <a:srgbClr val="A100FF"/>
+          </a:solidFill>
+          <a:ln>
+            <a:noFill/>
+          </a:ln>
+          <a:effectLst/>
+        </p:spPr>
+        <p:style>
+          <a:lnRef idx="1">
+            <a:schemeClr val="accent1"/>
+          </a:lnRef>
+          <a:fillRef idx="3">
+            <a:schemeClr val="accent1"/>
+          </a:fillRef>
+          <a:effectRef idx="2">
+            <a:schemeClr val="accent1"/>
+          </a:effectRef>
+          <a:fontRef idx="minor">
+            <a:schemeClr val="lt1"/>
+          </a:fontRef>
+        </p:style>
+        <p:txBody>
+          <a:bodyPr rtlCol="0" anchor="ctr"/>
+          <a:lstStyle/>
+          <a:p>
+            <a:pPr algn="ctr"/>
+          </a:p>
+        </p:txBody>
+      </p:sp>
+      <p:sp>
+        <p:nvSpPr>
+          <p:cNvPr id="16" name="TextBox 15"/>
+          <p:cNvSpPr txBox="1"/>
+          <p:nvPr/>
+        </p:nvSpPr>
+        <p:spPr>
+          <a:xfrm>
+            <a:off x="768096" y="6309360"/>
+            <a:ext cx="10771632" cy="365760"/>
+          </a:xfrm>
+          <a:prstGeom prst="rect">
+            <a:avLst/>
+          </a:prstGeom>
+          <a:noFill/>
+        </p:spPr>
+        <p:txBody>
+          <a:bodyPr wrap="square" anchor="ctr" lIns="0" rIns="0" tIns="0" bIns="0">
+            <a:spAutoFit/>
+          </a:bodyPr>
+          <a:lstStyle/>
+          <a:p>
+            <a:pPr algn="l">
+              <a:lnSpc>
+                <a:spcPct val="116000"/>
+              </a:lnSpc>
+              <a:spcAft>
+                <a:spcPts val="0"/>
+              </a:spcAft>
+            </a:pPr>
+            <a:r>
+              <a:rPr sz="1000" i="1" b="0">
+                <a:solidFill>
+                  <a:srgbClr val="22222A"/>
+                </a:solidFill>
+                <a:latin typeface="Calibri"/>
+              </a:rPr>
+              <a:t>If a participation metric is ever used, staff should be told it exists. A survey sold as confidential and quietly re-used as a risk score costs you the instrument.</a:t>
+            </a:r>
+          </a:p>
+        </p:txBody>
+      </p:sp>
+    </p:spTree>
+  </p:cSld>
+  <p:clrMapOvr>
+    <a:masterClrMapping/>
+  </p:clrMapOvr>
+</p:sld>
+</file>
+
+<file path=ppt/slides/slide4.xml><?xml version="1.0" encoding="utf-8"?>
+<p:sld xmlns:a="http://schemas.openxmlformats.org/drawingml/2006/main" xmlns:p="http://schemas.openxmlformats.org/presentationml/2006/main" xmlns:r="http://schemas.openxmlformats.org/officeDocument/2006/relationships">
+  <p:cSld>
+    <p:spTree>
+      <p:nvGrpSpPr>
+        <p:cNvPr id="1" name=""/>
+        <p:cNvGrpSpPr/>
+        <p:nvPr/>
+      </p:nvGrpSpPr>
+      <p:grpSpPr/>
+      <p:sp>
+        <p:nvSpPr>
+          <p:cNvPr id="2" name="Rectangle 1"/>
+          <p:cNvSpPr/>
+          <p:nvPr/>
+        </p:nvSpPr>
+        <p:spPr>
+          <a:xfrm>
+            <a:off x="0" y="0"/>
+            <a:ext cx="12191695" cy="68580"/>
+          </a:xfrm>
+          <a:prstGeom prst="rect">
+            <a:avLst/>
+          </a:prstGeom>
+          <a:solidFill>
+            <a:srgbClr val="A100FF"/>
+          </a:solidFill>
+          <a:ln>
+            <a:noFill/>
+          </a:ln>
+          <a:effectLst/>
+        </p:spPr>
+        <p:style>
+          <a:lnRef idx="1">
+            <a:schemeClr val="accent1"/>
+          </a:lnRef>
+          <a:fillRef idx="3">
+            <a:schemeClr val="accent1"/>
+          </a:fillRef>
+          <a:effectRef idx="2">
+            <a:schemeClr val="accent1"/>
+          </a:effectRef>
+          <a:fontRef idx="minor">
+            <a:schemeClr val="lt1"/>
+          </a:fontRef>
+        </p:style>
+        <p:txBody>
+          <a:bodyPr rtlCol="0" anchor="ctr"/>
+          <a:lstStyle/>
+          <a:p>
+            <a:pPr algn="ctr"/>
+          </a:p>
+        </p:txBody>
+      </p:sp>
+      <p:sp>
+        <p:nvSpPr>
+          <p:cNvPr id="3" name="TextBox 2"/>
+          <p:cNvSpPr txBox="1"/>
+          <p:nvPr/>
+        </p:nvSpPr>
+        <p:spPr>
+          <a:xfrm>
+            <a:off x="566928" y="365760"/>
+            <a:ext cx="11057839" cy="219456"/>
+          </a:xfrm>
+          <a:prstGeom prst="rect">
+            <a:avLst/>
+          </a:prstGeom>
+          <a:noFill/>
+        </p:spPr>
+        <p:txBody>
+          <a:bodyPr wrap="square" anchor="t" lIns="0" rIns="0" tIns="0" bIns="0">
+            <a:spAutoFit/>
+          </a:bodyPr>
+          <a:lstStyle/>
+          <a:p>
+            <a:pPr algn="l">
+              <a:lnSpc>
+                <a:spcPct val="100000"/>
+              </a:lnSpc>
+              <a:spcAft>
+                <a:spcPts val="0"/>
+              </a:spcAft>
+            </a:pPr>
+            <a:r>
               <a:rPr sz="1050" i="0" b="1">
                 <a:solidFill>
                   <a:srgbClr val="5A5A66"/>
@@ -27771,8 +31082,8 @@
         </p:blipFill>
         <p:spPr>
           <a:xfrm>
-            <a:off x="4892040" y="2060129"/>
-            <a:ext cx="6720840" cy="3789302"/>
+            <a:off x="4892040" y="2036350"/>
+            <a:ext cx="6720840" cy="3836859"/>
           </a:xfrm>
           <a:prstGeom prst="rect">
             <a:avLst/>
@@ -28111,8 +31422,8 @@
         </p:blipFill>
         <p:spPr>
           <a:xfrm>
-            <a:off x="502920" y="1777628"/>
-            <a:ext cx="6720840" cy="3805663"/>
+            <a:off x="502920" y="1782314"/>
+            <a:ext cx="6720840" cy="3796290"/>
           </a:xfrm>
           <a:prstGeom prst="rect">
             <a:avLst/>
@@ -28844,7 +32155,7 @@
                 <a:spcPct val="118000"/>
               </a:lnSpc>
               <a:spcAft>
-                <a:spcPts val="1300"/>
+                <a:spcPts val="1100"/>
               </a:spcAft>
             </a:pPr>
             <a:r>
@@ -28935,7 +32246,7 @@
                 <a:spcPct val="118000"/>
               </a:lnSpc>
               <a:spcAft>
-                <a:spcPts val="1300"/>
+                <a:spcPts val="1100"/>
               </a:spcAft>
             </a:pPr>
             <a:r>
@@ -28954,7 +32265,7 @@
                 <a:spcPct val="118000"/>
               </a:lnSpc>
               <a:spcAft>
-                <a:spcPts val="1300"/>
+                <a:spcPts val="1100"/>
               </a:spcAft>
             </a:pPr>
             <a:r>
@@ -28983,6 +32294,52 @@
                 <a:latin typeface="Calibri"/>
               </a:rPr>
               <a:t>, two years on. Entity_A was absorbed onto the core system and is now the healthiest cohort in the company.</a:t>
+            </a:r>
+          </a:p>
+          <a:p>
+            <a:pPr algn="l">
+              <a:lnSpc>
+                <a:spcPct val="118000"/>
+              </a:lnSpc>
+              <a:spcAft>
+                <a:spcPts val="1100"/>
+              </a:spcAft>
+            </a:pPr>
+            <a:r>
+              <a:rPr sz="1300" i="0" b="1">
+                <a:solidFill>
+                  <a:srgbClr val="460073"/>
+                </a:solidFill>
+                <a:latin typeface="Calibri"/>
+              </a:rPr>
+              <a:t>It isn't department mix.</a:t>
+            </a:r>
+            <a:r>
+              <a:rPr sz="1300" i="0" b="0">
+                <a:solidFill>
+                  <a:srgbClr val="22222A"/>
+                </a:solidFill>
+                <a:latin typeface="Calibri"/>
+              </a:rPr>
+              <a:t> Controlling for department, role level, pay and potential, Entity_B still leaves at </a:t>
+            </a:r>
+            <a:r>
+              <a:rPr sz="1300" i="0" b="1">
+                <a:solidFill>
+                  <a:srgbClr val="460073"/>
+                </a:solidFill>
+                <a:latin typeface="Calibri"/>
+              </a:rPr>
+              <a:t>1.95×</a:t>
+            </a:r>
+            <a:r>
+              <a:rPr sz="1300" i="0" b="0">
+                <a:solidFill>
+                  <a:srgbClr val="22222A"/>
+                </a:solidFill>
+                <a:latin typeface="Calibri"/>
+              </a:rPr>
+              <a:t> Entity_A (appendix A15).</a:t>
             </a:r>
           </a:p>
         </p:txBody>
@@ -29003,8 +32360,8 @@
         </p:blipFill>
         <p:spPr>
           <a:xfrm>
-            <a:off x="5061843" y="1783080"/>
-            <a:ext cx="6381234" cy="4206240"/>
+            <a:off x="5077215" y="1783080"/>
+            <a:ext cx="6350490" cy="4206240"/>
           </a:xfrm>
           <a:prstGeom prst="rect">
             <a:avLst/>
@@ -29559,8 +32916,8 @@
         </p:blipFill>
         <p:spPr>
           <a:xfrm>
-            <a:off x="4892040" y="1877424"/>
-            <a:ext cx="6720840" cy="3880392"/>
+            <a:off x="4892040" y="1877000"/>
+            <a:ext cx="6720840" cy="3881239"/>
           </a:xfrm>
           <a:prstGeom prst="rect">
             <a:avLst/>
@@ -29899,8 +33256,8 @@
         </p:blipFill>
         <p:spPr>
           <a:xfrm>
-            <a:off x="2836199" y="1572768"/>
-            <a:ext cx="6489122" cy="3310128"/>
+            <a:off x="2836765" y="1572768"/>
+            <a:ext cx="6487990" cy="3310128"/>
           </a:xfrm>
           <a:prstGeom prst="rect">
             <a:avLst/>
@@ -30508,8 +33865,8 @@
         </p:blipFill>
         <p:spPr>
           <a:xfrm>
-            <a:off x="4892040" y="1985868"/>
-            <a:ext cx="6720839" cy="3709223"/>
+            <a:off x="4892040" y="1989879"/>
+            <a:ext cx="6720840" cy="3701201"/>
           </a:xfrm>
           <a:prstGeom prst="rect">
             <a:avLst/>

</xml_diff>

<commit_message>
fix(a16): anchor milestones to survey waves after checking actual cadence
</commit_message>
<xml_diff>
--- a/deck/NovaCorp_deck.pptx
+++ b/deck/NovaCorp_deck.pptx
@@ -28399,7 +28399,7 @@
                 </a:solidFill>
                 <a:latin typeface="Calibri"/>
               </a:rPr>
-              <a:t>The first 90 days, and what to measure</a:t>
+              <a:t>What to measure, and when you can actually read it</a:t>
             </a:r>
           </a:p>
         </p:txBody>
@@ -28441,7 +28441,7 @@
                 </a:solidFill>
                 <a:latin typeface="Calibri"/>
               </a:rPr>
-              <a:t>Slide 9 says Entity_A sets the success measure. This is that measure, stated so it can go in front of a board.</a:t>
+              <a:t>Slide 9 says Entity_A sets the success measure. This is that measure, stated so it can go in front of a board — and paced to the survey cadence NovaCorp actually runs.</a:t>
             </a:r>
           </a:p>
         </p:txBody>
@@ -28483,7 +28483,7 @@
                 </a:solidFill>
                 <a:latin typeface="Calibri"/>
               </a:rPr>
-              <a:t>Baselines are the current figures from cost_model.py. Targets are Entity_A's present position, not a generic benchmark, because Entity_A reached them inside this company with this workforce.</a:t>
+              <a:t>Baselines from cost_model.py. Targets are Entity_A's present position.</a:t>
             </a:r>
           </a:p>
         </p:txBody>
@@ -28638,7 +28638,7 @@
                           </a:solidFill>
                           <a:latin typeface="Calibri"/>
                         </a:rPr>
-                        <a:t>Review</a:t>
+                        <a:t>First readable</a:t>
                       </a:r>
                     </a:p>
                   </a:txBody>
@@ -28755,7 +28755,7 @@
                           </a:solidFill>
                           <a:latin typeface="Calibri"/>
                         </a:rPr>
-                        <a:t>Every wave</a:t>
+                        <a:t>Next wave</a:t>
                       </a:r>
                     </a:p>
                   </a:txBody>
@@ -28872,7 +28872,7 @@
                           </a:solidFill>
                           <a:latin typeface="Calibri"/>
                         </a:rPr>
-                        <a:t>Every wave</a:t>
+                        <a:t>Next wave</a:t>
                       </a:r>
                     </a:p>
                   </a:txBody>
@@ -28989,7 +28989,7 @@
                           </a:solidFill>
                           <a:latin typeface="Calibri"/>
                         </a:rPr>
-                        <a:t>Every wave</a:t>
+                        <a:t>Next wave</a:t>
                       </a:r>
                     </a:p>
                   </a:txBody>
@@ -29037,7 +29037,7 @@
                           </a:solidFill>
                           <a:latin typeface="Calibri"/>
                         </a:rPr>
-                        <a:t>Senior Manager (L3) attrition</a:t>
+                        <a:t>Employees never surveyed</a:t>
                       </a:r>
                     </a:p>
                   </a:txBody>
@@ -29060,7 +29060,7 @@
                           </a:solidFill>
                           <a:latin typeface="Calibri"/>
                         </a:rPr>
-                        <a:t>9.8%/yr</a:t>
+                        <a:t>152 on B and C systems</a:t>
                       </a:r>
                     </a:p>
                   </a:txBody>
@@ -29083,7 +29083,7 @@
                           </a:solidFill>
                           <a:latin typeface="Calibri"/>
                         </a:rPr>
-                        <a:t>2.9%/yr</a:t>
+                        <a:t>0</a:t>
                       </a:r>
                     </a:p>
                   </a:txBody>
@@ -29106,7 +29106,7 @@
                           </a:solidFill>
                           <a:latin typeface="Calibri"/>
                         </a:rPr>
-                        <a:t>Quarterly</a:t>
+                        <a:t>Next wave</a:t>
                       </a:r>
                     </a:p>
                   </a:txBody>
@@ -29129,7 +29129,7 @@
                           </a:solidFill>
                           <a:latin typeface="Calibri"/>
                         </a:rPr>
-                        <a:t>The layer that has to carry the integration message.</a:t>
+                        <a:t>You cannot manage a cohort you are not asking. Fixable before the wave issues.</a:t>
                       </a:r>
                     </a:p>
                   </a:txBody>
@@ -29154,7 +29154,7 @@
                           </a:solidFill>
                           <a:latin typeface="Calibri"/>
                         </a:rPr>
-                        <a:t>Voluntary attrition</a:t>
+                        <a:t>Senior Manager (L3) attrition</a:t>
                       </a:r>
                     </a:p>
                   </a:txBody>
@@ -29177,7 +29177,7 @@
                           </a:solidFill>
                           <a:latin typeface="Calibri"/>
                         </a:rPr>
-                        <a:t>7.0%/yr</a:t>
+                        <a:t>9.8%/yr</a:t>
                       </a:r>
                     </a:p>
                   </a:txBody>
@@ -29200,7 +29200,7 @@
                           </a:solidFill>
                           <a:latin typeface="Calibri"/>
                         </a:rPr>
-                        <a:t>3.6%/yr</a:t>
+                        <a:t>2.9%/yr</a:t>
                       </a:r>
                     </a:p>
                   </a:txBody>
@@ -29223,7 +29223,7 @@
                           </a:solidFill>
                           <a:latin typeface="Calibri"/>
                         </a:rPr>
-                        <a:t>Quarterly</a:t>
+                        <a:t>2 quarters</a:t>
                       </a:r>
                     </a:p>
                   </a:txBody>
@@ -29246,7 +29246,7 @@
                           </a:solidFill>
                           <a:latin typeface="Calibri"/>
                         </a:rPr>
-                        <a:t>The outcome. Moves last, so do not judge the programme on it early.</a:t>
+                        <a:t>The layer that has to carry the integration message.</a:t>
                       </a:r>
                     </a:p>
                   </a:txBody>
@@ -29271,7 +29271,7 @@
                           </a:solidFill>
                           <a:latin typeface="Calibri"/>
                         </a:rPr>
-                        <a:t>Employees never surveyed</a:t>
+                        <a:t>Voluntary attrition</a:t>
                       </a:r>
                     </a:p>
                   </a:txBody>
@@ -29294,7 +29294,7 @@
                           </a:solidFill>
                           <a:latin typeface="Calibri"/>
                         </a:rPr>
-                        <a:t>152 on B and C systems</a:t>
+                        <a:t>7.0%/yr</a:t>
                       </a:r>
                     </a:p>
                   </a:txBody>
@@ -29317,7 +29317,7 @@
                           </a:solidFill>
                           <a:latin typeface="Calibri"/>
                         </a:rPr>
-                        <a:t>0</a:t>
+                        <a:t>3.6%/yr</a:t>
                       </a:r>
                     </a:p>
                   </a:txBody>
@@ -29340,7 +29340,7 @@
                           </a:solidFill>
                           <a:latin typeface="Calibri"/>
                         </a:rPr>
-                        <a:t>Every wave</a:t>
+                        <a:t>3–4 quarters</a:t>
                       </a:r>
                     </a:p>
                   </a:txBody>
@@ -29363,7 +29363,7 @@
                           </a:solidFill>
                           <a:latin typeface="Calibri"/>
                         </a:rPr>
-                        <a:t>You cannot manage a cohort you are not asking.</a:t>
+                        <a:t>The outcome. Moves last, so do not judge the programme on it early.</a:t>
                       </a:r>
                     </a:p>
                   </a:txBody>
@@ -29386,7 +29386,7 @@
         </p:nvSpPr>
         <p:spPr>
           <a:xfrm>
-            <a:off x="566928" y="4892040"/>
+            <a:off x="566928" y="4846320"/>
             <a:ext cx="3538728" cy="45720"/>
           </a:xfrm>
           <a:prstGeom prst="rect">
@@ -29430,7 +29430,7 @@
         </p:nvSpPr>
         <p:spPr>
           <a:xfrm>
-            <a:off x="566928" y="5065776"/>
+            <a:off x="566928" y="5020056"/>
             <a:ext cx="3538728" cy="256032"/>
           </a:xfrm>
           <a:prstGeom prst="rect">
@@ -29459,7 +29459,7 @@
                 </a:solidFill>
                 <a:latin typeface="Calibri"/>
               </a:rPr>
-              <a:t>BY DAY 30</a:t>
+              <a:t>BEFORE THE NEXT WAVE</a:t>
             </a:r>
           </a:p>
           <a:p>
@@ -29472,13 +29472,13 @@
               </a:spcAft>
             </a:pPr>
             <a:r>
-              <a:rPr sz="1100" i="0" b="0">
+              <a:rPr sz="1050" i="0" b="0">
                 <a:solidFill>
                   <a:srgbClr val="22222A"/>
                 </a:solidFill>
                 <a:latin typeface="Calibri"/>
               </a:rPr>
-              <a:t>Regrettable flag redefined to include High Performer, and separated from the function that approves exits. Baseline restated. Costs about $0 and needs no programme.</a:t>
+              <a:t>Redefine the regrettable flag, separate it from the function that approves exits, restate the baseline, and add the 152 unsurveyed staff to the issue list. All policy, all ~$0.</a:t>
             </a:r>
           </a:p>
         </p:txBody>
@@ -29491,7 +29491,7 @@
         </p:nvSpPr>
         <p:spPr>
           <a:xfrm>
-            <a:off x="4325112" y="4892040"/>
+            <a:off x="4325112" y="4846320"/>
             <a:ext cx="3538728" cy="45720"/>
           </a:xfrm>
           <a:prstGeom prst="rect">
@@ -29535,7 +29535,7 @@
         </p:nvSpPr>
         <p:spPr>
           <a:xfrm>
-            <a:off x="4325112" y="5065776"/>
+            <a:off x="4325112" y="5020056"/>
             <a:ext cx="3538728" cy="256032"/>
           </a:xfrm>
           <a:prstGeom prst="rect">
@@ -29564,7 +29564,7 @@
                 </a:solidFill>
                 <a:latin typeface="Calibri"/>
               </a:rPr>
-              <a:t>BY DAY 60</a:t>
+              <a:t>AT THE NEXT WAVE</a:t>
             </a:r>
           </a:p>
           <a:p>
@@ -29577,13 +29577,13 @@
               </a:spcAft>
             </a:pPr>
             <a:r>
-              <a:rPr sz="1100" i="0" b="0">
+              <a:rPr sz="1050" i="0" b="0">
                 <a:solidFill>
                   <a:srgbClr val="22222A"/>
                 </a:solidFill>
                 <a:latin typeface="Calibri"/>
               </a:rPr>
-              <a:t>Entity_B migration off BambooHR scheduled with a date. Senior Manager retention conversations complete. All 152 unsurveyed staff issued the next wave.</a:t>
+              <a:t>The first real read. Response rate and the two collapsed dimensions, against Entity_A's trajectory rather than Entity_B's own past. Attrition will not have moved.</a:t>
             </a:r>
           </a:p>
         </p:txBody>
@@ -29596,7 +29596,7 @@
         </p:nvSpPr>
         <p:spPr>
           <a:xfrm>
-            <a:off x="8083296" y="4892040"/>
+            <a:off x="8083296" y="4846320"/>
             <a:ext cx="3538728" cy="45720"/>
           </a:xfrm>
           <a:prstGeom prst="rect">
@@ -29640,7 +29640,7 @@
         </p:nvSpPr>
         <p:spPr>
           <a:xfrm>
-            <a:off x="8083296" y="5065776"/>
+            <a:off x="8083296" y="5020056"/>
             <a:ext cx="3538728" cy="256032"/>
           </a:xfrm>
           <a:prstGeom prst="rect">
@@ -29669,7 +29669,7 @@
                 </a:solidFill>
                 <a:latin typeface="Calibri"/>
               </a:rPr>
-              <a:t>BY DAY 90</a:t>
+              <a:t>THE WAVE AFTER</a:t>
             </a:r>
           </a:p>
           <a:p>
@@ -29682,13 +29682,13 @@
               </a:spcAft>
             </a:pPr>
             <a:r>
-              <a:rPr sz="1100" i="0" b="0">
+              <a:rPr sz="1050" i="0" b="0">
                 <a:solidFill>
                   <a:srgbClr val="22222A"/>
                 </a:solidFill>
                 <a:latin typeface="Calibri"/>
               </a:rPr>
-              <a:t>First post-intervention wave read against Entity_A's trajectory, not against Entity_B's own past. Response rate is the number to watch; attrition will not have moved yet.</a:t>
+              <a:t>Confirm direction rather than declare success. Two consecutive wave-on-wave improvements in response rate is the earliest defensible signal.</a:t>
             </a:r>
           </a:p>
         </p:txBody>
@@ -29701,8 +29701,8 @@
         </p:nvSpPr>
         <p:spPr>
           <a:xfrm>
-            <a:off x="566928" y="5943600"/>
-            <a:ext cx="50292" cy="347472"/>
+            <a:off x="566928" y="5961888"/>
+            <a:ext cx="50292" cy="402336"/>
           </a:xfrm>
           <a:prstGeom prst="rect">
             <a:avLst/>
@@ -29745,8 +29745,8 @@
         </p:nvSpPr>
         <p:spPr>
           <a:xfrm>
-            <a:off x="768096" y="5943600"/>
-            <a:ext cx="10771632" cy="347472"/>
+            <a:off x="768096" y="5961888"/>
+            <a:ext cx="10771632" cy="402336"/>
           </a:xfrm>
           <a:prstGeom prst="rect">
             <a:avLst/>
@@ -29774,7 +29774,7 @@
                 </a:solidFill>
                 <a:latin typeface="Calibri"/>
               </a:rPr>
-              <a:t>Judge the programme on response rate and trust at 90 days. Attrition is a lagging measure and will not have moved.</a:t>
+              <a:t>Anchored to waves, not days: NovaCorp's ran 122, 92, 123 and 181 days apart, mean 4.2 months and widening. A 90-day plan would promise a reading the cadence cannot deliver — and a leading indicator read twice a year is not a leading indicator.</a:t>
             </a:r>
           </a:p>
         </p:txBody>

</xml_diff>

<commit_message>
docs: fill in repo readme
</commit_message>
<xml_diff>
--- a/deck/NovaCorp_deck.pptx
+++ b/deck/NovaCorp_deck.pptx
@@ -40,6 +40,8 @@
     <p:sldId id="288" r:id="rId39"/>
     <p:sldId id="289" r:id="rId40"/>
     <p:sldId id="290" r:id="rId41"/>
+    <p:sldId id="291" r:id="rId42"/>
+    <p:sldId id="292" r:id="rId43"/>
   </p:sldIdLst>
   <p:sldSz cx="12191695" cy="6858000" type="screen4x3"/>
   <p:notesSz cx="6858000" cy="9144000"/>
@@ -6763,7 +6765,7 @@
                 </a:solidFill>
                 <a:latin typeface="Calibri"/>
               </a:rPr>
-              <a:t>The limits of this analysis, stated before you ask.</a:t>
+              <a:t>Seven limits on what this analysis can support.</a:t>
             </a:r>
           </a:p>
         </p:txBody>
@@ -6984,34 +6986,6 @@
               <a:t>, and leavers responded less, so every disengagement figure is a lower bound.</a:t>
             </a:r>
           </a:p>
-          <a:p>
-            <a:pPr algn="l">
-              <a:lnSpc>
-                <a:spcPct val="118000"/>
-              </a:lnSpc>
-              <a:spcAft>
-                <a:spcPts val="1300"/>
-              </a:spcAft>
-            </a:pPr>
-            <a:r>
-              <a:rPr sz="1150" i="0" b="1">
-                <a:solidFill>
-                  <a:srgbClr val="460073"/>
-                </a:solidFill>
-                <a:latin typeface="Calibri"/>
-              </a:rPr>
-              <a:t>Association, not causation.</a:t>
-            </a:r>
-            <a:r>
-              <a:rPr sz="1150" i="0" b="0">
-                <a:solidFill>
-                  <a:srgbClr val="22222A"/>
-                </a:solidFill>
-                <a:latin typeface="Calibri"/>
-              </a:rPr>
-              <a:t> Senior Manager churn and collapsed trust move together. We cannot say which drives which.</a:t>
-            </a:r>
-          </a:p>
         </p:txBody>
       </p:sp>
       <p:sp>
@@ -7035,6 +7009,34 @@
             <a:spAutoFit/>
           </a:bodyPr>
           <a:lstStyle/>
+          <a:p>
+            <a:pPr algn="l">
+              <a:lnSpc>
+                <a:spcPct val="118000"/>
+              </a:lnSpc>
+              <a:spcAft>
+                <a:spcPts val="1300"/>
+              </a:spcAft>
+            </a:pPr>
+            <a:r>
+              <a:rPr sz="1150" i="0" b="1">
+                <a:solidFill>
+                  <a:srgbClr val="460073"/>
+                </a:solidFill>
+                <a:latin typeface="Calibri"/>
+              </a:rPr>
+              <a:t>Association, not causation.</a:t>
+            </a:r>
+            <a:r>
+              <a:rPr sz="1150" i="0" b="0">
+                <a:solidFill>
+                  <a:srgbClr val="22222A"/>
+                </a:solidFill>
+                <a:latin typeface="Calibri"/>
+              </a:rPr>
+              <a:t> Senior Manager churn and collapsed trust move together. We cannot say which drives which.</a:t>
+            </a:r>
+          </a:p>
           <a:p>
             <a:pPr algn="l">
               <a:lnSpc>
@@ -13809,7 +13811,7 @@
                 </a:solidFill>
                 <a:latin typeface="Calibri"/>
               </a:rPr>
-              <a:t>Documenting what we verified and found sound matters as much as what we found broken.</a:t>
+              <a:t>Nine integrity checks across the four files, and what each returned.</a:t>
             </a:r>
           </a:p>
         </p:txBody>
@@ -29962,7 +29964,7 @@
                 </a:solidFill>
                 <a:latin typeface="Calibri"/>
               </a:rPr>
-              <a:t>The accompanying dashboard is a model, so it gets a model card. Intended use, prohibited use, and known limits, stated up front rather than discovered later.</a:t>
+              <a:t>Intended use, prohibited use, and known limits for the accompanying dashboard.</a:t>
             </a:r>
           </a:p>
         </p:txBody>
@@ -30557,7 +30559,7 @@
                 </a:solidFill>
                 <a:latin typeface="Calibri"/>
               </a:rPr>
-              <a:t>We built and tested one. On the four-fifths rule it returns impact ratios of 0.08 on age, 0.15 on role level and 0.08 on acquisition cohort, and its precision is 22.6% — 901 false positives against 263 true ones. Low response is concentrated in the acquisition cohorts, so at individual level the flag would substantially be measuring integration failure rather than intent. We did not ship it, and this page exists so that decision travels with the tool.</a:t>
+              <a:t>We built and tested one. On the four-fifths rule it returns impact ratios of 0.08 on age, 0.15 on role level and 0.08 on acquisition cohort, and its precision is 22.6% — 901 false positives against 263 true ones. Low response is concentrated in the acquisition cohorts, so at individual level the flag would substantially be measuring integration failure rather than intent, so we did not ship it.</a:t>
             </a:r>
           </a:p>
         </p:txBody>
@@ -30644,6 +30646,1726 @@
                 <a:latin typeface="Calibri"/>
               </a:rPr>
               <a:t>If a participation metric is ever used, staff should be told it exists. A survey sold as confidential and quietly re-used as a risk score costs you the instrument.</a:t>
+            </a:r>
+          </a:p>
+        </p:txBody>
+      </p:sp>
+    </p:spTree>
+  </p:cSld>
+  <p:clrMapOvr>
+    <a:masterClrMapping/>
+  </p:clrMapOvr>
+</p:sld>
+</file>
+
+<file path=ppt/slides/slide36.xml><?xml version="1.0" encoding="utf-8"?>
+<p:sld xmlns:a="http://schemas.openxmlformats.org/drawingml/2006/main" xmlns:p="http://schemas.openxmlformats.org/presentationml/2006/main" xmlns:r="http://schemas.openxmlformats.org/officeDocument/2006/relationships">
+  <p:cSld>
+    <p:spTree>
+      <p:nvGrpSpPr>
+        <p:cNvPr id="1" name=""/>
+        <p:cNvGrpSpPr/>
+        <p:nvPr/>
+      </p:nvGrpSpPr>
+      <p:grpSpPr/>
+      <p:sp>
+        <p:nvSpPr>
+          <p:cNvPr id="2" name="Rectangle 1"/>
+          <p:cNvSpPr/>
+          <p:nvPr/>
+        </p:nvSpPr>
+        <p:spPr>
+          <a:xfrm>
+            <a:off x="0" y="0"/>
+            <a:ext cx="12191695" cy="68580"/>
+          </a:xfrm>
+          <a:prstGeom prst="rect">
+            <a:avLst/>
+          </a:prstGeom>
+          <a:solidFill>
+            <a:srgbClr val="5A5A66"/>
+          </a:solidFill>
+          <a:ln>
+            <a:noFill/>
+          </a:ln>
+          <a:effectLst/>
+        </p:spPr>
+        <p:style>
+          <a:lnRef idx="1">
+            <a:schemeClr val="accent1"/>
+          </a:lnRef>
+          <a:fillRef idx="3">
+            <a:schemeClr val="accent1"/>
+          </a:fillRef>
+          <a:effectRef idx="2">
+            <a:schemeClr val="accent1"/>
+          </a:effectRef>
+          <a:fontRef idx="minor">
+            <a:schemeClr val="lt1"/>
+          </a:fontRef>
+        </p:style>
+        <p:txBody>
+          <a:bodyPr rtlCol="0" anchor="ctr"/>
+          <a:lstStyle/>
+          <a:p>
+            <a:pPr algn="ctr"/>
+          </a:p>
+        </p:txBody>
+      </p:sp>
+      <p:sp>
+        <p:nvSpPr>
+          <p:cNvPr id="3" name="TextBox 2"/>
+          <p:cNvSpPr txBox="1"/>
+          <p:nvPr/>
+        </p:nvSpPr>
+        <p:spPr>
+          <a:xfrm>
+            <a:off x="566928" y="347472"/>
+            <a:ext cx="11057839" cy="237744"/>
+          </a:xfrm>
+          <a:prstGeom prst="rect">
+            <a:avLst/>
+          </a:prstGeom>
+          <a:noFill/>
+        </p:spPr>
+        <p:txBody>
+          <a:bodyPr wrap="square" anchor="t" lIns="0" rIns="0" tIns="0" bIns="0">
+            <a:spAutoFit/>
+          </a:bodyPr>
+          <a:lstStyle/>
+          <a:p>
+            <a:pPr algn="l">
+              <a:lnSpc>
+                <a:spcPct val="100000"/>
+              </a:lnSpc>
+              <a:spcAft>
+                <a:spcPts val="0"/>
+              </a:spcAft>
+            </a:pPr>
+            <a:r>
+              <a:rPr sz="1100" i="0" b="1">
+                <a:solidFill>
+                  <a:srgbClr val="A100FF"/>
+                </a:solidFill>
+                <a:latin typeface="Calibri"/>
+              </a:rPr>
+              <a:t>APPENDIX A18</a:t>
+            </a:r>
+          </a:p>
+        </p:txBody>
+      </p:sp>
+      <p:sp>
+        <p:nvSpPr>
+          <p:cNvPr id="4" name="TextBox 3"/>
+          <p:cNvSpPr txBox="1"/>
+          <p:nvPr/>
+        </p:nvSpPr>
+        <p:spPr>
+          <a:xfrm>
+            <a:off x="566928" y="621792"/>
+            <a:ext cx="11057839" cy="457200"/>
+          </a:xfrm>
+          <a:prstGeom prst="rect">
+            <a:avLst/>
+          </a:prstGeom>
+          <a:noFill/>
+        </p:spPr>
+        <p:txBody>
+          <a:bodyPr wrap="square" anchor="t" lIns="0" rIns="0" tIns="0" bIns="0">
+            <a:spAutoFit/>
+          </a:bodyPr>
+          <a:lstStyle/>
+          <a:p>
+            <a:pPr algn="l">
+              <a:lnSpc>
+                <a:spcPct val="100000"/>
+              </a:lnSpc>
+              <a:spcAft>
+                <a:spcPts val="0"/>
+              </a:spcAft>
+            </a:pPr>
+            <a:r>
+              <a:rPr sz="2300" i="0" b="1">
+                <a:solidFill>
+                  <a:srgbClr val="460073"/>
+                </a:solidFill>
+                <a:latin typeface="Calibri"/>
+              </a:rPr>
+              <a:t>Questions we expect — the number</a:t>
+            </a:r>
+          </a:p>
+        </p:txBody>
+      </p:sp>
+      <p:sp>
+        <p:nvSpPr>
+          <p:cNvPr id="5" name="TextBox 4"/>
+          <p:cNvSpPr txBox="1"/>
+          <p:nvPr/>
+        </p:nvSpPr>
+        <p:spPr>
+          <a:xfrm>
+            <a:off x="566928" y="1051560"/>
+            <a:ext cx="10607040" cy="384048"/>
+          </a:xfrm>
+          <a:prstGeom prst="rect">
+            <a:avLst/>
+          </a:prstGeom>
+          <a:noFill/>
+        </p:spPr>
+        <p:txBody>
+          <a:bodyPr wrap="square" anchor="t" lIns="0" rIns="0" tIns="0" bIns="0">
+            <a:spAutoFit/>
+          </a:bodyPr>
+          <a:lstStyle/>
+          <a:p>
+            <a:pPr algn="l">
+              <a:lnSpc>
+                <a:spcPct val="115000"/>
+              </a:lnSpc>
+              <a:spcAft>
+                <a:spcPts val="0"/>
+              </a:spcAft>
+            </a:pPr>
+            <a:r>
+              <a:rPr sz="1150" i="1" b="0">
+                <a:solidFill>
+                  <a:srgbClr val="5A5A66"/>
+                </a:solidFill>
+                <a:latin typeface="Calibri"/>
+              </a:rPr>
+              <a:t>Prepared answers, with the page that backs each one. Anyone on the team can present from this.</a:t>
+            </a:r>
+          </a:p>
+        </p:txBody>
+      </p:sp>
+      <p:sp>
+        <p:nvSpPr>
+          <p:cNvPr id="6" name="TextBox 5"/>
+          <p:cNvSpPr txBox="1"/>
+          <p:nvPr/>
+        </p:nvSpPr>
+        <p:spPr>
+          <a:xfrm>
+            <a:off x="10893247" y="6355080"/>
+            <a:ext cx="731520" cy="228600"/>
+          </a:xfrm>
+          <a:prstGeom prst="rect">
+            <a:avLst/>
+          </a:prstGeom>
+          <a:noFill/>
+        </p:spPr>
+        <p:txBody>
+          <a:bodyPr wrap="square" anchor="t" lIns="0" rIns="0" tIns="0" bIns="0">
+            <a:spAutoFit/>
+          </a:bodyPr>
+          <a:lstStyle/>
+          <a:p>
+            <a:pPr algn="r">
+              <a:lnSpc>
+                <a:spcPct val="100000"/>
+              </a:lnSpc>
+              <a:spcAft>
+                <a:spcPts val="0"/>
+              </a:spcAft>
+            </a:pPr>
+            <a:r>
+              <a:rPr sz="1000" i="0" b="1">
+                <a:solidFill>
+                  <a:srgbClr val="5A5A66"/>
+                </a:solidFill>
+                <a:latin typeface="Calibri"/>
+              </a:rPr>
+              <a:t>A18</a:t>
+            </a:r>
+          </a:p>
+        </p:txBody>
+      </p:sp>
+      <p:sp>
+        <p:nvSpPr>
+          <p:cNvPr id="7" name="TextBox 6"/>
+          <p:cNvSpPr txBox="1"/>
+          <p:nvPr/>
+        </p:nvSpPr>
+        <p:spPr>
+          <a:xfrm>
+            <a:off x="566928" y="1572768"/>
+            <a:ext cx="10881360" cy="256032"/>
+          </a:xfrm>
+          <a:prstGeom prst="rect">
+            <a:avLst/>
+          </a:prstGeom>
+          <a:noFill/>
+        </p:spPr>
+        <p:txBody>
+          <a:bodyPr wrap="square" anchor="t" lIns="0" rIns="0" tIns="0" bIns="0">
+            <a:spAutoFit/>
+          </a:bodyPr>
+          <a:lstStyle/>
+          <a:p>
+            <a:pPr algn="l">
+              <a:lnSpc>
+                <a:spcPct val="100000"/>
+              </a:lnSpc>
+              <a:spcAft>
+                <a:spcPts val="400"/>
+              </a:spcAft>
+            </a:pPr>
+            <a:r>
+              <a:rPr sz="1250" i="0" b="1">
+                <a:solidFill>
+                  <a:srgbClr val="460073"/>
+                </a:solidFill>
+                <a:latin typeface="Calibri"/>
+              </a:rPr>
+              <a:t>“Your number is double Finance's. Which is right?”</a:t>
+            </a:r>
+          </a:p>
+        </p:txBody>
+      </p:sp>
+      <p:sp>
+        <p:nvSpPr>
+          <p:cNvPr id="8" name="TextBox 7"/>
+          <p:cNvSpPr txBox="1"/>
+          <p:nvPr/>
+        </p:nvSpPr>
+        <p:spPr>
+          <a:xfrm>
+            <a:off x="566928" y="1847088"/>
+            <a:ext cx="9418320" cy="566928"/>
+          </a:xfrm>
+          <a:prstGeom prst="rect">
+            <a:avLst/>
+          </a:prstGeom>
+          <a:noFill/>
+        </p:spPr>
+        <p:txBody>
+          <a:bodyPr wrap="square" anchor="t" lIns="0" rIns="0" tIns="0" bIns="0">
+            <a:spAutoFit/>
+          </a:bodyPr>
+          <a:lstStyle/>
+          <a:p>
+            <a:pPr algn="l">
+              <a:lnSpc>
+                <a:spcPct val="118000"/>
+              </a:lnSpc>
+              <a:spcAft>
+                <a:spcPts val="0"/>
+              </a:spcAft>
+            </a:pPr>
+            <a:r>
+              <a:rPr sz="1100" i="0" b="0">
+                <a:solidFill>
+                  <a:srgbClr val="22222A"/>
+                </a:solidFill>
+                <a:latin typeface="Calibri"/>
+              </a:rPr>
+              <a:t>Both, for different questions. Finance priced the departures HR flagged. We priced the departures that cost you money. The gap is the finding, not a disagreement about arithmetic — we used their formula and their constants.</a:t>
+            </a:r>
+          </a:p>
+        </p:txBody>
+      </p:sp>
+      <p:sp>
+        <p:nvSpPr>
+          <p:cNvPr id="9" name="TextBox 8"/>
+          <p:cNvSpPr txBox="1"/>
+          <p:nvPr/>
+        </p:nvSpPr>
+        <p:spPr>
+          <a:xfrm>
+            <a:off x="10149840" y="1847088"/>
+            <a:ext cx="1463040" cy="274320"/>
+          </a:xfrm>
+          <a:prstGeom prst="rect">
+            <a:avLst/>
+          </a:prstGeom>
+          <a:noFill/>
+        </p:spPr>
+        <p:txBody>
+          <a:bodyPr wrap="square" anchor="t" lIns="0" rIns="0" tIns="0" bIns="0">
+            <a:spAutoFit/>
+          </a:bodyPr>
+          <a:lstStyle/>
+          <a:p>
+            <a:pPr algn="r">
+              <a:lnSpc>
+                <a:spcPct val="100000"/>
+              </a:lnSpc>
+              <a:spcAft>
+                <a:spcPts val="0"/>
+              </a:spcAft>
+            </a:pPr>
+            <a:r>
+              <a:rPr sz="950" i="0" b="1">
+                <a:solidFill>
+                  <a:srgbClr val="A100FF"/>
+                </a:solidFill>
+                <a:latin typeface="Calibri"/>
+              </a:rPr>
+              <a:t>Slides 3–5</a:t>
+            </a:r>
+          </a:p>
+        </p:txBody>
+      </p:sp>
+      <p:sp>
+        <p:nvSpPr>
+          <p:cNvPr id="10" name="TextBox 9"/>
+          <p:cNvSpPr txBox="1"/>
+          <p:nvPr/>
+        </p:nvSpPr>
+        <p:spPr>
+          <a:xfrm>
+            <a:off x="566928" y="2532888"/>
+            <a:ext cx="10881360" cy="256032"/>
+          </a:xfrm>
+          <a:prstGeom prst="rect">
+            <a:avLst/>
+          </a:prstGeom>
+          <a:noFill/>
+        </p:spPr>
+        <p:txBody>
+          <a:bodyPr wrap="square" anchor="t" lIns="0" rIns="0" tIns="0" bIns="0">
+            <a:spAutoFit/>
+          </a:bodyPr>
+          <a:lstStyle/>
+          <a:p>
+            <a:pPr algn="l">
+              <a:lnSpc>
+                <a:spcPct val="100000"/>
+              </a:lnSpc>
+              <a:spcAft>
+                <a:spcPts val="400"/>
+              </a:spcAft>
+            </a:pPr>
+            <a:r>
+              <a:rPr sz="1250" i="0" b="1">
+                <a:solidFill>
+                  <a:srgbClr val="460073"/>
+                </a:solidFill>
+                <a:latin typeface="Calibri"/>
+              </a:rPr>
+              <a:t>“Your buckets total $65M, not $42M. Haven't you just inflated the problem?”</a:t>
+            </a:r>
+          </a:p>
+        </p:txBody>
+      </p:sp>
+      <p:sp>
+        <p:nvSpPr>
+          <p:cNvPr id="11" name="TextBox 10"/>
+          <p:cNvSpPr txBox="1"/>
+          <p:nvPr/>
+        </p:nvSpPr>
+        <p:spPr>
+          <a:xfrm>
+            <a:off x="566928" y="2807208"/>
+            <a:ext cx="9418320" cy="566928"/>
+          </a:xfrm>
+          <a:prstGeom prst="rect">
+            <a:avLst/>
+          </a:prstGeom>
+          <a:noFill/>
+        </p:spPr>
+        <p:txBody>
+          <a:bodyPr wrap="square" anchor="t" lIns="0" rIns="0" tIns="0" bIns="0">
+            <a:spAutoFit/>
+          </a:bodyPr>
+          <a:lstStyle/>
+          <a:p>
+            <a:pPr algn="l">
+              <a:lnSpc>
+                <a:spcPct val="118000"/>
+              </a:lnSpc>
+              <a:spcAft>
+                <a:spcPts val="0"/>
+              </a:spcAft>
+            </a:pPr>
+            <a:r>
+              <a:rPr sz="1100" i="0" b="0">
+                <a:solidFill>
+                  <a:srgbClr val="22222A"/>
+                </a:solidFill>
+                <a:latin typeface="Calibri"/>
+              </a:rPr>
+              <a:t>Two of the three moved against you and one moved in your favour, and we show all three. The hiring bucket you were most worried about is the smallest thing here at $2.3M against Finance's $4–6M. If we were inflating, that is the number we would have left alone.</a:t>
+            </a:r>
+          </a:p>
+        </p:txBody>
+      </p:sp>
+      <p:sp>
+        <p:nvSpPr>
+          <p:cNvPr id="12" name="TextBox 11"/>
+          <p:cNvSpPr txBox="1"/>
+          <p:nvPr/>
+        </p:nvSpPr>
+        <p:spPr>
+          <a:xfrm>
+            <a:off x="10149840" y="2807208"/>
+            <a:ext cx="1463040" cy="274320"/>
+          </a:xfrm>
+          <a:prstGeom prst="rect">
+            <a:avLst/>
+          </a:prstGeom>
+          <a:noFill/>
+        </p:spPr>
+        <p:txBody>
+          <a:bodyPr wrap="square" anchor="t" lIns="0" rIns="0" tIns="0" bIns="0">
+            <a:spAutoFit/>
+          </a:bodyPr>
+          <a:lstStyle/>
+          <a:p>
+            <a:pPr algn="r">
+              <a:lnSpc>
+                <a:spcPct val="100000"/>
+              </a:lnSpc>
+              <a:spcAft>
+                <a:spcPts val="0"/>
+              </a:spcAft>
+            </a:pPr>
+            <a:r>
+              <a:rPr sz="950" i="0" b="1">
+                <a:solidFill>
+                  <a:srgbClr val="A100FF"/>
+                </a:solidFill>
+                <a:latin typeface="Calibri"/>
+              </a:rPr>
+              <a:t>Slide 5</a:t>
+            </a:r>
+          </a:p>
+        </p:txBody>
+      </p:sp>
+      <p:sp>
+        <p:nvSpPr>
+          <p:cNvPr id="13" name="TextBox 12"/>
+          <p:cNvSpPr txBox="1"/>
+          <p:nvPr/>
+        </p:nvSpPr>
+        <p:spPr>
+          <a:xfrm>
+            <a:off x="566928" y="3493008"/>
+            <a:ext cx="10881360" cy="256032"/>
+          </a:xfrm>
+          <a:prstGeom prst="rect">
+            <a:avLst/>
+          </a:prstGeom>
+          <a:noFill/>
+        </p:spPr>
+        <p:txBody>
+          <a:bodyPr wrap="square" anchor="t" lIns="0" rIns="0" tIns="0" bIns="0">
+            <a:spAutoFit/>
+          </a:bodyPr>
+          <a:lstStyle/>
+          <a:p>
+            <a:pPr algn="l">
+              <a:lnSpc>
+                <a:spcPct val="100000"/>
+              </a:lnSpc>
+              <a:spcAft>
+                <a:spcPts val="400"/>
+              </a:spcAft>
+            </a:pPr>
+            <a:r>
+              <a:rPr sz="1250" i="0" b="1">
+                <a:solidFill>
+                  <a:srgbClr val="460073"/>
+                </a:solidFill>
+                <a:latin typeface="Calibri"/>
+              </a:rPr>
+              <a:t>“How confident are you in $45.1M?”</a:t>
+            </a:r>
+          </a:p>
+        </p:txBody>
+      </p:sp>
+      <p:sp>
+        <p:nvSpPr>
+          <p:cNvPr id="14" name="TextBox 13"/>
+          <p:cNvSpPr txBox="1"/>
+          <p:nvPr/>
+        </p:nvSpPr>
+        <p:spPr>
+          <a:xfrm>
+            <a:off x="566928" y="3767328"/>
+            <a:ext cx="9418320" cy="566928"/>
+          </a:xfrm>
+          <a:prstGeom prst="rect">
+            <a:avLst/>
+          </a:prstGeom>
+          <a:noFill/>
+        </p:spPr>
+        <p:txBody>
+          <a:bodyPr wrap="square" anchor="t" lIns="0" rIns="0" tIns="0" bIns="0">
+            <a:spAutoFit/>
+          </a:bodyPr>
+          <a:lstStyle/>
+          <a:p>
+            <a:pPr algn="l">
+              <a:lnSpc>
+                <a:spcPct val="118000"/>
+              </a:lnSpc>
+              <a:spcAft>
+                <a:spcPts val="0"/>
+              </a:spcAft>
+            </a:pPr>
+            <a:r>
+              <a:rPr sz="1100" i="0" b="0">
+                <a:solidFill>
+                  <a:srgbClr val="22222A"/>
+                </a:solidFill>
+                <a:latin typeface="Calibri"/>
+              </a:rPr>
+              <a:t>It is a point estimate on your own constants. The defensible range is $34–56M, varying the replacement multiplier 1.0–2.0× and backfill 70–100%. Every cell in that grid is above the $14.3M you currently count, so the finding does not depend on the assumption.</a:t>
+            </a:r>
+          </a:p>
+        </p:txBody>
+      </p:sp>
+      <p:sp>
+        <p:nvSpPr>
+          <p:cNvPr id="15" name="TextBox 14"/>
+          <p:cNvSpPr txBox="1"/>
+          <p:nvPr/>
+        </p:nvSpPr>
+        <p:spPr>
+          <a:xfrm>
+            <a:off x="10149840" y="3767328"/>
+            <a:ext cx="1463040" cy="274320"/>
+          </a:xfrm>
+          <a:prstGeom prst="rect">
+            <a:avLst/>
+          </a:prstGeom>
+          <a:noFill/>
+        </p:spPr>
+        <p:txBody>
+          <a:bodyPr wrap="square" anchor="t" lIns="0" rIns="0" tIns="0" bIns="0">
+            <a:spAutoFit/>
+          </a:bodyPr>
+          <a:lstStyle/>
+          <a:p>
+            <a:pPr algn="r">
+              <a:lnSpc>
+                <a:spcPct val="100000"/>
+              </a:lnSpc>
+              <a:spcAft>
+                <a:spcPts val="0"/>
+              </a:spcAft>
+            </a:pPr>
+            <a:r>
+              <a:rPr sz="950" i="0" b="1">
+                <a:solidFill>
+                  <a:srgbClr val="A100FF"/>
+                </a:solidFill>
+                <a:latin typeface="Calibri"/>
+              </a:rPr>
+              <a:t>A5</a:t>
+            </a:r>
+          </a:p>
+        </p:txBody>
+      </p:sp>
+      <p:sp>
+        <p:nvSpPr>
+          <p:cNvPr id="16" name="TextBox 15"/>
+          <p:cNvSpPr txBox="1"/>
+          <p:nvPr/>
+        </p:nvSpPr>
+        <p:spPr>
+          <a:xfrm>
+            <a:off x="566928" y="4453128"/>
+            <a:ext cx="10881360" cy="256032"/>
+          </a:xfrm>
+          <a:prstGeom prst="rect">
+            <a:avLst/>
+          </a:prstGeom>
+          <a:noFill/>
+        </p:spPr>
+        <p:txBody>
+          <a:bodyPr wrap="square" anchor="t" lIns="0" rIns="0" tIns="0" bIns="0">
+            <a:spAutoFit/>
+          </a:bodyPr>
+          <a:lstStyle/>
+          <a:p>
+            <a:pPr algn="l">
+              <a:lnSpc>
+                <a:spcPct val="100000"/>
+              </a:lnSpc>
+              <a:spcAft>
+                <a:spcPts val="400"/>
+              </a:spcAft>
+            </a:pPr>
+            <a:r>
+              <a:rPr sz="1250" i="0" b="1">
+                <a:solidFill>
+                  <a:srgbClr val="460073"/>
+                </a:solidFill>
+                <a:latin typeface="Calibri"/>
+              </a:rPr>
+              <a:t>“You changed your own figure from $29.6M to $7.9M. Why trust the rest?”</a:t>
+            </a:r>
+          </a:p>
+        </p:txBody>
+      </p:sp>
+      <p:sp>
+        <p:nvSpPr>
+          <p:cNvPr id="17" name="TextBox 16"/>
+          <p:cNvSpPr txBox="1"/>
+          <p:nvPr/>
+        </p:nvSpPr>
+        <p:spPr>
+          <a:xfrm>
+            <a:off x="566928" y="4727448"/>
+            <a:ext cx="9418320" cy="566928"/>
+          </a:xfrm>
+          <a:prstGeom prst="rect">
+            <a:avLst/>
+          </a:prstGeom>
+          <a:noFill/>
+        </p:spPr>
+        <p:txBody>
+          <a:bodyPr wrap="square" anchor="t" lIns="0" rIns="0" tIns="0" bIns="0">
+            <a:spAutoFit/>
+          </a:bodyPr>
+          <a:lstStyle/>
+          <a:p>
+            <a:pPr algn="l">
+              <a:lnSpc>
+                <a:spcPct val="118000"/>
+              </a:lnSpc>
+              <a:spcAft>
+                <a:spcPts val="0"/>
+              </a:spcAft>
+            </a:pPr>
+            <a:r>
+              <a:rPr sz="1100" i="0" b="0">
+                <a:solidFill>
+                  <a:srgbClr val="22222A"/>
+                </a:solidFill>
+                <a:latin typeface="Calibri"/>
+              </a:rPr>
+              <a:t>Because we found it, said so, and showed the method. The original counted the baseline early attrition every employer carries as if it were addressable. Correcting it cost us $21.7M of headline and is the reason to believe the numbers we kept.</a:t>
+            </a:r>
+          </a:p>
+        </p:txBody>
+      </p:sp>
+      <p:sp>
+        <p:nvSpPr>
+          <p:cNvPr id="18" name="TextBox 17"/>
+          <p:cNvSpPr txBox="1"/>
+          <p:nvPr/>
+        </p:nvSpPr>
+        <p:spPr>
+          <a:xfrm>
+            <a:off x="10149840" y="4727448"/>
+            <a:ext cx="1463040" cy="274320"/>
+          </a:xfrm>
+          <a:prstGeom prst="rect">
+            <a:avLst/>
+          </a:prstGeom>
+          <a:noFill/>
+        </p:spPr>
+        <p:txBody>
+          <a:bodyPr wrap="square" anchor="t" lIns="0" rIns="0" tIns="0" bIns="0">
+            <a:spAutoFit/>
+          </a:bodyPr>
+          <a:lstStyle/>
+          <a:p>
+            <a:pPr algn="r">
+              <a:lnSpc>
+                <a:spcPct val="100000"/>
+              </a:lnSpc>
+              <a:spcAft>
+                <a:spcPts val="0"/>
+              </a:spcAft>
+            </a:pPr>
+            <a:r>
+              <a:rPr sz="950" i="0" b="1">
+                <a:solidFill>
+                  <a:srgbClr val="A100FF"/>
+                </a:solidFill>
+                <a:latin typeface="Calibri"/>
+              </a:rPr>
+              <a:t>A7</a:t>
+            </a:r>
+          </a:p>
+        </p:txBody>
+      </p:sp>
+      <p:sp>
+        <p:nvSpPr>
+          <p:cNvPr id="19" name="TextBox 18"/>
+          <p:cNvSpPr txBox="1"/>
+          <p:nvPr/>
+        </p:nvSpPr>
+        <p:spPr>
+          <a:xfrm>
+            <a:off x="566928" y="5413248"/>
+            <a:ext cx="10881360" cy="256032"/>
+          </a:xfrm>
+          <a:prstGeom prst="rect">
+            <a:avLst/>
+          </a:prstGeom>
+          <a:noFill/>
+        </p:spPr>
+        <p:txBody>
+          <a:bodyPr wrap="square" anchor="t" lIns="0" rIns="0" tIns="0" bIns="0">
+            <a:spAutoFit/>
+          </a:bodyPr>
+          <a:lstStyle/>
+          <a:p>
+            <a:pPr algn="l">
+              <a:lnSpc>
+                <a:spcPct val="100000"/>
+              </a:lnSpc>
+              <a:spcAft>
+                <a:spcPts val="400"/>
+              </a:spcAft>
+            </a:pPr>
+            <a:r>
+              <a:rPr sz="1250" i="0" b="1">
+                <a:solidFill>
+                  <a:srgbClr val="460073"/>
+                </a:solidFill>
+                <a:latin typeface="Calibri"/>
+              </a:rPr>
+              <a:t>“How do we know any of these numbers are right?”</a:t>
+            </a:r>
+          </a:p>
+        </p:txBody>
+      </p:sp>
+      <p:sp>
+        <p:nvSpPr>
+          <p:cNvPr id="20" name="TextBox 19"/>
+          <p:cNvSpPr txBox="1"/>
+          <p:nvPr/>
+        </p:nvSpPr>
+        <p:spPr>
+          <a:xfrm>
+            <a:off x="566928" y="5687568"/>
+            <a:ext cx="9418320" cy="566928"/>
+          </a:xfrm>
+          <a:prstGeom prst="rect">
+            <a:avLst/>
+          </a:prstGeom>
+          <a:noFill/>
+        </p:spPr>
+        <p:txBody>
+          <a:bodyPr wrap="square" anchor="t" lIns="0" rIns="0" tIns="0" bIns="0">
+            <a:spAutoFit/>
+          </a:bodyPr>
+          <a:lstStyle/>
+          <a:p>
+            <a:pPr algn="l">
+              <a:lnSpc>
+                <a:spcPct val="118000"/>
+              </a:lnSpc>
+              <a:spcAft>
+                <a:spcPts val="0"/>
+              </a:spcAft>
+            </a:pPr>
+            <a:r>
+              <a:rPr sz="1100" i="0" b="0">
+                <a:solidFill>
+                  <a:srgbClr val="22222A"/>
+                </a:solidFill>
+                <a:latin typeface="Calibri"/>
+              </a:rPr>
+              <a:t>Every figure on a slide traces to the script that produces it, listed page by page. Two independent implementations agree on the early-tenure lever to the dollar; four agree on the entity attrition rates to the decimal. Run them yourself.</a:t>
+            </a:r>
+          </a:p>
+        </p:txBody>
+      </p:sp>
+      <p:sp>
+        <p:nvSpPr>
+          <p:cNvPr id="21" name="TextBox 20"/>
+          <p:cNvSpPr txBox="1"/>
+          <p:nvPr/>
+        </p:nvSpPr>
+        <p:spPr>
+          <a:xfrm>
+            <a:off x="10149840" y="5687568"/>
+            <a:ext cx="1463040" cy="274320"/>
+          </a:xfrm>
+          <a:prstGeom prst="rect">
+            <a:avLst/>
+          </a:prstGeom>
+          <a:noFill/>
+        </p:spPr>
+        <p:txBody>
+          <a:bodyPr wrap="square" anchor="t" lIns="0" rIns="0" tIns="0" bIns="0">
+            <a:spAutoFit/>
+          </a:bodyPr>
+          <a:lstStyle/>
+          <a:p>
+            <a:pPr algn="r">
+              <a:lnSpc>
+                <a:spcPct val="100000"/>
+              </a:lnSpc>
+              <a:spcAft>
+                <a:spcPts val="0"/>
+              </a:spcAft>
+            </a:pPr>
+            <a:r>
+              <a:rPr sz="950" i="0" b="1">
+                <a:solidFill>
+                  <a:srgbClr val="A100FF"/>
+                </a:solidFill>
+                <a:latin typeface="Calibri"/>
+              </a:rPr>
+              <a:t>A14, A11</a:t>
+            </a:r>
+          </a:p>
+        </p:txBody>
+      </p:sp>
+    </p:spTree>
+  </p:cSld>
+  <p:clrMapOvr>
+    <a:masterClrMapping/>
+  </p:clrMapOvr>
+</p:sld>
+</file>
+
+<file path=ppt/slides/slide37.xml><?xml version="1.0" encoding="utf-8"?>
+<p:sld xmlns:a="http://schemas.openxmlformats.org/drawingml/2006/main" xmlns:p="http://schemas.openxmlformats.org/presentationml/2006/main" xmlns:r="http://schemas.openxmlformats.org/officeDocument/2006/relationships">
+  <p:cSld>
+    <p:spTree>
+      <p:nvGrpSpPr>
+        <p:cNvPr id="1" name=""/>
+        <p:cNvGrpSpPr/>
+        <p:nvPr/>
+      </p:nvGrpSpPr>
+      <p:grpSpPr/>
+      <p:sp>
+        <p:nvSpPr>
+          <p:cNvPr id="2" name="Rectangle 1"/>
+          <p:cNvSpPr/>
+          <p:nvPr/>
+        </p:nvSpPr>
+        <p:spPr>
+          <a:xfrm>
+            <a:off x="0" y="0"/>
+            <a:ext cx="12191695" cy="68580"/>
+          </a:xfrm>
+          <a:prstGeom prst="rect">
+            <a:avLst/>
+          </a:prstGeom>
+          <a:solidFill>
+            <a:srgbClr val="5A5A66"/>
+          </a:solidFill>
+          <a:ln>
+            <a:noFill/>
+          </a:ln>
+          <a:effectLst/>
+        </p:spPr>
+        <p:style>
+          <a:lnRef idx="1">
+            <a:schemeClr val="accent1"/>
+          </a:lnRef>
+          <a:fillRef idx="3">
+            <a:schemeClr val="accent1"/>
+          </a:fillRef>
+          <a:effectRef idx="2">
+            <a:schemeClr val="accent1"/>
+          </a:effectRef>
+          <a:fontRef idx="minor">
+            <a:schemeClr val="lt1"/>
+          </a:fontRef>
+        </p:style>
+        <p:txBody>
+          <a:bodyPr rtlCol="0" anchor="ctr"/>
+          <a:lstStyle/>
+          <a:p>
+            <a:pPr algn="ctr"/>
+          </a:p>
+        </p:txBody>
+      </p:sp>
+      <p:sp>
+        <p:nvSpPr>
+          <p:cNvPr id="3" name="TextBox 2"/>
+          <p:cNvSpPr txBox="1"/>
+          <p:nvPr/>
+        </p:nvSpPr>
+        <p:spPr>
+          <a:xfrm>
+            <a:off x="566928" y="347472"/>
+            <a:ext cx="11057839" cy="237744"/>
+          </a:xfrm>
+          <a:prstGeom prst="rect">
+            <a:avLst/>
+          </a:prstGeom>
+          <a:noFill/>
+        </p:spPr>
+        <p:txBody>
+          <a:bodyPr wrap="square" anchor="t" lIns="0" rIns="0" tIns="0" bIns="0">
+            <a:spAutoFit/>
+          </a:bodyPr>
+          <a:lstStyle/>
+          <a:p>
+            <a:pPr algn="l">
+              <a:lnSpc>
+                <a:spcPct val="100000"/>
+              </a:lnSpc>
+              <a:spcAft>
+                <a:spcPts val="0"/>
+              </a:spcAft>
+            </a:pPr>
+            <a:r>
+              <a:rPr sz="1100" i="0" b="1">
+                <a:solidFill>
+                  <a:srgbClr val="A100FF"/>
+                </a:solidFill>
+                <a:latin typeface="Calibri"/>
+              </a:rPr>
+              <a:t>APPENDIX A18</a:t>
+            </a:r>
+          </a:p>
+        </p:txBody>
+      </p:sp>
+      <p:sp>
+        <p:nvSpPr>
+          <p:cNvPr id="4" name="TextBox 3"/>
+          <p:cNvSpPr txBox="1"/>
+          <p:nvPr/>
+        </p:nvSpPr>
+        <p:spPr>
+          <a:xfrm>
+            <a:off x="566928" y="621792"/>
+            <a:ext cx="11057839" cy="457200"/>
+          </a:xfrm>
+          <a:prstGeom prst="rect">
+            <a:avLst/>
+          </a:prstGeom>
+          <a:noFill/>
+        </p:spPr>
+        <p:txBody>
+          <a:bodyPr wrap="square" anchor="t" lIns="0" rIns="0" tIns="0" bIns="0">
+            <a:spAutoFit/>
+          </a:bodyPr>
+          <a:lstStyle/>
+          <a:p>
+            <a:pPr algn="l">
+              <a:lnSpc>
+                <a:spcPct val="100000"/>
+              </a:lnSpc>
+              <a:spcAft>
+                <a:spcPts val="0"/>
+              </a:spcAft>
+            </a:pPr>
+            <a:r>
+              <a:rPr sz="2300" i="0" b="1">
+                <a:solidFill>
+                  <a:srgbClr val="460073"/>
+                </a:solidFill>
+                <a:latin typeface="Calibri"/>
+              </a:rPr>
+              <a:t>Questions we expect — the recommendation</a:t>
+            </a:r>
+          </a:p>
+        </p:txBody>
+      </p:sp>
+      <p:sp>
+        <p:nvSpPr>
+          <p:cNvPr id="5" name="TextBox 4"/>
+          <p:cNvSpPr txBox="1"/>
+          <p:nvPr/>
+        </p:nvSpPr>
+        <p:spPr>
+          <a:xfrm>
+            <a:off x="566928" y="1051560"/>
+            <a:ext cx="10607040" cy="384048"/>
+          </a:xfrm>
+          <a:prstGeom prst="rect">
+            <a:avLst/>
+          </a:prstGeom>
+          <a:noFill/>
+        </p:spPr>
+        <p:txBody>
+          <a:bodyPr wrap="square" anchor="t" lIns="0" rIns="0" tIns="0" bIns="0">
+            <a:spAutoFit/>
+          </a:bodyPr>
+          <a:lstStyle/>
+          <a:p>
+            <a:pPr algn="l">
+              <a:lnSpc>
+                <a:spcPct val="115000"/>
+              </a:lnSpc>
+              <a:spcAft>
+                <a:spcPts val="0"/>
+              </a:spcAft>
+            </a:pPr>
+            <a:r>
+              <a:rPr sz="1150" i="1" b="0">
+                <a:solidFill>
+                  <a:srgbClr val="5A5A66"/>
+                </a:solidFill>
+                <a:latin typeface="Calibri"/>
+              </a:rPr>
+              <a:t>Continued.</a:t>
+            </a:r>
+          </a:p>
+        </p:txBody>
+      </p:sp>
+      <p:sp>
+        <p:nvSpPr>
+          <p:cNvPr id="6" name="TextBox 5"/>
+          <p:cNvSpPr txBox="1"/>
+          <p:nvPr/>
+        </p:nvSpPr>
+        <p:spPr>
+          <a:xfrm>
+            <a:off x="10893247" y="6355080"/>
+            <a:ext cx="731520" cy="228600"/>
+          </a:xfrm>
+          <a:prstGeom prst="rect">
+            <a:avLst/>
+          </a:prstGeom>
+          <a:noFill/>
+        </p:spPr>
+        <p:txBody>
+          <a:bodyPr wrap="square" anchor="t" lIns="0" rIns="0" tIns="0" bIns="0">
+            <a:spAutoFit/>
+          </a:bodyPr>
+          <a:lstStyle/>
+          <a:p>
+            <a:pPr algn="r">
+              <a:lnSpc>
+                <a:spcPct val="100000"/>
+              </a:lnSpc>
+              <a:spcAft>
+                <a:spcPts val="0"/>
+              </a:spcAft>
+            </a:pPr>
+            <a:r>
+              <a:rPr sz="1000" i="0" b="1">
+                <a:solidFill>
+                  <a:srgbClr val="5A5A66"/>
+                </a:solidFill>
+                <a:latin typeface="Calibri"/>
+              </a:rPr>
+              <a:t>A18</a:t>
+            </a:r>
+          </a:p>
+        </p:txBody>
+      </p:sp>
+      <p:sp>
+        <p:nvSpPr>
+          <p:cNvPr id="7" name="TextBox 6"/>
+          <p:cNvSpPr txBox="1"/>
+          <p:nvPr/>
+        </p:nvSpPr>
+        <p:spPr>
+          <a:xfrm>
+            <a:off x="566928" y="1572768"/>
+            <a:ext cx="10881360" cy="256032"/>
+          </a:xfrm>
+          <a:prstGeom prst="rect">
+            <a:avLst/>
+          </a:prstGeom>
+          <a:noFill/>
+        </p:spPr>
+        <p:txBody>
+          <a:bodyPr wrap="square" anchor="t" lIns="0" rIns="0" tIns="0" bIns="0">
+            <a:spAutoFit/>
+          </a:bodyPr>
+          <a:lstStyle/>
+          <a:p>
+            <a:pPr algn="l">
+              <a:lnSpc>
+                <a:spcPct val="100000"/>
+              </a:lnSpc>
+              <a:spcAft>
+                <a:spcPts val="400"/>
+              </a:spcAft>
+            </a:pPr>
+            <a:r>
+              <a:rPr sz="1250" i="0" b="1">
+                <a:solidFill>
+                  <a:srgbClr val="460073"/>
+                </a:solidFill>
+                <a:latin typeface="Calibri"/>
+              </a:rPr>
+              <a:t>“Are you telling me my HR team is dishonest?”</a:t>
+            </a:r>
+          </a:p>
+        </p:txBody>
+      </p:sp>
+      <p:sp>
+        <p:nvSpPr>
+          <p:cNvPr id="8" name="TextBox 7"/>
+          <p:cNvSpPr txBox="1"/>
+          <p:nvPr/>
+        </p:nvSpPr>
+        <p:spPr>
+          <a:xfrm>
+            <a:off x="566928" y="1847088"/>
+            <a:ext cx="9418320" cy="566928"/>
+          </a:xfrm>
+          <a:prstGeom prst="rect">
+            <a:avLst/>
+          </a:prstGeom>
+          <a:noFill/>
+        </p:spPr>
+        <p:txBody>
+          <a:bodyPr wrap="square" anchor="t" lIns="0" rIns="0" tIns="0" bIns="0">
+            <a:spAutoFit/>
+          </a:bodyPr>
+          <a:lstStyle/>
+          <a:p>
+            <a:pPr algn="l">
+              <a:lnSpc>
+                <a:spcPct val="118000"/>
+              </a:lnSpc>
+              <a:spcAft>
+                <a:spcPts val="0"/>
+              </a:spcAft>
+            </a:pPr>
+            <a:r>
+              <a:rPr sz="1100" i="0" b="0">
+                <a:solidFill>
+                  <a:srgbClr val="22222A"/>
+                </a:solidFill>
+                <a:latin typeface="Calibri"/>
+              </a:rPr>
+              <a:t>No. The flag was almost certainly built to spot top-talent loss, and it does that for Outstanding. The failure is that it was then used as a cost metric, which it was never designed to be. That is a governance gap, not a personnel matter.</a:t>
+            </a:r>
+          </a:p>
+        </p:txBody>
+      </p:sp>
+      <p:sp>
+        <p:nvSpPr>
+          <p:cNvPr id="9" name="TextBox 8"/>
+          <p:cNvSpPr txBox="1"/>
+          <p:nvPr/>
+        </p:nvSpPr>
+        <p:spPr>
+          <a:xfrm>
+            <a:off x="10149840" y="1847088"/>
+            <a:ext cx="1463040" cy="274320"/>
+          </a:xfrm>
+          <a:prstGeom prst="rect">
+            <a:avLst/>
+          </a:prstGeom>
+          <a:noFill/>
+        </p:spPr>
+        <p:txBody>
+          <a:bodyPr wrap="square" anchor="t" lIns="0" rIns="0" tIns="0" bIns="0">
+            <a:spAutoFit/>
+          </a:bodyPr>
+          <a:lstStyle/>
+          <a:p>
+            <a:pPr algn="r">
+              <a:lnSpc>
+                <a:spcPct val="100000"/>
+              </a:lnSpc>
+              <a:spcAft>
+                <a:spcPts val="0"/>
+              </a:spcAft>
+            </a:pPr>
+            <a:r>
+              <a:rPr sz="950" i="0" b="1">
+                <a:solidFill>
+                  <a:srgbClr val="A100FF"/>
+                </a:solidFill>
+                <a:latin typeface="Calibri"/>
+              </a:rPr>
+              <a:t>Slide 4</a:t>
+            </a:r>
+          </a:p>
+        </p:txBody>
+      </p:sp>
+      <p:sp>
+        <p:nvSpPr>
+          <p:cNvPr id="10" name="TextBox 9"/>
+          <p:cNvSpPr txBox="1"/>
+          <p:nvPr/>
+        </p:nvSpPr>
+        <p:spPr>
+          <a:xfrm>
+            <a:off x="566928" y="2532888"/>
+            <a:ext cx="10881360" cy="256032"/>
+          </a:xfrm>
+          <a:prstGeom prst="rect">
+            <a:avLst/>
+          </a:prstGeom>
+          <a:noFill/>
+        </p:spPr>
+        <p:txBody>
+          <a:bodyPr wrap="square" anchor="t" lIns="0" rIns="0" tIns="0" bIns="0">
+            <a:spAutoFit/>
+          </a:bodyPr>
+          <a:lstStyle/>
+          <a:p>
+            <a:pPr algn="l">
+              <a:lnSpc>
+                <a:spcPct val="100000"/>
+              </a:lnSpc>
+              <a:spcAft>
+                <a:spcPts val="400"/>
+              </a:spcAft>
+            </a:pPr>
+            <a:r>
+              <a:rPr sz="1250" i="0" b="1">
+                <a:solidFill>
+                  <a:srgbClr val="460073"/>
+                </a:solidFill>
+                <a:latin typeface="Calibri"/>
+              </a:rPr>
+              <a:t>“Isn't Entity_B just sitting in your worst departments?”</a:t>
+            </a:r>
+          </a:p>
+        </p:txBody>
+      </p:sp>
+      <p:sp>
+        <p:nvSpPr>
+          <p:cNvPr id="11" name="TextBox 10"/>
+          <p:cNvSpPr txBox="1"/>
+          <p:nvPr/>
+        </p:nvSpPr>
+        <p:spPr>
+          <a:xfrm>
+            <a:off x="566928" y="2807208"/>
+            <a:ext cx="9418320" cy="566928"/>
+          </a:xfrm>
+          <a:prstGeom prst="rect">
+            <a:avLst/>
+          </a:prstGeom>
+          <a:noFill/>
+        </p:spPr>
+        <p:txBody>
+          <a:bodyPr wrap="square" anchor="t" lIns="0" rIns="0" tIns="0" bIns="0">
+            <a:spAutoFit/>
+          </a:bodyPr>
+          <a:lstStyle/>
+          <a:p>
+            <a:pPr algn="l">
+              <a:lnSpc>
+                <a:spcPct val="118000"/>
+              </a:lnSpc>
+              <a:spcAft>
+                <a:spcPts val="0"/>
+              </a:spcAft>
+            </a:pPr>
+            <a:r>
+              <a:rPr sz="1100" i="0" b="0">
+                <a:solidFill>
+                  <a:srgbClr val="22222A"/>
+                </a:solidFill>
+                <a:latin typeface="Calibri"/>
+              </a:rPr>
+              <a:t>No. Controlling for department, role level, pay and high-potential status, Entity_B still leaves at 1.95× Entity_A (95% CI 1.55–2.44). Only one of six department terms is significant, and Risk &amp; Compliance comes out at exactly 1.00 once entity is in the model.</a:t>
+            </a:r>
+          </a:p>
+        </p:txBody>
+      </p:sp>
+      <p:sp>
+        <p:nvSpPr>
+          <p:cNvPr id="12" name="TextBox 11"/>
+          <p:cNvSpPr txBox="1"/>
+          <p:nvPr/>
+        </p:nvSpPr>
+        <p:spPr>
+          <a:xfrm>
+            <a:off x="10149840" y="2807208"/>
+            <a:ext cx="1463040" cy="274320"/>
+          </a:xfrm>
+          <a:prstGeom prst="rect">
+            <a:avLst/>
+          </a:prstGeom>
+          <a:noFill/>
+        </p:spPr>
+        <p:txBody>
+          <a:bodyPr wrap="square" anchor="t" lIns="0" rIns="0" tIns="0" bIns="0">
+            <a:spAutoFit/>
+          </a:bodyPr>
+          <a:lstStyle/>
+          <a:p>
+            <a:pPr algn="r">
+              <a:lnSpc>
+                <a:spcPct val="100000"/>
+              </a:lnSpc>
+              <a:spcAft>
+                <a:spcPts val="0"/>
+              </a:spcAft>
+            </a:pPr>
+            <a:r>
+              <a:rPr sz="950" i="0" b="1">
+                <a:solidFill>
+                  <a:srgbClr val="A100FF"/>
+                </a:solidFill>
+                <a:latin typeface="Calibri"/>
+              </a:rPr>
+              <a:t>A15</a:t>
+            </a:r>
+          </a:p>
+        </p:txBody>
+      </p:sp>
+      <p:sp>
+        <p:nvSpPr>
+          <p:cNvPr id="13" name="TextBox 12"/>
+          <p:cNvSpPr txBox="1"/>
+          <p:nvPr/>
+        </p:nvSpPr>
+        <p:spPr>
+          <a:xfrm>
+            <a:off x="566928" y="3493008"/>
+            <a:ext cx="10881360" cy="256032"/>
+          </a:xfrm>
+          <a:prstGeom prst="rect">
+            <a:avLst/>
+          </a:prstGeom>
+          <a:noFill/>
+        </p:spPr>
+        <p:txBody>
+          <a:bodyPr wrap="square" anchor="t" lIns="0" rIns="0" tIns="0" bIns="0">
+            <a:spAutoFit/>
+          </a:bodyPr>
+          <a:lstStyle/>
+          <a:p>
+            <a:pPr algn="l">
+              <a:lnSpc>
+                <a:spcPct val="100000"/>
+              </a:lnSpc>
+              <a:spcAft>
+                <a:spcPts val="400"/>
+              </a:spcAft>
+            </a:pPr>
+            <a:r>
+              <a:rPr sz="1250" i="0" b="1">
+                <a:solidFill>
+                  <a:srgbClr val="460073"/>
+                </a:solidFill>
+                <a:latin typeface="Calibri"/>
+              </a:rPr>
+              <a:t>“Entity_B is only 1,601 people. Why should I care?”</a:t>
+            </a:r>
+          </a:p>
+        </p:txBody>
+      </p:sp>
+      <p:sp>
+        <p:nvSpPr>
+          <p:cNvPr id="14" name="TextBox 13"/>
+          <p:cNvSpPr txBox="1"/>
+          <p:nvPr/>
+        </p:nvSpPr>
+        <p:spPr>
+          <a:xfrm>
+            <a:off x="566928" y="3767328"/>
+            <a:ext cx="9418320" cy="566928"/>
+          </a:xfrm>
+          <a:prstGeom prst="rect">
+            <a:avLst/>
+          </a:prstGeom>
+          <a:noFill/>
+        </p:spPr>
+        <p:txBody>
+          <a:bodyPr wrap="square" anchor="t" lIns="0" rIns="0" tIns="0" bIns="0">
+            <a:spAutoFit/>
+          </a:bodyPr>
+          <a:lstStyle/>
+          <a:p>
+            <a:pPr algn="l">
+              <a:lnSpc>
+                <a:spcPct val="118000"/>
+              </a:lnSpc>
+              <a:spcAft>
+                <a:spcPts val="0"/>
+              </a:spcAft>
+            </a:pPr>
+            <a:r>
+              <a:rPr sz="1100" i="0" b="0">
+                <a:solidFill>
+                  <a:srgbClr val="22222A"/>
+                </a:solidFill>
+                <a:latin typeface="Calibri"/>
+              </a:rPr>
+              <a:t>You shouldn't care about it for the dollars — NovaCorp-Origin holds $29.2M of the $45.1M on headcount alone. You should care because it is the one place where the cause is identified, the fix is proven inside your own company, and the budget is already guided.</a:t>
+            </a:r>
+          </a:p>
+        </p:txBody>
+      </p:sp>
+      <p:sp>
+        <p:nvSpPr>
+          <p:cNvPr id="15" name="TextBox 14"/>
+          <p:cNvSpPr txBox="1"/>
+          <p:nvPr/>
+        </p:nvSpPr>
+        <p:spPr>
+          <a:xfrm>
+            <a:off x="10149840" y="3767328"/>
+            <a:ext cx="1463040" cy="274320"/>
+          </a:xfrm>
+          <a:prstGeom prst="rect">
+            <a:avLst/>
+          </a:prstGeom>
+          <a:noFill/>
+        </p:spPr>
+        <p:txBody>
+          <a:bodyPr wrap="square" anchor="t" lIns="0" rIns="0" tIns="0" bIns="0">
+            <a:spAutoFit/>
+          </a:bodyPr>
+          <a:lstStyle/>
+          <a:p>
+            <a:pPr algn="r">
+              <a:lnSpc>
+                <a:spcPct val="100000"/>
+              </a:lnSpc>
+              <a:spcAft>
+                <a:spcPts val="0"/>
+              </a:spcAft>
+            </a:pPr>
+            <a:r>
+              <a:rPr sz="950" i="0" b="1">
+                <a:solidFill>
+                  <a:srgbClr val="A100FF"/>
+                </a:solidFill>
+                <a:latin typeface="Calibri"/>
+              </a:rPr>
+              <a:t>Slides 6, 9</a:t>
+            </a:r>
+          </a:p>
+        </p:txBody>
+      </p:sp>
+      <p:sp>
+        <p:nvSpPr>
+          <p:cNvPr id="16" name="TextBox 15"/>
+          <p:cNvSpPr txBox="1"/>
+          <p:nvPr/>
+        </p:nvSpPr>
+        <p:spPr>
+          <a:xfrm>
+            <a:off x="566928" y="4453128"/>
+            <a:ext cx="10881360" cy="256032"/>
+          </a:xfrm>
+          <a:prstGeom prst="rect">
+            <a:avLst/>
+          </a:prstGeom>
+          <a:noFill/>
+        </p:spPr>
+        <p:txBody>
+          <a:bodyPr wrap="square" anchor="t" lIns="0" rIns="0" tIns="0" bIns="0">
+            <a:spAutoFit/>
+          </a:bodyPr>
+          <a:lstStyle/>
+          <a:p>
+            <a:pPr algn="l">
+              <a:lnSpc>
+                <a:spcPct val="100000"/>
+              </a:lnSpc>
+              <a:spcAft>
+                <a:spcPts val="400"/>
+              </a:spcAft>
+            </a:pPr>
+            <a:r>
+              <a:rPr sz="1250" i="0" b="1">
+                <a:solidFill>
+                  <a:srgbClr val="460073"/>
+                </a:solidFill>
+                <a:latin typeface="Calibri"/>
+              </a:rPr>
+              <a:t>“Can't I just run the silence flag? It's free.”</a:t>
+            </a:r>
+          </a:p>
+        </p:txBody>
+      </p:sp>
+      <p:sp>
+        <p:nvSpPr>
+          <p:cNvPr id="17" name="TextBox 16"/>
+          <p:cNvSpPr txBox="1"/>
+          <p:nvPr/>
+        </p:nvSpPr>
+        <p:spPr>
+          <a:xfrm>
+            <a:off x="566928" y="4727448"/>
+            <a:ext cx="9418320" cy="566928"/>
+          </a:xfrm>
+          <a:prstGeom prst="rect">
+            <a:avLst/>
+          </a:prstGeom>
+          <a:noFill/>
+        </p:spPr>
+        <p:txBody>
+          <a:bodyPr wrap="square" anchor="t" lIns="0" rIns="0" tIns="0" bIns="0">
+            <a:spAutoFit/>
+          </a:bodyPr>
+          <a:lstStyle/>
+          <a:p>
+            <a:pPr algn="l">
+              <a:lnSpc>
+                <a:spcPct val="118000"/>
+              </a:lnSpc>
+              <a:spcAft>
+                <a:spcPts val="0"/>
+              </a:spcAft>
+            </a:pPr>
+            <a:r>
+              <a:rPr sz="1100" i="0" b="0">
+                <a:solidFill>
+                  <a:srgbClr val="22222A"/>
+                </a:solidFill>
+                <a:latin typeface="Calibri"/>
+              </a:rPr>
+              <a:t>At team level, yes. As an individual score it fails the four-fifths rule on age by a factor of twelve and is wrong roughly three times in four. If it ever surfaced in a performance or redundancy conversation, the exposure would cost more than the attrition does.</a:t>
+            </a:r>
+          </a:p>
+        </p:txBody>
+      </p:sp>
+      <p:sp>
+        <p:nvSpPr>
+          <p:cNvPr id="18" name="TextBox 17"/>
+          <p:cNvSpPr txBox="1"/>
+          <p:nvPr/>
+        </p:nvSpPr>
+        <p:spPr>
+          <a:xfrm>
+            <a:off x="10149840" y="4727448"/>
+            <a:ext cx="1463040" cy="274320"/>
+          </a:xfrm>
+          <a:prstGeom prst="rect">
+            <a:avLst/>
+          </a:prstGeom>
+          <a:noFill/>
+        </p:spPr>
+        <p:txBody>
+          <a:bodyPr wrap="square" anchor="t" lIns="0" rIns="0" tIns="0" bIns="0">
+            <a:spAutoFit/>
+          </a:bodyPr>
+          <a:lstStyle/>
+          <a:p>
+            <a:pPr algn="r">
+              <a:lnSpc>
+                <a:spcPct val="100000"/>
+              </a:lnSpc>
+              <a:spcAft>
+                <a:spcPts val="0"/>
+              </a:spcAft>
+            </a:pPr>
+            <a:r>
+              <a:rPr sz="950" i="0" b="1">
+                <a:solidFill>
+                  <a:srgbClr val="A100FF"/>
+                </a:solidFill>
+                <a:latin typeface="Calibri"/>
+              </a:rPr>
+              <a:t>Slides 12–13, A4</a:t>
+            </a:r>
+          </a:p>
+        </p:txBody>
+      </p:sp>
+      <p:sp>
+        <p:nvSpPr>
+          <p:cNvPr id="19" name="TextBox 18"/>
+          <p:cNvSpPr txBox="1"/>
+          <p:nvPr/>
+        </p:nvSpPr>
+        <p:spPr>
+          <a:xfrm>
+            <a:off x="566928" y="5413248"/>
+            <a:ext cx="10881360" cy="256032"/>
+          </a:xfrm>
+          <a:prstGeom prst="rect">
+            <a:avLst/>
+          </a:prstGeom>
+          <a:noFill/>
+        </p:spPr>
+        <p:txBody>
+          <a:bodyPr wrap="square" anchor="t" lIns="0" rIns="0" tIns="0" bIns="0">
+            <a:spAutoFit/>
+          </a:bodyPr>
+          <a:lstStyle/>
+          <a:p>
+            <a:pPr algn="l">
+              <a:lnSpc>
+                <a:spcPct val="100000"/>
+              </a:lnSpc>
+              <a:spcAft>
+                <a:spcPts val="400"/>
+              </a:spcAft>
+            </a:pPr>
+            <a:r>
+              <a:rPr sz="1250" i="0" b="1">
+                <a:solidFill>
+                  <a:srgbClr val="460073"/>
+                </a:solidFill>
+                <a:latin typeface="Calibri"/>
+              </a:rPr>
+              <a:t>“What would change your mind?”</a:t>
+            </a:r>
+          </a:p>
+        </p:txBody>
+      </p:sp>
+      <p:sp>
+        <p:nvSpPr>
+          <p:cNvPr id="20" name="TextBox 19"/>
+          <p:cNvSpPr txBox="1"/>
+          <p:nvPr/>
+        </p:nvSpPr>
+        <p:spPr>
+          <a:xfrm>
+            <a:off x="566928" y="5687568"/>
+            <a:ext cx="9418320" cy="566928"/>
+          </a:xfrm>
+          <a:prstGeom prst="rect">
+            <a:avLst/>
+          </a:prstGeom>
+          <a:noFill/>
+        </p:spPr>
+        <p:txBody>
+          <a:bodyPr wrap="square" anchor="t" lIns="0" rIns="0" tIns="0" bIns="0">
+            <a:spAutoFit/>
+          </a:bodyPr>
+          <a:lstStyle/>
+          <a:p>
+            <a:pPr algn="l">
+              <a:lnSpc>
+                <a:spcPct val="118000"/>
+              </a:lnSpc>
+              <a:spcAft>
+                <a:spcPts val="0"/>
+              </a:spcAft>
+            </a:pPr>
+            <a:r>
+              <a:rPr sz="1100" i="0" b="0">
+                <a:solidFill>
+                  <a:srgbClr val="22222A"/>
+                </a:solidFill>
+                <a:latin typeface="Calibri"/>
+              </a:rPr>
+              <a:t>Pre-acquisition Entity_B engagement data. If they arrived unhappy from their previous employer, the integration story weakens considerably and we cannot currently rule that out. A shorter survey cadence would also test it: if response rate does not move within two waves of the flag change, our leading indicator is wrong.</a:t>
+            </a:r>
+          </a:p>
+        </p:txBody>
+      </p:sp>
+      <p:sp>
+        <p:nvSpPr>
+          <p:cNvPr id="21" name="TextBox 20"/>
+          <p:cNvSpPr txBox="1"/>
+          <p:nvPr/>
+        </p:nvSpPr>
+        <p:spPr>
+          <a:xfrm>
+            <a:off x="10149840" y="5687568"/>
+            <a:ext cx="1463040" cy="274320"/>
+          </a:xfrm>
+          <a:prstGeom prst="rect">
+            <a:avLst/>
+          </a:prstGeom>
+          <a:noFill/>
+        </p:spPr>
+        <p:txBody>
+          <a:bodyPr wrap="square" anchor="t" lIns="0" rIns="0" tIns="0" bIns="0">
+            <a:spAutoFit/>
+          </a:bodyPr>
+          <a:lstStyle/>
+          <a:p>
+            <a:pPr algn="r">
+              <a:lnSpc>
+                <a:spcPct val="100000"/>
+              </a:lnSpc>
+              <a:spcAft>
+                <a:spcPts val="0"/>
+              </a:spcAft>
+            </a:pPr>
+            <a:r>
+              <a:rPr sz="950" i="0" b="1">
+                <a:solidFill>
+                  <a:srgbClr val="A100FF"/>
+                </a:solidFill>
+                <a:latin typeface="Calibri"/>
+              </a:rPr>
+              <a:t>Slide 14, A16</a:t>
             </a:r>
           </a:p>
         </p:txBody>

</xml_diff>

<commit_message>
fix(deck): remove statistical jargon from main slides and enlarge callouts
</commit_message>
<xml_diff>
--- a/deck/NovaCorp_deck.pptx
+++ b/deck/NovaCorp_deck.pptx
@@ -4256,7 +4256,7 @@
               </a:spcAft>
             </a:pPr>
             <a:r>
-              <a:rPr sz="1150" i="1" b="0">
+              <a:rPr sz="1350" i="1" b="0">
                 <a:solidFill>
                   <a:srgbClr val="22222A"/>
                 </a:solidFill>
@@ -5186,7 +5186,7 @@
               </a:spcAft>
             </a:pPr>
             <a:r>
-              <a:rPr sz="1150" i="1" b="0">
+              <a:rPr sz="1350" i="1" b="0">
                 <a:solidFill>
                   <a:srgbClr val="22222A"/>
                 </a:solidFill>
@@ -5485,7 +5485,7 @@
                 </a:solidFill>
                 <a:latin typeface="Calibri"/>
               </a:rPr>
-              <a:t>Four-fifths rule applied to a proposed individual flight-risk flag, on all active staff. All figures from ethics_audit.py. Full fairness method and results in appendix A4.</a:t>
+              <a:t>The four-fifths rule is the standard EEOC adverse-impact screen. Applied to a proposed individual flight-risk flag across all active staff. Full method and results in appendix A4.</a:t>
             </a:r>
           </a:p>
         </p:txBody>
@@ -5597,7 +5597,7 @@
                 </a:solidFill>
                 <a:latin typeface="Calibri"/>
               </a:rPr>
-              <a:t>Under the </a:t>
+              <a:t>It flags one age group </a:t>
             </a:r>
             <a:r>
               <a:rPr sz="1200" i="0" b="1">
@@ -5606,7 +5606,7 @@
                 </a:solidFill>
                 <a:latin typeface="Calibri"/>
               </a:rPr>
-              <a:t>four-fifths rule</a:t>
+              <a:t>twelve times</a:t>
             </a:r>
             <a:r>
               <a:rPr sz="1200" i="0" b="0">
@@ -5615,25 +5615,7 @@
                 </a:solidFill>
                 <a:latin typeface="Calibri"/>
               </a:rPr>
-              <a:t> it fails on age (ratio </a:t>
-            </a:r>
-            <a:r>
-              <a:rPr sz="1200" i="0" b="1">
-                <a:solidFill>
-                  <a:srgbClr val="460073"/>
-                </a:solidFill>
-                <a:latin typeface="Calibri"/>
-              </a:rPr>
-              <a:t>0.08</a:t>
-            </a:r>
-            <a:r>
-              <a:rPr sz="1200" i="0" b="0">
-                <a:solidFill>
-                  <a:srgbClr val="22222A"/>
-                </a:solidFill>
-                <a:latin typeface="Calibri"/>
-              </a:rPr>
-              <a:t>, a twelvefold gap), on role level (L1 9.2% vs L5 1.4%) and on acquisition cohort (Entity_C 31.7% vs NovaCorp-Origin 2.4%).</a:t>
+              <a:t> more often than another, and shows the same pattern by role level (L1 9.2% vs L5 1.4%) and by acquisition cohort (Entity_C 31.7% vs NovaCorp-Origin 2.4%). That is the standard legal test for adverse impact, and it fails on all three.</a:t>
             </a:r>
           </a:p>
           <a:p>
@@ -5847,13 +5829,13 @@
               </a:spcAft>
             </a:pPr>
             <a:r>
-              <a:rPr sz="1050" i="1" b="0">
+              <a:rPr sz="1250" i="1" b="0">
                 <a:solidFill>
                   <a:srgbClr val="22222A"/>
                 </a:solidFill>
                 <a:latin typeface="Calibri"/>
               </a:rPr>
-              <a:t>We're showing you the thing we decided not to recommend. In a performance or redundancy conversation this is a discrimination exposure that costs more than the attrition does.</a:t>
+              <a:t>In a performance or redundancy conversation, this is a discrimination exposure that costs more than the attrition does.</a:t>
             </a:r>
           </a:p>
         </p:txBody>
@@ -6807,7 +6789,7 @@
                 </a:solidFill>
                 <a:latin typeface="Calibri"/>
               </a:rPr>
-              <a:t>Full data-quality register in appendix A6. Statistical test register in A8.</a:t>
+              <a:t>Full data-quality register in appendix A6. Every test we ran is listed in A8.</a:t>
             </a:r>
           </a:p>
         </p:txBody>
@@ -7198,7 +7180,7 @@
               </a:spcAft>
             </a:pPr>
             <a:r>
-              <a:rPr sz="1150" i="1" b="0">
+              <a:rPr sz="1350" i="1" b="0">
                 <a:solidFill>
                   <a:srgbClr val="22222A"/>
                 </a:solidFill>
@@ -9008,7 +8990,7 @@
               </a:spcAft>
             </a:pPr>
             <a:r>
-              <a:rPr sz="1250" i="1" b="0">
+              <a:rPr sz="1450" i="1" b="0">
                 <a:solidFill>
                   <a:srgbClr val="22222A"/>
                 </a:solidFill>
@@ -11406,7 +11388,7 @@
               </a:spcAft>
             </a:pPr>
             <a:r>
-              <a:rPr sz="1250" i="1" b="0">
+              <a:rPr sz="1450" i="1" b="0">
                 <a:solidFill>
                   <a:srgbClr val="22222A"/>
                 </a:solidFill>
@@ -23239,7 +23221,7 @@
               </a:spcAft>
             </a:pPr>
             <a:r>
-              <a:rPr sz="1100" i="1" b="0">
+              <a:rPr sz="1300" i="1" b="0">
                 <a:solidFill>
                   <a:srgbClr val="22222A"/>
                 </a:solidFill>
@@ -32887,7 +32869,7 @@
               </a:spcAft>
             </a:pPr>
             <a:r>
-              <a:rPr sz="1050" i="1" b="0">
+              <a:rPr sz="1250" i="1" b="0">
                 <a:solidFill>
                   <a:srgbClr val="22222A"/>
                 </a:solidFill>
@@ -33609,7 +33591,7 @@
               </a:spcAft>
             </a:pPr>
             <a:r>
-              <a:rPr sz="1100" i="1" b="0">
+              <a:rPr sz="1300" i="1" b="0">
                 <a:solidFill>
                   <a:srgbClr val="22222A"/>
                 </a:solidFill>
@@ -33803,7 +33785,7 @@
                 </a:solidFill>
                 <a:latin typeface="Calibri"/>
               </a:rPr>
-              <a:t>Rates are annualised voluntary exits ÷ active headcount (n = 12,003), the same convention used on every rate in this deck. Chi-square, Entity_B vs Entity_A, p = 8×10⁻⁹.</a:t>
+              <a:t>Rates are annualised voluntary exits ÷ active headcount (n = 12,003), the same convention used on every rate in this deck. Every test we ran is listed in appendix A8.</a:t>
             </a:r>
           </a:p>
         </p:txBody>
@@ -33978,7 +33960,7 @@
                 </a:solidFill>
                 <a:latin typeface="Calibri"/>
               </a:rPr>
-              <a:t>Entity_B vs Entity_A on 1,601 and 1,804 active staff. The most statistically solid finding in the analysis.</a:t>
+              <a:t>That gap is on 1,601 and 1,804 active staff. It is the clearest and most reliable finding in the whole analysis.</a:t>
             </a:r>
           </a:p>
           <a:p>
@@ -34165,7 +34147,7 @@
               </a:spcAft>
             </a:pPr>
             <a:r>
-              <a:rPr sz="1050" i="1" b="0">
+              <a:rPr sz="1250" i="1" b="0">
                 <a:solidFill>
                   <a:srgbClr val="22222A"/>
                 </a:solidFill>
@@ -34359,7 +34341,7 @@
                 </a:solidFill>
                 <a:latin typeface="Calibri"/>
               </a:rPr>
-              <a:t>Employee-level means across five waves, Welch's t-test. Entity_A n = 1,938, Entity_B n = 1,697 responders. Composite index: Entity_B 3.280 vs Entity_A 3.366.</a:t>
+              <a:t>Employee-level means across five waves. Entity_A n = 1,938, Entity_B n = 1,697 responders. Composite index: Entity_B 3.280 vs Entity_A 3.366. Tests in appendix A8.</a:t>
             </a:r>
           </a:p>
         </p:txBody>
@@ -34452,7 +34434,7 @@
                 </a:solidFill>
                 <a:latin typeface="Calibri"/>
               </a:rPr>
-              <a:t>: 3.344 vs 3.371, </a:t>
+              <a:t>: 3.344 vs 3.371. </a:t>
             </a:r>
             <a:r>
               <a:rPr sz="1250" i="0" b="1">
@@ -34461,7 +34443,26 @@
                 </a:solidFill>
                 <a:latin typeface="Calibri"/>
               </a:rPr>
-              <a:t>no difference</a:t>
+              <a:t>No meaningful difference.</a:t>
+            </a:r>
+          </a:p>
+          <a:p>
+            <a:pPr algn="l">
+              <a:lnSpc>
+                <a:spcPct val="118000"/>
+              </a:lnSpc>
+              <a:spcAft>
+                <a:spcPts val="1100"/>
+              </a:spcAft>
+            </a:pPr>
+            <a:r>
+              <a:rPr sz="1250" i="0" b="1">
+                <a:solidFill>
+                  <a:srgbClr val="460073"/>
+                </a:solidFill>
+                <a:latin typeface="Calibri"/>
+              </a:rPr>
+              <a:t>Psychological safety</a:t>
             </a:r>
             <a:r>
               <a:rPr sz="1250" i="0" b="0">
@@ -34470,7 +34471,16 @@
                 </a:solidFill>
                 <a:latin typeface="Calibri"/>
               </a:rPr>
-              <a:t> (p = 0.35).</a:t>
+              <a:t>: 3.351 vs 3.354. </a:t>
+            </a:r>
+            <a:r>
+              <a:rPr sz="1250" i="0" b="1">
+                <a:solidFill>
+                  <a:srgbClr val="460073"/>
+                </a:solidFill>
+                <a:latin typeface="Calibri"/>
+              </a:rPr>
+              <a:t>No meaningful difference.</a:t>
             </a:r>
           </a:p>
           <a:p>
@@ -34489,7 +34499,7 @@
                 </a:solidFill>
                 <a:latin typeface="Calibri"/>
               </a:rPr>
-              <a:t>Psychological safety</a:t>
+              <a:t>Senior leadership trust is down 0.301</a:t>
             </a:r>
             <a:r>
               <a:rPr sz="1250" i="0" b="0">
@@ -34498,7 +34508,7 @@
                 </a:solidFill>
                 <a:latin typeface="Calibri"/>
               </a:rPr>
-              <a:t>: 3.351 vs 3.354, </a:t>
+              <a:t> and </a:t>
             </a:r>
             <a:r>
               <a:rPr sz="1250" i="0" b="1">
@@ -34507,7 +34517,7 @@
                 </a:solidFill>
                 <a:latin typeface="Calibri"/>
               </a:rPr>
-              <a:t>no difference</a:t>
+              <a:t>purpose &amp; meaning down 0.300</a:t>
             </a:r>
             <a:r>
               <a:rPr sz="1250" i="0" b="0">
@@ -34516,53 +34526,7 @@
                 </a:solidFill>
                 <a:latin typeface="Calibri"/>
               </a:rPr>
-              <a:t> (p = 0.91).</a:t>
-            </a:r>
-          </a:p>
-          <a:p>
-            <a:pPr algn="l">
-              <a:lnSpc>
-                <a:spcPct val="118000"/>
-              </a:lnSpc>
-              <a:spcAft>
-                <a:spcPts val="1100"/>
-              </a:spcAft>
-            </a:pPr>
-            <a:r>
-              <a:rPr sz="1250" i="0" b="1">
-                <a:solidFill>
-                  <a:srgbClr val="460073"/>
-                </a:solidFill>
-                <a:latin typeface="Calibri"/>
-              </a:rPr>
-              <a:t>Senior leadership trust −0.301</a:t>
-            </a:r>
-            <a:r>
-              <a:rPr sz="1250" i="0" b="0">
-                <a:solidFill>
-                  <a:srgbClr val="22222A"/>
-                </a:solidFill>
-                <a:latin typeface="Calibri"/>
-              </a:rPr>
-              <a:t> (p = 1.5×10⁻²⁵). </a:t>
-            </a:r>
-            <a:r>
-              <a:rPr sz="1250" i="0" b="1">
-                <a:solidFill>
-                  <a:srgbClr val="460073"/>
-                </a:solidFill>
-                <a:latin typeface="Calibri"/>
-              </a:rPr>
-              <a:t>Purpose &amp; meaning −0.300</a:t>
-            </a:r>
-            <a:r>
-              <a:rPr sz="1250" i="0" b="0">
-                <a:solidFill>
-                  <a:srgbClr val="22222A"/>
-                </a:solidFill>
-                <a:latin typeface="Calibri"/>
-              </a:rPr>
-              <a:t> (p = 2.6×10⁻²⁵).</a:t>
+              <a:t> — far larger than any other gap, and the only two that are not explainable by chance.</a:t>
             </a:r>
           </a:p>
           <a:p>
@@ -34638,8 +34602,8 @@
         </p:blipFill>
         <p:spPr>
           <a:xfrm>
-            <a:off x="4892040" y="1877000"/>
-            <a:ext cx="6720840" cy="3881239"/>
+            <a:off x="4892040" y="1850489"/>
+            <a:ext cx="6720840" cy="3934262"/>
           </a:xfrm>
           <a:prstGeom prst="rect">
             <a:avLst/>
@@ -34721,7 +34685,7 @@
               </a:spcAft>
             </a:pPr>
             <a:r>
-              <a:rPr sz="1050" i="1" b="0">
+              <a:rPr sz="1250" i="1" b="0">
                 <a:solidFill>
                   <a:srgbClr val="22222A"/>
                 </a:solidFill>
@@ -35372,7 +35336,7 @@
                 </a:solidFill>
                 <a:latin typeface="Calibri"/>
               </a:rPr>
-              <a:t>Attrition is annualised voluntary on active headcount. Response rate is the mean of each employee's own rate across five waves. Entity_A vs Entity_C, p = 0.101, not significant.</a:t>
+              <a:t>Attrition is annualised voluntary on active headcount. Response rate is the mean of each employee's own rate across five waves. Entity_C is not yet distinguishable from Entity_A.</a:t>
             </a:r>
           </a:p>
         </p:txBody>
@@ -35548,7 +35512,7 @@
                 </a:solidFill>
                 <a:latin typeface="Calibri"/>
               </a:rPr>
-              <a:t> and statistically indistinguishable from Entity_A. It is </a:t>
+              <a:t>, tracking with Entity_A rather than Entity_B. It is </a:t>
             </a:r>
             <a:r>
               <a:rPr sz="1300" i="0" b="1">
@@ -35670,13 +35634,13 @@
               </a:spcAft>
             </a:pPr>
             <a:r>
-              <a:rPr sz="1050" i="1" b="0">
+              <a:rPr sz="1250" i="1" b="0">
                 <a:solidFill>
                   <a:srgbClr val="22222A"/>
                 </a:solidFill>
                 <a:latin typeface="Calibri"/>
               </a:rPr>
-              <a:t>This turns the recommendation from “we hope this helps” into “you have already done this once, in this company, with this workforce.” It also sets your success measure.</a:t>
+              <a:t>Track Entity_B against Entity_A's recovery, not against its own past or a generic benchmark. Entity_A is the only comparison that reflects this workforce.</a:t>
             </a:r>
           </a:p>
         </p:txBody>

</xml_diff>